<commit_message>
Add football-term and unit captions to final deck for a non-football audience
</commit_message>
<xml_diff>
--- a/Worth_the_Investment_Capstone_Skeleton_Final.pptx
+++ b/Worth_the_Investment_Capstone_Skeleton_Final.pptx
@@ -7400,7 +7400,7 @@
 </p:sld>
 </file>
 
-<file path=ppt/slides/slide14.xml><?xml version="1.0" encoding="utf-8"?>
+<file path=ppt/slides/slide13.xml><?xml version="1.0" encoding="utf-8"?>
 <p:sld xmlns:a="http://schemas.openxmlformats.org/drawingml/2006/main" xmlns:r="http://schemas.openxmlformats.org/officeDocument/2006/relationships" xmlns:p="http://schemas.openxmlformats.org/presentationml/2006/main">
   <p:cSld name="Slide 12">
     <p:bg>
@@ -8841,7 +8841,7 @@
 </p:sld>
 </file>
 
-<file path=ppt/slides/slide15.xml><?xml version="1.0" encoding="utf-8"?>
+<file path=ppt/slides/slide14.xml><?xml version="1.0" encoding="utf-8"?>
 <p:sld xmlns:a="http://schemas.openxmlformats.org/drawingml/2006/main" xmlns:r="http://schemas.openxmlformats.org/officeDocument/2006/relationships" xmlns:p="http://schemas.openxmlformats.org/presentationml/2006/main">
   <p:cSld name="Slide 14">
     <p:bg>
@@ -9764,7 +9764,7 @@
 </p:sld>
 </file>
 
-<file path=ppt/slides/slide16.xml><?xml version="1.0" encoding="utf-8"?>
+<file path=ppt/slides/slide15.xml><?xml version="1.0" encoding="utf-8"?>
 <p:sld xmlns:a="http://schemas.openxmlformats.org/drawingml/2006/main" xmlns:r="http://schemas.openxmlformats.org/officeDocument/2006/relationships" xmlns:p="http://schemas.openxmlformats.org/presentationml/2006/main">
   <p:cSld name="Slide 13">
     <p:bg>
@@ -14930,6 +14930,50 @@
           </a:p>
         </p:txBody>
       </p:sp>
+      <p:sp>
+        <p:nvSpPr>
+          <p:cNvPr id="52" name="TextBox 51"/>
+          <p:cNvSpPr txBox="1"/>
+          <p:nvPr/>
+        </p:nvSpPr>
+        <p:spPr>
+          <a:xfrm>
+            <a:off x="822960" y="3160000"/>
+            <a:ext cx="10545775" cy="420000"/>
+          </a:xfrm>
+          <a:prstGeom prst="rect">
+            <a:avLst/>
+          </a:prstGeom>
+          <a:noFill/>
+        </p:spPr>
+        <p:txBody>
+          <a:bodyPr wrap="square" lIns="0" rIns="0" tIns="0" bIns="0">
+            <a:spAutoFit/>
+          </a:bodyPr>
+          <a:lstStyle/>
+          <a:p>
+            <a:pPr algn="l"/>
+            <a:r>
+              <a:rPr sz="1200" i="1" b="1">
+                <a:solidFill>
+                  <a:srgbClr val="CADCFC"/>
+                </a:solidFill>
+                <a:latin typeface="Calibri"/>
+              </a:rPr>
+              <a:t>TERM CHECK — </a:t>
+            </a:r>
+            <a:r>
+              <a:rPr sz="1200" i="1" b="0">
+                <a:solidFill>
+                  <a:srgbClr val="CADCFC"/>
+                </a:solidFill>
+                <a:latin typeface="Calibri"/>
+              </a:rPr>
+              <a:t>“market value” = a player’s estimated transfer-market worth (public valuation data), not a confirmed sale price.</a:t>
+            </a:r>
+          </a:p>
+        </p:txBody>
+      </p:sp>
     </p:spTree>
     <p:extLst>
       <p:ext uri="{BB962C8B-B14F-4D97-AF65-F5344CB8AC3E}">
@@ -20593,6 +20637,50 @@
           </a:p>
         </p:txBody>
       </p:sp>
+      <p:sp>
+        <p:nvSpPr>
+          <p:cNvPr id="72" name="TextBox 71"/>
+          <p:cNvSpPr txBox="1"/>
+          <p:nvPr/>
+        </p:nvSpPr>
+        <p:spPr>
+          <a:xfrm>
+            <a:off x="822960" y="6180000"/>
+            <a:ext cx="4937760" cy="210000"/>
+          </a:xfrm>
+          <a:prstGeom prst="rect">
+            <a:avLst/>
+          </a:prstGeom>
+          <a:noFill/>
+        </p:spPr>
+        <p:txBody>
+          <a:bodyPr wrap="square" lIns="0" rIns="0" tIns="0" bIns="0">
+            <a:spAutoFit/>
+          </a:bodyPr>
+          <a:lstStyle/>
+          <a:p>
+            <a:pPr algn="l"/>
+            <a:r>
+              <a:rPr sz="1000" i="1" b="1">
+                <a:solidFill>
+                  <a:srgbClr val="44506B"/>
+                </a:solidFill>
+                <a:latin typeface="Calibri"/>
+              </a:rPr>
+              <a:t>Note: </a:t>
+            </a:r>
+            <a:r>
+              <a:rPr sz="1000" i="1" b="0">
+                <a:solidFill>
+                  <a:srgbClr val="44506B"/>
+                </a:solidFill>
+                <a:latin typeface="Calibri"/>
+              </a:rPr>
+              <a:t>“value” = Transfermarkt market valuation, not on-pitch performance.</a:t>
+            </a:r>
+          </a:p>
+        </p:txBody>
+      </p:sp>
     </p:spTree>
     <p:extLst>
       <p:ext uri="{BB962C8B-B14F-4D97-AF65-F5344CB8AC3E}">
@@ -22063,6 +22151,50 @@
           </a:graphicData>
         </a:graphic>
       </p:graphicFrame>
+      <p:sp>
+        <p:nvSpPr>
+          <p:cNvPr id="64" name="TextBox 63"/>
+          <p:cNvSpPr txBox="1"/>
+          <p:nvPr/>
+        </p:nvSpPr>
+        <p:spPr>
+          <a:xfrm>
+            <a:off x="6757416" y="6100000"/>
+            <a:ext cx="4608576" cy="280000"/>
+          </a:xfrm>
+          <a:prstGeom prst="rect">
+            <a:avLst/>
+          </a:prstGeom>
+          <a:noFill/>
+        </p:spPr>
+        <p:txBody>
+          <a:bodyPr wrap="square" lIns="0" rIns="0" tIns="0" bIns="0">
+            <a:spAutoFit/>
+          </a:bodyPr>
+          <a:lstStyle/>
+          <a:p>
+            <a:pPr algn="l"/>
+            <a:r>
+              <a:rPr sz="1000" i="1" b="1">
+                <a:solidFill>
+                  <a:srgbClr val="44506B"/>
+                </a:solidFill>
+                <a:latin typeface="Calibri"/>
+              </a:rPr>
+              <a:t>Note: </a:t>
+            </a:r>
+            <a:r>
+              <a:rPr sz="1000" i="1" b="0">
+                <a:solidFill>
+                  <a:srgbClr val="44506B"/>
+                </a:solidFill>
+                <a:latin typeface="Calibri"/>
+              </a:rPr>
+              <a:t>a “90” = one full match played. Rate is per 1,000 to compare players fairly, regardless of playing time.</a:t>
+            </a:r>
+          </a:p>
+        </p:txBody>
+      </p:sp>
     </p:spTree>
     <p:extLst>
       <p:ext uri="{BB962C8B-B14F-4D97-AF65-F5344CB8AC3E}">
@@ -23533,6 +23665,50 @@
           </a:graphicData>
         </a:graphic>
       </p:graphicFrame>
+      <p:sp>
+        <p:nvSpPr>
+          <p:cNvPr id="64" name="TextBox 63"/>
+          <p:cNvSpPr txBox="1"/>
+          <p:nvPr/>
+        </p:nvSpPr>
+        <p:spPr>
+          <a:xfrm>
+            <a:off x="822960" y="6100000"/>
+            <a:ext cx="4937760" cy="280000"/>
+          </a:xfrm>
+          <a:prstGeom prst="rect">
+            <a:avLst/>
+          </a:prstGeom>
+          <a:noFill/>
+        </p:spPr>
+        <p:txBody>
+          <a:bodyPr wrap="square" lIns="0" rIns="0" tIns="0" bIns="0">
+            <a:spAutoFit/>
+          </a:bodyPr>
+          <a:lstStyle/>
+          <a:p>
+            <a:pPr algn="l"/>
+            <a:r>
+              <a:rPr sz="1000" i="1" b="1">
+                <a:solidFill>
+                  <a:srgbClr val="44506B"/>
+                </a:solidFill>
+                <a:latin typeface="Calibri"/>
+              </a:rPr>
+              <a:t>Reminder: </a:t>
+            </a:r>
+            <a:r>
+              <a:rPr sz="1000" i="1" b="0">
+                <a:solidFill>
+                  <a:srgbClr val="44506B"/>
+                </a:solidFill>
+                <a:latin typeface="Calibri"/>
+              </a:rPr>
+              <a:t>“90s” = full matches played; injuries are counted per 1,000 to stay fair across playing time (see slide 07).</a:t>
+            </a:r>
+          </a:p>
+        </p:txBody>
+      </p:sp>
     </p:spTree>
     <p:extLst>
       <p:ext uri="{BB962C8B-B14F-4D97-AF65-F5344CB8AC3E}">
@@ -24981,6 +25157,50 @@
           </a:graphicData>
         </a:graphic>
       </p:graphicFrame>
+      <p:sp>
+        <p:nvSpPr>
+          <p:cNvPr id="26" name="TextBox 25"/>
+          <p:cNvSpPr txBox="1"/>
+          <p:nvPr/>
+        </p:nvSpPr>
+        <p:spPr>
+          <a:xfrm>
+            <a:off x="1152144" y="5820000"/>
+            <a:ext cx="4608576" cy="550000"/>
+          </a:xfrm>
+          <a:prstGeom prst="rect">
+            <a:avLst/>
+          </a:prstGeom>
+          <a:noFill/>
+        </p:spPr>
+        <p:txBody>
+          <a:bodyPr wrap="square" lIns="0" rIns="0" tIns="0" bIns="0">
+            <a:spAutoFit/>
+          </a:bodyPr>
+          <a:lstStyle/>
+          <a:p>
+            <a:pPr algn="l"/>
+            <a:r>
+              <a:rPr sz="1000" i="1" b="1">
+                <a:solidFill>
+                  <a:srgbClr val="44506B"/>
+                </a:solidFill>
+                <a:latin typeface="Calibri"/>
+              </a:rPr>
+              <a:t>Term check: </a:t>
+            </a:r>
+            <a:r>
+              <a:rPr sz="1000" i="1" b="0">
+                <a:solidFill>
+                  <a:srgbClr val="44506B"/>
+                </a:solidFill>
+                <a:latin typeface="Calibri"/>
+              </a:rPr>
+              <a:t>“directional accuracy” = did the forecast get up-vs-down right (not the exact number). “Backtested” = tested against real past outcomes the model never saw during training.</a:t>
+            </a:r>
+          </a:p>
+        </p:txBody>
+      </p:sp>
     </p:spTree>
   </p:cSld>
   <p:clrMapOvr>

</xml_diff>

<commit_message>
Fix invalid negative chart axis IDs causing PowerPoint repair prompt
</commit_message>
<xml_diff>
--- a/Worth_the_Investment_Capstone_Skeleton_Final.pptx
+++ b/Worth_the_Investment_Capstone_Skeleton_Final.pptx
@@ -610,11 +610,11 @@
           <c:showLeaderLines val="1"/>
         </c:dLbls>
         <c:gapWidth val="60"/>
-        <c:axId val="-2068027336"/>
-        <c:axId val="-2113994440"/>
+        <c:axId val="2068027336"/>
+        <c:axId val="2113994440"/>
       </c:barChart>
       <c:catAx>
-        <c:axId val="-2068027336"/>
+        <c:axId val="2068027336"/>
         <c:scaling>
           <c:orientation val="minMax"/>
         </c:scaling>
@@ -644,7 +644,7 @@
             </a:pPr>
           </a:p>
         </c:txPr>
-        <c:crossAx val="-2113994440"/>
+        <c:crossAx val="2113994440"/>
         <c:crosses val="autoZero"/>
         <c:auto val="1"/>
         <c:lblAlgn val="ctr"/>
@@ -652,7 +652,7 @@
         <c:noMultiLvlLbl val="0"/>
       </c:catAx>
       <c:valAx>
-        <c:axId val="-2113994440"/>
+        <c:axId val="2113994440"/>
         <c:scaling>
           <c:max val="5.5"/>
           <c:min val="0.0"/>
@@ -690,7 +690,7 @@
             </a:pPr>
           </a:p>
         </c:txPr>
-        <c:crossAx val="-2068027336"/>
+        <c:crossAx val="2068027336"/>
         <c:crosses val="autoZero"/>
       </c:valAx>
     </c:plotArea>
@@ -813,11 +813,11 @@
           <c:showLeaderLines val="1"/>
         </c:dLbls>
         <c:gapWidth val="70"/>
-        <c:axId val="-2068027336"/>
-        <c:axId val="-2113994440"/>
+        <c:axId val="2068027336"/>
+        <c:axId val="2113994440"/>
       </c:barChart>
       <c:catAx>
-        <c:axId val="-2068027336"/>
+        <c:axId val="2068027336"/>
         <c:scaling>
           <c:orientation val="minMax"/>
         </c:scaling>
@@ -847,7 +847,7 @@
             </a:pPr>
           </a:p>
         </c:txPr>
-        <c:crossAx val="-2113994440"/>
+        <c:crossAx val="2113994440"/>
         <c:crosses val="autoZero"/>
         <c:auto val="1"/>
         <c:lblAlgn val="ctr"/>
@@ -855,7 +855,7 @@
         <c:noMultiLvlLbl val="0"/>
       </c:catAx>
       <c:valAx>
-        <c:axId val="-2113994440"/>
+        <c:axId val="2113994440"/>
         <c:scaling>
           <c:max val="60.0"/>
           <c:min val="0.0"/>
@@ -893,7 +893,7 @@
             </a:pPr>
           </a:p>
         </c:txPr>
-        <c:crossAx val="-2068027336"/>
+        <c:crossAx val="2068027336"/>
         <c:crosses val="autoZero"/>
       </c:valAx>
     </c:plotArea>

</xml_diff>

<commit_message>
Rebuild slide 7-9 charts from scratch with clean relationship handling and source-level axis-ID fix
</commit_message>
<xml_diff>
--- a/Worth_the_Investment_Capstone_Skeleton_Final.pptx
+++ b/Worth_the_Investment_Capstone_Skeleton_Final.pptx
@@ -124,6 +124,640 @@
     </p:ext>
   </p:extLst>
 </p:presentation>
+</file>
+
+<file path=ppt/charts/chart2.xml><?xml version="1.0" encoding="utf-8"?>
+<c:chartSpace xmlns:c="http://schemas.openxmlformats.org/drawingml/2006/chart" xmlns:a="http://schemas.openxmlformats.org/drawingml/2006/main" xmlns:r="http://schemas.openxmlformats.org/officeDocument/2006/relationships">
+  <c:date1904 val="0"/>
+  <c:chart>
+    <c:autoTitleDeleted val="1"/>
+    <c:plotArea>
+      <c:barChart>
+        <c:barDir val="bar"/>
+        <c:grouping val="clustered"/>
+        <c:ser>
+          <c:idx val="0"/>
+          <c:order val="0"/>
+          <c:tx>
+            <c:strRef>
+              <c:f>Sheet1!$B$1</c:f>
+              <c:strCache>
+                <c:ptCount val="1"/>
+                <c:pt idx="0">
+                  <c:v>Accuracy (%)</c:v>
+                </c:pt>
+              </c:strCache>
+            </c:strRef>
+          </c:tx>
+          <c:dPt>
+            <c:idx val="1"/>
+            <c:spPr>
+              <a:solidFill>
+                <a:srgbClr val="C0392B"/>
+              </a:solidFill>
+            </c:spPr>
+          </c:dPt>
+          <c:dPt>
+            <c:idx val="0"/>
+            <c:spPr>
+              <a:noFill/>
+              <a:ln w="22225">
+                <a:solidFill>
+                  <a:srgbClr val="44506B"/>
+                </a:solidFill>
+                <a:prstDash val="dash"/>
+              </a:ln>
+            </c:spPr>
+          </c:dPt>
+          <c:cat>
+            <c:strRef>
+              <c:f>Sheet1!$A$2:$A$3</c:f>
+              <c:strCache>
+                <c:ptCount val="2"/>
+                <c:pt idx="0">
+                  <c:v>Coin-flip
+baseline</c:v>
+                </c:pt>
+                <c:pt idx="1">
+                  <c:v>Model
+(backtested)</c:v>
+                </c:pt>
+              </c:strCache>
+            </c:strRef>
+          </c:cat>
+          <c:val>
+            <c:numRef>
+              <c:f>Sheet1!$B$2:$B$3</c:f>
+              <c:numCache>
+                <c:formatCode>General</c:formatCode>
+                <c:ptCount val="2"/>
+                <c:pt idx="0">
+                  <c:v>50.0</c:v>
+                </c:pt>
+                <c:pt idx="1">
+                  <c:v>22.7</c:v>
+                </c:pt>
+              </c:numCache>
+            </c:numRef>
+          </c:val>
+        </c:ser>
+        <c:dLbls>
+          <c:numFmt formatCode="0.0&quot;%&quot;" sourceLinked="0"/>
+          <c:txPr>
+            <a:bodyPr/>
+            <a:lstStyle/>
+            <a:p>
+              <a:pPr>
+                <a:defRPr sz="1300" b="1">
+                  <a:solidFill>
+                    <a:srgbClr val="44506B"/>
+                  </a:solidFill>
+                  <a:latin typeface="Calibri"/>
+                </a:defRPr>
+              </a:pPr>
+            </a:p>
+          </c:txPr>
+          <c:dLblPos val="outEnd"/>
+          <c:showLegendKey val="0"/>
+          <c:showVal val="1"/>
+          <c:showCatName val="0"/>
+          <c:showSerName val="0"/>
+          <c:showPercent val="0"/>
+          <c:showBubbleSize val="0"/>
+          <c:showLeaderLines val="1"/>
+        </c:dLbls>
+        <c:gapWidth val="70"/>
+        <c:axId val="2068027336"/>
+        <c:axId val="2113994440"/>
+      </c:barChart>
+      <c:catAx>
+        <c:axId val="2068027336"/>
+        <c:scaling>
+          <c:orientation val="minMax"/>
+        </c:scaling>
+        <c:delete val="0"/>
+        <c:axPos val="l"/>
+        <c:majorTickMark val="out"/>
+        <c:minorTickMark val="none"/>
+        <c:tickLblPos val="nextTo"/>
+        <c:spPr>
+          <a:ln>
+            <a:solidFill>
+              <a:srgbClr val="E3E6EC"/>
+            </a:solidFill>
+          </a:ln>
+        </c:spPr>
+        <c:txPr>
+          <a:bodyPr/>
+          <a:lstStyle/>
+          <a:p>
+            <a:pPr>
+              <a:defRPr sz="1200">
+                <a:solidFill>
+                  <a:srgbClr val="44506B"/>
+                </a:solidFill>
+                <a:latin typeface="Calibri"/>
+              </a:defRPr>
+            </a:pPr>
+          </a:p>
+        </c:txPr>
+        <c:crossAx val="2113994440"/>
+        <c:crosses val="autoZero"/>
+        <c:auto val="1"/>
+        <c:lblAlgn val="ctr"/>
+        <c:lblOffset val="100"/>
+        <c:noMultiLvlLbl val="0"/>
+      </c:catAx>
+      <c:valAx>
+        <c:axId val="2113994440"/>
+        <c:scaling>
+          <c:max val="60.0"/>
+          <c:min val="0.0"/>
+        </c:scaling>
+        <c:delete val="0"/>
+        <c:axPos val="b"/>
+        <c:majorGridlines>
+          <c:spPr>
+            <a:ln w="6350">
+              <a:solidFill>
+                <a:srgbClr val="E3E6EC"/>
+              </a:solidFill>
+            </a:ln>
+          </c:spPr>
+        </c:majorGridlines>
+        <c:majorTickMark val="out"/>
+        <c:minorTickMark val="none"/>
+        <c:tickLblPos val="nextTo"/>
+        <c:spPr>
+          <a:ln>
+            <a:noFill/>
+          </a:ln>
+        </c:spPr>
+        <c:txPr>
+          <a:bodyPr/>
+          <a:lstStyle/>
+          <a:p>
+            <a:pPr>
+              <a:defRPr sz="1000">
+                <a:solidFill>
+                  <a:srgbClr val="44506B"/>
+                </a:solidFill>
+                <a:latin typeface="Calibri"/>
+              </a:defRPr>
+            </a:pPr>
+          </a:p>
+        </c:txPr>
+        <c:crossAx val="2068027336"/>
+        <c:crosses val="autoZero"/>
+      </c:valAx>
+    </c:plotArea>
+    <c:dispBlanksAs val="gap"/>
+  </c:chart>
+  <c:txPr>
+    <a:bodyPr/>
+    <a:lstStyle/>
+    <a:p>
+      <a:pPr>
+        <a:defRPr sz="1800"/>
+      </a:pPr>
+      <a:endParaRPr lang="en-US"/>
+    </a:p>
+  </c:txPr>
+  <c:externalData r:id="rId1">
+    <c:autoUpdate val="0"/>
+  </c:externalData>
+</c:chartSpace>
+</file>
+
+<file path=ppt/charts/chart3.xml><?xml version="1.0" encoding="utf-8"?>
+<c:chartSpace xmlns:c="http://schemas.openxmlformats.org/drawingml/2006/chart" xmlns:a="http://schemas.openxmlformats.org/drawingml/2006/main" xmlns:r="http://schemas.openxmlformats.org/officeDocument/2006/relationships">
+  <c:date1904 val="0"/>
+  <c:chart>
+    <c:autoTitleDeleted val="1"/>
+    <c:plotArea>
+      <c:barChart>
+        <c:barDir val="bar"/>
+        <c:grouping val="clustered"/>
+        <c:ser>
+          <c:idx val="0"/>
+          <c:order val="0"/>
+          <c:tx>
+            <c:strRef>
+              <c:f>Sheet1!$B$1</c:f>
+              <c:strCache>
+                <c:ptCount val="1"/>
+                <c:pt idx="0">
+                  <c:v>Injuries / 1,000 90s</c:v>
+                </c:pt>
+              </c:strCache>
+            </c:strRef>
+          </c:tx>
+          <c:spPr>
+            <a:solidFill>
+              <a:srgbClr val="B9C0CE"/>
+            </a:solidFill>
+            <a:ln>
+              <a:noFill/>
+            </a:ln>
+          </c:spPr>
+          <c:dPt>
+            <c:idx val="3"/>
+            <c:spPr>
+              <a:solidFill>
+                <a:srgbClr val="0F1B3D"/>
+              </a:solidFill>
+            </c:spPr>
+          </c:dPt>
+          <c:cat>
+            <c:strRef>
+              <c:f>Sheet1!$A$2:$A$5</c:f>
+              <c:strCache>
+                <c:ptCount val="4"/>
+                <c:pt idx="0">
+                  <c:v>Attack</c:v>
+                </c:pt>
+                <c:pt idx="1">
+                  <c:v>Midfield</c:v>
+                </c:pt>
+                <c:pt idx="2">
+                  <c:v>Defender</c:v>
+                </c:pt>
+                <c:pt idx="3">
+                  <c:v>Goalkeeper</c:v>
+                </c:pt>
+              </c:strCache>
+            </c:strRef>
+          </c:cat>
+          <c:val>
+            <c:numRef>
+              <c:f>Sheet1!$B$2:$B$5</c:f>
+              <c:numCache>
+                <c:formatCode>General</c:formatCode>
+                <c:ptCount val="4"/>
+                <c:pt idx="0">
+                  <c:v>4.15</c:v>
+                </c:pt>
+                <c:pt idx="1">
+                  <c:v>4.23</c:v>
+                </c:pt>
+                <c:pt idx="2">
+                  <c:v>4.3</c:v>
+                </c:pt>
+                <c:pt idx="3">
+                  <c:v>2.32</c:v>
+                </c:pt>
+              </c:numCache>
+            </c:numRef>
+          </c:val>
+        </c:ser>
+        <c:dLbls>
+          <c:numFmt formatCode="0.00" sourceLinked="0"/>
+          <c:txPr>
+            <a:bodyPr/>
+            <a:lstStyle/>
+            <a:p>
+              <a:pPr>
+                <a:defRPr sz="1200" b="1">
+                  <a:solidFill>
+                    <a:srgbClr val="44506B"/>
+                  </a:solidFill>
+                  <a:latin typeface="Calibri"/>
+                </a:defRPr>
+              </a:pPr>
+            </a:p>
+          </c:txPr>
+          <c:dLblPos val="outEnd"/>
+          <c:showLegendKey val="0"/>
+          <c:showVal val="1"/>
+          <c:showCatName val="0"/>
+          <c:showSerName val="0"/>
+          <c:showPercent val="0"/>
+          <c:showBubbleSize val="0"/>
+          <c:showLeaderLines val="1"/>
+        </c:dLbls>
+        <c:gapWidth val="60"/>
+        <c:axId val="2068027336"/>
+        <c:axId val="2113994440"/>
+      </c:barChart>
+      <c:catAx>
+        <c:axId val="2068027336"/>
+        <c:scaling>
+          <c:orientation val="minMax"/>
+        </c:scaling>
+        <c:delete val="0"/>
+        <c:axPos val="l"/>
+        <c:majorTickMark val="out"/>
+        <c:minorTickMark val="none"/>
+        <c:tickLblPos val="nextTo"/>
+        <c:spPr>
+          <a:ln>
+            <a:solidFill>
+              <a:srgbClr val="E3E6EC"/>
+            </a:solidFill>
+          </a:ln>
+        </c:spPr>
+        <c:txPr>
+          <a:bodyPr/>
+          <a:lstStyle/>
+          <a:p>
+            <a:pPr>
+              <a:defRPr sz="1200">
+                <a:solidFill>
+                  <a:srgbClr val="44506B"/>
+                </a:solidFill>
+                <a:latin typeface="Calibri"/>
+              </a:defRPr>
+            </a:pPr>
+          </a:p>
+        </c:txPr>
+        <c:crossAx val="2113994440"/>
+        <c:crosses val="autoZero"/>
+        <c:auto val="1"/>
+        <c:lblAlgn val="ctr"/>
+        <c:lblOffset val="100"/>
+        <c:noMultiLvlLbl val="0"/>
+      </c:catAx>
+      <c:valAx>
+        <c:axId val="2113994440"/>
+        <c:scaling>
+          <c:max val="5.5"/>
+          <c:min val="0.0"/>
+        </c:scaling>
+        <c:delete val="0"/>
+        <c:axPos val="b"/>
+        <c:majorGridlines>
+          <c:spPr>
+            <a:ln w="6350">
+              <a:solidFill>
+                <a:srgbClr val="E3E6EC"/>
+              </a:solidFill>
+            </a:ln>
+          </c:spPr>
+        </c:majorGridlines>
+        <c:majorTickMark val="out"/>
+        <c:minorTickMark val="none"/>
+        <c:tickLblPos val="nextTo"/>
+        <c:spPr>
+          <a:ln>
+            <a:noFill/>
+          </a:ln>
+        </c:spPr>
+        <c:txPr>
+          <a:bodyPr/>
+          <a:lstStyle/>
+          <a:p>
+            <a:pPr>
+              <a:defRPr sz="1000">
+                <a:solidFill>
+                  <a:srgbClr val="44506B"/>
+                </a:solidFill>
+                <a:latin typeface="Calibri"/>
+              </a:defRPr>
+            </a:pPr>
+          </a:p>
+        </c:txPr>
+        <c:crossAx val="2068027336"/>
+        <c:crosses val="autoZero"/>
+      </c:valAx>
+    </c:plotArea>
+    <c:dispBlanksAs val="gap"/>
+  </c:chart>
+  <c:txPr>
+    <a:bodyPr/>
+    <a:lstStyle/>
+    <a:p>
+      <a:pPr>
+        <a:defRPr sz="1800"/>
+      </a:pPr>
+      <a:endParaRPr lang="en-US"/>
+    </a:p>
+  </c:txPr>
+  <c:externalData r:id="rId1">
+    <c:autoUpdate val="0"/>
+  </c:externalData>
+</c:chartSpace>
+</file>
+
+<file path=ppt/charts/chart4.xml><?xml version="1.0" encoding="utf-8"?>
+<c:chartSpace xmlns:c="http://schemas.openxmlformats.org/drawingml/2006/chart" xmlns:a="http://schemas.openxmlformats.org/drawingml/2006/main" xmlns:r="http://schemas.openxmlformats.org/officeDocument/2006/relationships">
+  <c:date1904 val="0"/>
+  <c:chart>
+    <c:autoTitleDeleted val="1"/>
+    <c:plotArea>
+      <c:lineChart>
+        <c:grouping val="standard"/>
+        <c:varyColors val="0"/>
+        <c:ser>
+          <c:idx val="0"/>
+          <c:order val="0"/>
+          <c:tx>
+            <c:strRef>
+              <c:f>Sheet1!$B$1</c:f>
+              <c:strCache>
+                <c:ptCount val="1"/>
+                <c:pt idx="0">
+                  <c:v>Injuries / 1,000 90s</c:v>
+                </c:pt>
+              </c:strCache>
+            </c:strRef>
+          </c:tx>
+          <c:spPr>
+            <a:ln w="34925">
+              <a:solidFill>
+                <a:srgbClr val="C0392B"/>
+              </a:solidFill>
+            </a:ln>
+          </c:spPr>
+          <c:marker>
+            <c:symbol val="circle"/>
+            <c:size val="9"/>
+            <c:spPr>
+              <a:solidFill>
+                <a:srgbClr val="C0392B"/>
+              </a:solidFill>
+              <a:ln>
+                <a:solidFill>
+                  <a:srgbClr val="C0392B"/>
+                </a:solidFill>
+              </a:ln>
+            </c:spPr>
+          </c:marker>
+          <c:cat>
+            <c:strRef>
+              <c:f>Sheet1!$A$2:$A$5</c:f>
+              <c:strCache>
+                <c:ptCount val="4"/>
+                <c:pt idx="0">
+                  <c:v>21–24
+(emerging)</c:v>
+                </c:pt>
+                <c:pt idx="1">
+                  <c:v>25–28
+(prime)</c:v>
+                </c:pt>
+                <c:pt idx="2">
+                  <c:v>29–32
+(established)</c:v>
+                </c:pt>
+                <c:pt idx="3">
+                  <c:v>33+
+(veteran)</c:v>
+                </c:pt>
+              </c:strCache>
+            </c:strRef>
+          </c:cat>
+          <c:val>
+            <c:numRef>
+              <c:f>Sheet1!$B$2:$B$5</c:f>
+              <c:numCache>
+                <c:formatCode>General</c:formatCode>
+                <c:ptCount val="4"/>
+                <c:pt idx="0">
+                  <c:v>2.49</c:v>
+                </c:pt>
+                <c:pt idx="1">
+                  <c:v>3.97</c:v>
+                </c:pt>
+                <c:pt idx="2">
+                  <c:v>3.22</c:v>
+                </c:pt>
+                <c:pt idx="3">
+                  <c:v>5.95</c:v>
+                </c:pt>
+              </c:numCache>
+            </c:numRef>
+          </c:val>
+          <c:smooth val="0"/>
+        </c:ser>
+        <c:dLbls>
+          <c:numFmt formatCode="0.00" sourceLinked="0"/>
+          <c:txPr>
+            <a:bodyPr/>
+            <a:lstStyle/>
+            <a:p>
+              <a:pPr>
+                <a:defRPr sz="1200" b="1">
+                  <a:solidFill>
+                    <a:srgbClr val="C0392B"/>
+                  </a:solidFill>
+                  <a:latin typeface="Calibri"/>
+                </a:defRPr>
+              </a:pPr>
+            </a:p>
+          </c:txPr>
+          <c:dLblPos val="t"/>
+          <c:showLegendKey val="0"/>
+          <c:showVal val="1"/>
+          <c:showCatName val="0"/>
+          <c:showSerName val="0"/>
+          <c:showPercent val="0"/>
+          <c:showBubbleSize val="0"/>
+          <c:showLeaderLines val="1"/>
+        </c:dLbls>
+        <c:marker val="1"/>
+        <c:smooth val="0"/>
+        <c:axId val="2118791784"/>
+        <c:axId val="2140495176"/>
+      </c:lineChart>
+      <c:catAx>
+        <c:axId val="2118791784"/>
+        <c:scaling>
+          <c:orientation val="minMax"/>
+        </c:scaling>
+        <c:delete val="0"/>
+        <c:axPos val="b"/>
+        <c:majorTickMark val="out"/>
+        <c:minorTickMark val="none"/>
+        <c:tickLblPos val="nextTo"/>
+        <c:spPr>
+          <a:ln>
+            <a:solidFill>
+              <a:srgbClr val="E3E6EC"/>
+            </a:solidFill>
+          </a:ln>
+        </c:spPr>
+        <c:txPr>
+          <a:bodyPr/>
+          <a:lstStyle/>
+          <a:p>
+            <a:pPr>
+              <a:defRPr sz="1100">
+                <a:solidFill>
+                  <a:srgbClr val="44506B"/>
+                </a:solidFill>
+                <a:latin typeface="Calibri"/>
+              </a:defRPr>
+            </a:pPr>
+          </a:p>
+        </c:txPr>
+        <c:crossAx val="2140495176"/>
+        <c:crosses val="autoZero"/>
+        <c:auto val="1"/>
+        <c:lblAlgn val="ctr"/>
+        <c:lblOffset val="100"/>
+        <c:noMultiLvlLbl val="0"/>
+      </c:catAx>
+      <c:valAx>
+        <c:axId val="2140495176"/>
+        <c:scaling>
+          <c:max val="7.0"/>
+          <c:min val="0.0"/>
+        </c:scaling>
+        <c:delete val="0"/>
+        <c:axPos val="l"/>
+        <c:majorGridlines>
+          <c:spPr>
+            <a:ln w="6350">
+              <a:solidFill>
+                <a:srgbClr val="E3E6EC"/>
+              </a:solidFill>
+            </a:ln>
+          </c:spPr>
+        </c:majorGridlines>
+        <c:majorTickMark val="out"/>
+        <c:minorTickMark val="none"/>
+        <c:tickLblPos val="nextTo"/>
+        <c:spPr>
+          <a:ln>
+            <a:noFill/>
+          </a:ln>
+        </c:spPr>
+        <c:txPr>
+          <a:bodyPr/>
+          <a:lstStyle/>
+          <a:p>
+            <a:pPr>
+              <a:defRPr sz="1100">
+                <a:solidFill>
+                  <a:srgbClr val="44506B"/>
+                </a:solidFill>
+                <a:latin typeface="Calibri"/>
+              </a:defRPr>
+            </a:pPr>
+          </a:p>
+        </c:txPr>
+        <c:crossAx val="2118791784"/>
+        <c:crosses val="autoZero"/>
+      </c:valAx>
+    </c:plotArea>
+    <c:plotVisOnly val="1"/>
+    <c:dispBlanksAs val="gap"/>
+    <c:showDLblsOverMax val="0"/>
+  </c:chart>
+  <c:txPr>
+    <a:bodyPr/>
+    <a:lstStyle/>
+    <a:p>
+      <a:pPr>
+        <a:defRPr sz="1800"/>
+      </a:pPr>
+      <a:endParaRPr lang="en-US"/>
+    </a:p>
+  </c:txPr>
+  <c:externalData r:id="rId1">
+    <c:autoUpdate val="0"/>
+  </c:externalData>
+</c:chartSpace>
 </file>
 
 <file path=ppt/charts/chart5.xml><?xml version="1.0" encoding="utf-8"?>
@@ -275,640 +909,6 @@
     </a:ln>
     <a:effectLst/>
   </c:spPr>
-  <c:externalData r:id="rId1">
-    <c:autoUpdate val="0"/>
-  </c:externalData>
-</c:chartSpace>
-</file>
-
-<file path=ppt/charts/chart6.xml><?xml version="1.0" encoding="utf-8"?>
-<c:chartSpace xmlns:c="http://schemas.openxmlformats.org/drawingml/2006/chart" xmlns:a="http://schemas.openxmlformats.org/drawingml/2006/main" xmlns:r="http://schemas.openxmlformats.org/officeDocument/2006/relationships">
-  <c:date1904 val="0"/>
-  <c:chart>
-    <c:autoTitleDeleted val="1"/>
-    <c:plotArea>
-      <c:lineChart>
-        <c:grouping val="standard"/>
-        <c:varyColors val="0"/>
-        <c:ser>
-          <c:idx val="0"/>
-          <c:order val="0"/>
-          <c:tx>
-            <c:strRef>
-              <c:f>Sheet1!$B$1</c:f>
-              <c:strCache>
-                <c:ptCount val="1"/>
-                <c:pt idx="0">
-                  <c:v>Injuries / 1,000 90s</c:v>
-                </c:pt>
-              </c:strCache>
-            </c:strRef>
-          </c:tx>
-          <c:spPr>
-            <a:ln w="34925">
-              <a:solidFill>
-                <a:srgbClr val="C0392B"/>
-              </a:solidFill>
-            </a:ln>
-          </c:spPr>
-          <c:marker>
-            <c:symbol val="circle"/>
-            <c:size val="9"/>
-            <c:spPr>
-              <a:solidFill>
-                <a:srgbClr val="C0392B"/>
-              </a:solidFill>
-              <a:ln>
-                <a:solidFill>
-                  <a:srgbClr val="C0392B"/>
-                </a:solidFill>
-              </a:ln>
-            </c:spPr>
-          </c:marker>
-          <c:cat>
-            <c:strRef>
-              <c:f>Sheet1!$A$2:$A$5</c:f>
-              <c:strCache>
-                <c:ptCount val="4"/>
-                <c:pt idx="0">
-                  <c:v>21–24
-(emerging)</c:v>
-                </c:pt>
-                <c:pt idx="1">
-                  <c:v>25–28
-(prime)</c:v>
-                </c:pt>
-                <c:pt idx="2">
-                  <c:v>29–32
-(established)</c:v>
-                </c:pt>
-                <c:pt idx="3">
-                  <c:v>33+
-(veteran)</c:v>
-                </c:pt>
-              </c:strCache>
-            </c:strRef>
-          </c:cat>
-          <c:val>
-            <c:numRef>
-              <c:f>Sheet1!$B$2:$B$5</c:f>
-              <c:numCache>
-                <c:formatCode>General</c:formatCode>
-                <c:ptCount val="4"/>
-                <c:pt idx="0">
-                  <c:v>2.49</c:v>
-                </c:pt>
-                <c:pt idx="1">
-                  <c:v>3.97</c:v>
-                </c:pt>
-                <c:pt idx="2">
-                  <c:v>3.22</c:v>
-                </c:pt>
-                <c:pt idx="3">
-                  <c:v>5.95</c:v>
-                </c:pt>
-              </c:numCache>
-            </c:numRef>
-          </c:val>
-          <c:smooth val="0"/>
-        </c:ser>
-        <c:dLbls>
-          <c:numFmt formatCode="0.00" sourceLinked="0"/>
-          <c:txPr>
-            <a:bodyPr/>
-            <a:lstStyle/>
-            <a:p>
-              <a:pPr>
-                <a:defRPr sz="1200" b="1">
-                  <a:solidFill>
-                    <a:srgbClr val="C0392B"/>
-                  </a:solidFill>
-                  <a:latin typeface="Calibri"/>
-                </a:defRPr>
-              </a:pPr>
-            </a:p>
-          </c:txPr>
-          <c:dLblPos val="t"/>
-          <c:showLegendKey val="0"/>
-          <c:showVal val="1"/>
-          <c:showCatName val="0"/>
-          <c:showSerName val="0"/>
-          <c:showPercent val="0"/>
-          <c:showBubbleSize val="0"/>
-          <c:showLeaderLines val="1"/>
-        </c:dLbls>
-        <c:marker val="1"/>
-        <c:smooth val="0"/>
-        <c:axId val="2118791784"/>
-        <c:axId val="2140495176"/>
-      </c:lineChart>
-      <c:catAx>
-        <c:axId val="2118791784"/>
-        <c:scaling>
-          <c:orientation val="minMax"/>
-        </c:scaling>
-        <c:delete val="0"/>
-        <c:axPos val="b"/>
-        <c:majorTickMark val="out"/>
-        <c:minorTickMark val="none"/>
-        <c:tickLblPos val="nextTo"/>
-        <c:spPr>
-          <a:ln>
-            <a:solidFill>
-              <a:srgbClr val="E3E6EC"/>
-            </a:solidFill>
-          </a:ln>
-        </c:spPr>
-        <c:txPr>
-          <a:bodyPr/>
-          <a:lstStyle/>
-          <a:p>
-            <a:pPr>
-              <a:defRPr sz="1100">
-                <a:solidFill>
-                  <a:srgbClr val="44506B"/>
-                </a:solidFill>
-                <a:latin typeface="Calibri"/>
-              </a:defRPr>
-            </a:pPr>
-          </a:p>
-        </c:txPr>
-        <c:crossAx val="2140495176"/>
-        <c:crosses val="autoZero"/>
-        <c:auto val="1"/>
-        <c:lblAlgn val="ctr"/>
-        <c:lblOffset val="100"/>
-        <c:noMultiLvlLbl val="0"/>
-      </c:catAx>
-      <c:valAx>
-        <c:axId val="2140495176"/>
-        <c:scaling>
-          <c:max val="7.0"/>
-          <c:min val="0.0"/>
-        </c:scaling>
-        <c:delete val="0"/>
-        <c:axPos val="l"/>
-        <c:majorGridlines>
-          <c:spPr>
-            <a:ln w="6350">
-              <a:solidFill>
-                <a:srgbClr val="E3E6EC"/>
-              </a:solidFill>
-            </a:ln>
-          </c:spPr>
-        </c:majorGridlines>
-        <c:majorTickMark val="out"/>
-        <c:minorTickMark val="none"/>
-        <c:tickLblPos val="nextTo"/>
-        <c:spPr>
-          <a:ln>
-            <a:noFill/>
-          </a:ln>
-        </c:spPr>
-        <c:txPr>
-          <a:bodyPr/>
-          <a:lstStyle/>
-          <a:p>
-            <a:pPr>
-              <a:defRPr sz="1100">
-                <a:solidFill>
-                  <a:srgbClr val="44506B"/>
-                </a:solidFill>
-                <a:latin typeface="Calibri"/>
-              </a:defRPr>
-            </a:pPr>
-          </a:p>
-        </c:txPr>
-        <c:crossAx val="2118791784"/>
-        <c:crosses val="autoZero"/>
-      </c:valAx>
-    </c:plotArea>
-    <c:plotVisOnly val="1"/>
-    <c:dispBlanksAs val="gap"/>
-    <c:showDLblsOverMax val="0"/>
-  </c:chart>
-  <c:txPr>
-    <a:bodyPr/>
-    <a:lstStyle/>
-    <a:p>
-      <a:pPr>
-        <a:defRPr sz="1800"/>
-      </a:pPr>
-      <a:endParaRPr lang="en-US"/>
-    </a:p>
-  </c:txPr>
-  <c:externalData r:id="rId1">
-    <c:autoUpdate val="0"/>
-  </c:externalData>
-</c:chartSpace>
-</file>
-
-<file path=ppt/charts/chart7.xml><?xml version="1.0" encoding="utf-8"?>
-<c:chartSpace xmlns:c="http://schemas.openxmlformats.org/drawingml/2006/chart" xmlns:a="http://schemas.openxmlformats.org/drawingml/2006/main" xmlns:r="http://schemas.openxmlformats.org/officeDocument/2006/relationships">
-  <c:date1904 val="0"/>
-  <c:chart>
-    <c:autoTitleDeleted val="1"/>
-    <c:plotArea>
-      <c:barChart>
-        <c:barDir val="bar"/>
-        <c:grouping val="clustered"/>
-        <c:ser>
-          <c:idx val="0"/>
-          <c:order val="0"/>
-          <c:tx>
-            <c:strRef>
-              <c:f>Sheet1!$B$1</c:f>
-              <c:strCache>
-                <c:ptCount val="1"/>
-                <c:pt idx="0">
-                  <c:v>Injuries / 1,000 90s</c:v>
-                </c:pt>
-              </c:strCache>
-            </c:strRef>
-          </c:tx>
-          <c:spPr>
-            <a:solidFill>
-              <a:srgbClr val="B9C0CE"/>
-            </a:solidFill>
-            <a:ln>
-              <a:noFill/>
-            </a:ln>
-          </c:spPr>
-          <c:dPt>
-            <c:idx val="3"/>
-            <c:spPr>
-              <a:solidFill>
-                <a:srgbClr val="0F1B3D"/>
-              </a:solidFill>
-            </c:spPr>
-          </c:dPt>
-          <c:cat>
-            <c:strRef>
-              <c:f>Sheet1!$A$2:$A$5</c:f>
-              <c:strCache>
-                <c:ptCount val="4"/>
-                <c:pt idx="0">
-                  <c:v>Attack</c:v>
-                </c:pt>
-                <c:pt idx="1">
-                  <c:v>Midfield</c:v>
-                </c:pt>
-                <c:pt idx="2">
-                  <c:v>Defender</c:v>
-                </c:pt>
-                <c:pt idx="3">
-                  <c:v>Goalkeeper</c:v>
-                </c:pt>
-              </c:strCache>
-            </c:strRef>
-          </c:cat>
-          <c:val>
-            <c:numRef>
-              <c:f>Sheet1!$B$2:$B$5</c:f>
-              <c:numCache>
-                <c:formatCode>General</c:formatCode>
-                <c:ptCount val="4"/>
-                <c:pt idx="0">
-                  <c:v>4.15</c:v>
-                </c:pt>
-                <c:pt idx="1">
-                  <c:v>4.23</c:v>
-                </c:pt>
-                <c:pt idx="2">
-                  <c:v>4.3</c:v>
-                </c:pt>
-                <c:pt idx="3">
-                  <c:v>2.32</c:v>
-                </c:pt>
-              </c:numCache>
-            </c:numRef>
-          </c:val>
-        </c:ser>
-        <c:dLbls>
-          <c:numFmt formatCode="0.00" sourceLinked="0"/>
-          <c:txPr>
-            <a:bodyPr/>
-            <a:lstStyle/>
-            <a:p>
-              <a:pPr>
-                <a:defRPr sz="1200" b="1">
-                  <a:solidFill>
-                    <a:srgbClr val="44506B"/>
-                  </a:solidFill>
-                  <a:latin typeface="Calibri"/>
-                </a:defRPr>
-              </a:pPr>
-            </a:p>
-          </c:txPr>
-          <c:dLblPos val="outEnd"/>
-          <c:showLegendKey val="0"/>
-          <c:showVal val="1"/>
-          <c:showCatName val="0"/>
-          <c:showSerName val="0"/>
-          <c:showPercent val="0"/>
-          <c:showBubbleSize val="0"/>
-          <c:showLeaderLines val="1"/>
-        </c:dLbls>
-        <c:gapWidth val="60"/>
-        <c:axId val="2068027336"/>
-        <c:axId val="2113994440"/>
-      </c:barChart>
-      <c:catAx>
-        <c:axId val="2068027336"/>
-        <c:scaling>
-          <c:orientation val="minMax"/>
-        </c:scaling>
-        <c:delete val="0"/>
-        <c:axPos val="l"/>
-        <c:majorTickMark val="out"/>
-        <c:minorTickMark val="none"/>
-        <c:tickLblPos val="nextTo"/>
-        <c:spPr>
-          <a:ln>
-            <a:solidFill>
-              <a:srgbClr val="E3E6EC"/>
-            </a:solidFill>
-          </a:ln>
-        </c:spPr>
-        <c:txPr>
-          <a:bodyPr/>
-          <a:lstStyle/>
-          <a:p>
-            <a:pPr>
-              <a:defRPr sz="1200">
-                <a:solidFill>
-                  <a:srgbClr val="44506B"/>
-                </a:solidFill>
-                <a:latin typeface="Calibri"/>
-              </a:defRPr>
-            </a:pPr>
-          </a:p>
-        </c:txPr>
-        <c:crossAx val="2113994440"/>
-        <c:crosses val="autoZero"/>
-        <c:auto val="1"/>
-        <c:lblAlgn val="ctr"/>
-        <c:lblOffset val="100"/>
-        <c:noMultiLvlLbl val="0"/>
-      </c:catAx>
-      <c:valAx>
-        <c:axId val="2113994440"/>
-        <c:scaling>
-          <c:max val="5.5"/>
-          <c:min val="0.0"/>
-        </c:scaling>
-        <c:delete val="0"/>
-        <c:axPos val="b"/>
-        <c:majorGridlines>
-          <c:spPr>
-            <a:ln w="6350">
-              <a:solidFill>
-                <a:srgbClr val="E3E6EC"/>
-              </a:solidFill>
-            </a:ln>
-          </c:spPr>
-        </c:majorGridlines>
-        <c:majorTickMark val="out"/>
-        <c:minorTickMark val="none"/>
-        <c:tickLblPos val="nextTo"/>
-        <c:spPr>
-          <a:ln>
-            <a:noFill/>
-          </a:ln>
-        </c:spPr>
-        <c:txPr>
-          <a:bodyPr/>
-          <a:lstStyle/>
-          <a:p>
-            <a:pPr>
-              <a:defRPr sz="1000">
-                <a:solidFill>
-                  <a:srgbClr val="44506B"/>
-                </a:solidFill>
-                <a:latin typeface="Calibri"/>
-              </a:defRPr>
-            </a:pPr>
-          </a:p>
-        </c:txPr>
-        <c:crossAx val="2068027336"/>
-        <c:crosses val="autoZero"/>
-      </c:valAx>
-    </c:plotArea>
-    <c:dispBlanksAs val="gap"/>
-  </c:chart>
-  <c:txPr>
-    <a:bodyPr/>
-    <a:lstStyle/>
-    <a:p>
-      <a:pPr>
-        <a:defRPr sz="1800"/>
-      </a:pPr>
-      <a:endParaRPr lang="en-US"/>
-    </a:p>
-  </c:txPr>
-  <c:externalData r:id="rId1">
-    <c:autoUpdate val="0"/>
-  </c:externalData>
-</c:chartSpace>
-</file>
-
-<file path=ppt/charts/chart8.xml><?xml version="1.0" encoding="utf-8"?>
-<c:chartSpace xmlns:c="http://schemas.openxmlformats.org/drawingml/2006/chart" xmlns:a="http://schemas.openxmlformats.org/drawingml/2006/main" xmlns:r="http://schemas.openxmlformats.org/officeDocument/2006/relationships">
-  <c:date1904 val="0"/>
-  <c:chart>
-    <c:autoTitleDeleted val="1"/>
-    <c:plotArea>
-      <c:barChart>
-        <c:barDir val="bar"/>
-        <c:grouping val="clustered"/>
-        <c:ser>
-          <c:idx val="0"/>
-          <c:order val="0"/>
-          <c:tx>
-            <c:strRef>
-              <c:f>Sheet1!$B$1</c:f>
-              <c:strCache>
-                <c:ptCount val="1"/>
-                <c:pt idx="0">
-                  <c:v>Accuracy (%)</c:v>
-                </c:pt>
-              </c:strCache>
-            </c:strRef>
-          </c:tx>
-          <c:dPt>
-            <c:idx val="1"/>
-            <c:spPr>
-              <a:solidFill>
-                <a:srgbClr val="C0392B"/>
-              </a:solidFill>
-            </c:spPr>
-          </c:dPt>
-          <c:dPt>
-            <c:idx val="0"/>
-            <c:spPr>
-              <a:noFill/>
-              <a:ln w="22225">
-                <a:solidFill>
-                  <a:srgbClr val="44506B"/>
-                </a:solidFill>
-                <a:prstDash val="dash"/>
-              </a:ln>
-            </c:spPr>
-          </c:dPt>
-          <c:cat>
-            <c:strRef>
-              <c:f>Sheet1!$A$2:$A$3</c:f>
-              <c:strCache>
-                <c:ptCount val="2"/>
-                <c:pt idx="0">
-                  <c:v>Coin-flip
-baseline</c:v>
-                </c:pt>
-                <c:pt idx="1">
-                  <c:v>Model
-(backtested)</c:v>
-                </c:pt>
-              </c:strCache>
-            </c:strRef>
-          </c:cat>
-          <c:val>
-            <c:numRef>
-              <c:f>Sheet1!$B$2:$B$3</c:f>
-              <c:numCache>
-                <c:formatCode>General</c:formatCode>
-                <c:ptCount val="2"/>
-                <c:pt idx="0">
-                  <c:v>50.0</c:v>
-                </c:pt>
-                <c:pt idx="1">
-                  <c:v>22.7</c:v>
-                </c:pt>
-              </c:numCache>
-            </c:numRef>
-          </c:val>
-        </c:ser>
-        <c:dLbls>
-          <c:numFmt formatCode="0.0&quot;%&quot;" sourceLinked="0"/>
-          <c:txPr>
-            <a:bodyPr/>
-            <a:lstStyle/>
-            <a:p>
-              <a:pPr>
-                <a:defRPr sz="1300" b="1">
-                  <a:solidFill>
-                    <a:srgbClr val="44506B"/>
-                  </a:solidFill>
-                  <a:latin typeface="Calibri"/>
-                </a:defRPr>
-              </a:pPr>
-            </a:p>
-          </c:txPr>
-          <c:dLblPos val="outEnd"/>
-          <c:showLegendKey val="0"/>
-          <c:showVal val="1"/>
-          <c:showCatName val="0"/>
-          <c:showSerName val="0"/>
-          <c:showPercent val="0"/>
-          <c:showBubbleSize val="0"/>
-          <c:showLeaderLines val="1"/>
-        </c:dLbls>
-        <c:gapWidth val="70"/>
-        <c:axId val="2068027336"/>
-        <c:axId val="2113994440"/>
-      </c:barChart>
-      <c:catAx>
-        <c:axId val="2068027336"/>
-        <c:scaling>
-          <c:orientation val="minMax"/>
-        </c:scaling>
-        <c:delete val="0"/>
-        <c:axPos val="l"/>
-        <c:majorTickMark val="out"/>
-        <c:minorTickMark val="none"/>
-        <c:tickLblPos val="nextTo"/>
-        <c:spPr>
-          <a:ln>
-            <a:solidFill>
-              <a:srgbClr val="E3E6EC"/>
-            </a:solidFill>
-          </a:ln>
-        </c:spPr>
-        <c:txPr>
-          <a:bodyPr/>
-          <a:lstStyle/>
-          <a:p>
-            <a:pPr>
-              <a:defRPr sz="1200">
-                <a:solidFill>
-                  <a:srgbClr val="44506B"/>
-                </a:solidFill>
-                <a:latin typeface="Calibri"/>
-              </a:defRPr>
-            </a:pPr>
-          </a:p>
-        </c:txPr>
-        <c:crossAx val="2113994440"/>
-        <c:crosses val="autoZero"/>
-        <c:auto val="1"/>
-        <c:lblAlgn val="ctr"/>
-        <c:lblOffset val="100"/>
-        <c:noMultiLvlLbl val="0"/>
-      </c:catAx>
-      <c:valAx>
-        <c:axId val="2113994440"/>
-        <c:scaling>
-          <c:max val="60.0"/>
-          <c:min val="0.0"/>
-        </c:scaling>
-        <c:delete val="0"/>
-        <c:axPos val="b"/>
-        <c:majorGridlines>
-          <c:spPr>
-            <a:ln w="6350">
-              <a:solidFill>
-                <a:srgbClr val="E3E6EC"/>
-              </a:solidFill>
-            </a:ln>
-          </c:spPr>
-        </c:majorGridlines>
-        <c:majorTickMark val="out"/>
-        <c:minorTickMark val="none"/>
-        <c:tickLblPos val="nextTo"/>
-        <c:spPr>
-          <a:ln>
-            <a:noFill/>
-          </a:ln>
-        </c:spPr>
-        <c:txPr>
-          <a:bodyPr/>
-          <a:lstStyle/>
-          <a:p>
-            <a:pPr>
-              <a:defRPr sz="1000">
-                <a:solidFill>
-                  <a:srgbClr val="44506B"/>
-                </a:solidFill>
-                <a:latin typeface="Calibri"/>
-              </a:defRPr>
-            </a:pPr>
-          </a:p>
-        </c:txPr>
-        <c:crossAx val="2068027336"/>
-        <c:crosses val="autoZero"/>
-      </c:valAx>
-    </c:plotArea>
-    <c:dispBlanksAs val="gap"/>
-  </c:chart>
-  <c:txPr>
-    <a:bodyPr/>
-    <a:lstStyle/>
-    <a:p>
-      <a:pPr>
-        <a:defRPr sz="1800"/>
-      </a:pPr>
-      <a:endParaRPr lang="en-US"/>
-    </a:p>
-  </c:txPr>
   <c:externalData r:id="rId1">
     <c:autoUpdate val="0"/>
   </c:externalData>
@@ -22133,24 +22133,6 @@
           </a:prstGeom>
         </p:spPr>
       </p:pic>
-      <p:graphicFrame>
-        <p:nvGraphicFramePr>
-          <p:cNvPr id="63" name="Chart 62"/>
-          <p:cNvGraphicFramePr>
-            <a:graphicFrameLocks noGrp="1"/>
-          </p:cNvGraphicFramePr>
-          <p:nvPr/>
-        </p:nvGraphicFramePr>
-        <p:xfrm>
-          <a:off x="1143000" y="1280160"/>
-          <a:ext cx="4507992" cy="3566160"/>
-        </p:xfrm>
-        <a:graphic>
-          <a:graphicData uri="http://schemas.openxmlformats.org/drawingml/2006/chart">
-            <c:chart xmlns:c="http://schemas.openxmlformats.org/drawingml/2006/chart" r:id="rId8"/>
-          </a:graphicData>
-        </a:graphic>
-      </p:graphicFrame>
       <p:sp>
         <p:nvSpPr>
           <p:cNvPr id="64" name="TextBox 63"/>
@@ -22195,6 +22177,24 @@
           </a:p>
         </p:txBody>
       </p:sp>
+      <p:graphicFrame>
+        <p:nvGraphicFramePr>
+          <p:cNvPr id="65" name="Chart 64"/>
+          <p:cNvGraphicFramePr>
+            <a:graphicFrameLocks noGrp="1"/>
+          </p:cNvGraphicFramePr>
+          <p:nvPr/>
+        </p:nvGraphicFramePr>
+        <p:xfrm>
+          <a:off x="1143000" y="1280160"/>
+          <a:ext cx="4507992" cy="3566160"/>
+        </p:xfrm>
+        <a:graphic>
+          <a:graphicData uri="http://schemas.openxmlformats.org/drawingml/2006/chart">
+            <c:chart xmlns:c="http://schemas.openxmlformats.org/drawingml/2006/chart" r:id="rId5"/>
+          </a:graphicData>
+        </a:graphic>
+      </p:graphicFrame>
     </p:spTree>
     <p:extLst>
       <p:ext uri="{BB962C8B-B14F-4D97-AF65-F5344CB8AC3E}">
@@ -23647,24 +23647,6 @@
           </a:prstGeom>
         </p:spPr>
       </p:pic>
-      <p:graphicFrame>
-        <p:nvGraphicFramePr>
-          <p:cNvPr id="63" name="Chart 62"/>
-          <p:cNvGraphicFramePr>
-            <a:graphicFrameLocks noGrp="1"/>
-          </p:cNvGraphicFramePr>
-          <p:nvPr/>
-        </p:nvGraphicFramePr>
-        <p:xfrm>
-          <a:off x="6537960" y="1280160"/>
-          <a:ext cx="4507992" cy="3566160"/>
-        </p:xfrm>
-        <a:graphic>
-          <a:graphicData uri="http://schemas.openxmlformats.org/drawingml/2006/chart">
-            <c:chart xmlns:c="http://schemas.openxmlformats.org/drawingml/2006/chart" r:id="rId8"/>
-          </a:graphicData>
-        </a:graphic>
-      </p:graphicFrame>
       <p:sp>
         <p:nvSpPr>
           <p:cNvPr id="64" name="TextBox 63"/>
@@ -23709,6 +23691,24 @@
           </a:p>
         </p:txBody>
       </p:sp>
+      <p:graphicFrame>
+        <p:nvGraphicFramePr>
+          <p:cNvPr id="65" name="Chart 64"/>
+          <p:cNvGraphicFramePr>
+            <a:graphicFrameLocks noGrp="1"/>
+          </p:cNvGraphicFramePr>
+          <p:nvPr/>
+        </p:nvGraphicFramePr>
+        <p:xfrm>
+          <a:off x="6537960" y="1280160"/>
+          <a:ext cx="4507992" cy="3566160"/>
+        </p:xfrm>
+        <a:graphic>
+          <a:graphicData uri="http://schemas.openxmlformats.org/drawingml/2006/chart">
+            <c:chart xmlns:c="http://schemas.openxmlformats.org/drawingml/2006/chart" r:id="rId5"/>
+          </a:graphicData>
+        </a:graphic>
+      </p:graphicFrame>
     </p:spTree>
     <p:extLst>
       <p:ext uri="{BB962C8B-B14F-4D97-AF65-F5344CB8AC3E}">
@@ -25139,24 +25139,6 @@
           </a:p>
         </p:txBody>
       </p:sp>
-      <p:graphicFrame>
-        <p:nvGraphicFramePr>
-          <p:cNvPr id="25" name="Chart 24"/>
-          <p:cNvGraphicFramePr>
-            <a:graphicFrameLocks noGrp="1"/>
-          </p:cNvGraphicFramePr>
-          <p:nvPr/>
-        </p:nvGraphicFramePr>
-        <p:xfrm>
-          <a:off x="6537960" y="1280160"/>
-          <a:ext cx="4507992" cy="3566160"/>
-        </p:xfrm>
-        <a:graphic>
-          <a:graphicData uri="http://schemas.openxmlformats.org/drawingml/2006/chart">
-            <c:chart xmlns:c="http://schemas.openxmlformats.org/drawingml/2006/chart" r:id="rId7"/>
-          </a:graphicData>
-        </a:graphic>
-      </p:graphicFrame>
       <p:sp>
         <p:nvSpPr>
           <p:cNvPr id="26" name="TextBox 25"/>
@@ -25201,6 +25183,24 @@
           </a:p>
         </p:txBody>
       </p:sp>
+      <p:graphicFrame>
+        <p:nvGraphicFramePr>
+          <p:cNvPr id="27" name="Chart 26"/>
+          <p:cNvGraphicFramePr>
+            <a:graphicFrameLocks noGrp="1"/>
+          </p:cNvGraphicFramePr>
+          <p:nvPr/>
+        </p:nvGraphicFramePr>
+        <p:xfrm>
+          <a:off x="6537960" y="1280160"/>
+          <a:ext cx="4507992" cy="3566160"/>
+        </p:xfrm>
+        <a:graphic>
+          <a:graphicData uri="http://schemas.openxmlformats.org/drawingml/2006/chart">
+            <c:chart xmlns:c="http://schemas.openxmlformats.org/drawingml/2006/chart" r:id="rId6"/>
+          </a:graphicData>
+        </a:graphic>
+      </p:graphicFrame>
     </p:spTree>
   </p:cSld>
   <p:clrMapOvr>

</xml_diff>

<commit_message>
Remove misplaced webextensiontaskpanes relationship from package root and unused webextension parts (likely PowerPoint repair root cause)
</commit_message>
<xml_diff>
--- a/Worth_the_Investment_Capstone_Skeleton_Final.pptx
+++ b/Worth_the_Investment_Capstone_Skeleton_Final.pptx
@@ -25817,26 +25817,4 @@
     </a:ext>
   </a:extLst>
 </a:theme>
-</file>
-
-<file path=ppt/webextensions/taskpanes.xml><?xml version="1.0" encoding="utf-8"?>
-<wetp:taskpanes xmlns:wetp="http://schemas.microsoft.com/office/webextensions/taskpanes/2010/11">
-  <wetp:taskpane dockstate="right" visibility="0" width="438" row="0">
-    <wetp:webextensionref xmlns:r="http://schemas.openxmlformats.org/officeDocument/2006/relationships" r:id="rId1"/>
-  </wetp:taskpane>
-</wetp:taskpanes>
-</file>
-
-<file path=ppt/webextensions/webextension1.xml><?xml version="1.0" encoding="utf-8"?>
-<we:webextension xmlns:we="http://schemas.microsoft.com/office/webextensions/webextension/2010/11" id="{3158304C-5A88-4E74-8F87-7A0943278825}">
-  <we:reference id="wa200010001" version="1.0.0.1" store="en-US" storeType="OMEX"/>
-  <we:alternateReferences>
-    <we:reference id="wa200010001" version="1.0.0.1" store="en-US" storeType="OMEX"/>
-  </we:alternateReferences>
-  <we:properties>
-    <we:property name="claude.fileId" value="&quot;9fa04c96-0cfd-4bc2-85fd-1c549d8db7d4&quot;"/>
-  </we:properties>
-  <we:bindings/>
-  <we:snapshot xmlns:r="http://schemas.openxmlformats.org/officeDocument/2006/relationships"/>
-</we:webextension>
 </file>
</xml_diff>

<commit_message>
Fix broken Tableau dashboard hyperlink on the 'Now, in Tableau' slide
The button and its label both pointed at stale paths from the cloud
build environment (/home/claude/... and /mnt/data/...) instead of the
workbook's real location on the user's machine, so PowerPoint couldn't
resolve it and opened a fresh, empty Tableau window instead of
activating the one already open. Repointed both to the correct absolute
path, verified the fix survived the LibreOffice normalization pass.
</commit_message>
<xml_diff>
--- a/Worth_the_Investment_Capstone_Skeleton_Final.pptx
+++ b/Worth_the_Investment_Capstone_Skeleton_Final.pptx
@@ -372,11 +372,11 @@
           </c:spPr>
         </c:hiLowLines>
         <c:marker val="1"/>
-        <c:axId val="30815567"/>
-        <c:axId val="42680508"/>
+        <c:axId val="12929865"/>
+        <c:axId val="34676920"/>
       </c:lineChart>
       <c:catAx>
-        <c:axId val="30815567"/>
+        <c:axId val="12929865"/>
         <c:scaling>
           <c:orientation val="minMax"/>
         </c:scaling>
@@ -408,7 +408,7 @@
             </a:pPr>
           </a:p>
         </c:txPr>
-        <c:crossAx val="42680508"/>
+        <c:crossAx val="34676920"/>
         <c:crosses val="autoZero"/>
         <c:auto val="1"/>
         <c:lblAlgn val="ctr"/>
@@ -416,7 +416,7 @@
         <c:noMultiLvlLbl val="0"/>
       </c:catAx>
       <c:valAx>
-        <c:axId val="42680508"/>
+        <c:axId val="34676920"/>
         <c:scaling>
           <c:orientation val="minMax"/>
           <c:max val="7"/>
@@ -457,7 +457,7 @@
             </a:pPr>
           </a:p>
         </c:txPr>
-        <c:crossAx val="30815567"/>
+        <c:crossAx val="12929865"/>
         <c:crosses val="autoZero"/>
         <c:crossBetween val="between"/>
       </c:valAx>
@@ -800,11 +800,11 @@
         </c:ser>
         <c:gapWidth val="60"/>
         <c:overlap val="0"/>
-        <c:axId val="80240490"/>
-        <c:axId val="28741744"/>
+        <c:axId val="60773148"/>
+        <c:axId val="71978636"/>
       </c:barChart>
       <c:catAx>
-        <c:axId val="80240490"/>
+        <c:axId val="60773148"/>
         <c:scaling>
           <c:orientation val="minMax"/>
         </c:scaling>
@@ -836,7 +836,7 @@
             </a:pPr>
           </a:p>
         </c:txPr>
-        <c:crossAx val="28741744"/>
+        <c:crossAx val="71978636"/>
         <c:crosses val="autoZero"/>
         <c:auto val="1"/>
         <c:lblAlgn val="ctr"/>
@@ -844,7 +844,7 @@
         <c:noMultiLvlLbl val="0"/>
       </c:catAx>
       <c:valAx>
-        <c:axId val="28741744"/>
+        <c:axId val="71978636"/>
         <c:scaling>
           <c:orientation val="minMax"/>
           <c:max val="5.5"/>
@@ -885,7 +885,7 @@
             </a:pPr>
           </a:p>
         </c:txPr>
-        <c:crossAx val="80240490"/>
+        <c:crossAx val="60773148"/>
         <c:crosses val="autoZero"/>
         <c:crossBetween val="between"/>
       </c:valAx>
@@ -1114,11 +1114,11 @@
         </c:ser>
         <c:gapWidth val="70"/>
         <c:overlap val="0"/>
-        <c:axId val="1885150"/>
-        <c:axId val="23409373"/>
+        <c:axId val="16454280"/>
+        <c:axId val="61549859"/>
       </c:barChart>
       <c:catAx>
-        <c:axId val="1885150"/>
+        <c:axId val="16454280"/>
         <c:scaling>
           <c:orientation val="minMax"/>
         </c:scaling>
@@ -1150,7 +1150,7 @@
             </a:pPr>
           </a:p>
         </c:txPr>
-        <c:crossAx val="23409373"/>
+        <c:crossAx val="61549859"/>
         <c:crosses val="autoZero"/>
         <c:auto val="1"/>
         <c:lblAlgn val="ctr"/>
@@ -1158,7 +1158,7 @@
         <c:noMultiLvlLbl val="0"/>
       </c:catAx>
       <c:valAx>
-        <c:axId val="23409373"/>
+        <c:axId val="61549859"/>
         <c:scaling>
           <c:orientation val="minMax"/>
           <c:max val="60"/>
@@ -1199,7 +1199,7 @@
             </a:pPr>
           </a:p>
         </c:txPr>
-        <c:crossAx val="1885150"/>
+        <c:crossAx val="16454280"/>
         <c:crosses val="autoZero"/>
         <c:crossBetween val="between"/>
       </c:valAx>
@@ -1546,7 +1546,7 @@
             <a:pPr indent="0" algn="r">
               <a:buNone/>
             </a:pPr>
-            <a:fld id="{491942AD-5DC6-4719-82D7-8C903203FDDD}" type="slidenum">
+            <a:fld id="{0AAA0103-5BDC-48C2-8E64-C2BB8BBC035F}" type="slidenum">
               <a:rPr b="0" lang="en-US" sz="1400" spc="-1" strike="noStrike">
                 <a:solidFill>
                   <a:srgbClr val="000000"/>
@@ -1705,7 +1705,7 @@
                 <a:tab algn="l" pos="0"/>
               </a:tabLst>
             </a:pPr>
-            <a:fld id="{FF8AF9B4-3E2F-4066-8C20-8A0EEED06AC3}" type="slidenum">
+            <a:fld id="{77A6512C-6E85-426F-B98D-1D172478699D}" type="slidenum">
               <a:rPr b="0" lang="en-US" sz="1800" spc="-1" strike="noStrike">
                 <a:solidFill>
                   <a:schemeClr val="dk1"/>
@@ -1879,7 +1879,7 @@
                 <a:tab algn="l" pos="0"/>
               </a:tabLst>
             </a:pPr>
-            <a:fld id="{E9190AB4-8887-4353-BD5E-41C955CEF3B0}" type="slidenum">
+            <a:fld id="{7C6D22EC-EB70-4D3A-95C4-06D04C735829}" type="slidenum">
               <a:rPr b="0" lang="en-US" sz="1800" spc="-1" strike="noStrike">
                 <a:solidFill>
                   <a:schemeClr val="dk1"/>
@@ -2053,7 +2053,7 @@
                 <a:tab algn="l" pos="0"/>
               </a:tabLst>
             </a:pPr>
-            <a:fld id="{66ED7F55-907A-4BCA-8C75-C8B5F932F314}" type="slidenum">
+            <a:fld id="{11B71B4E-4B36-45F2-8C13-154A9282442C}" type="slidenum">
               <a:rPr b="0" lang="en-US" sz="1800" spc="-1" strike="noStrike">
                 <a:solidFill>
                   <a:schemeClr val="dk1"/>
@@ -2212,7 +2212,7 @@
                 <a:tab algn="l" pos="0"/>
               </a:tabLst>
             </a:pPr>
-            <a:fld id="{C6767527-5163-4424-86EA-E5DF0B432DAB}" type="slidenum">
+            <a:fld id="{E69B9640-BD58-49A5-8336-98F25C65313E}" type="slidenum">
               <a:rPr b="0" lang="en-US" sz="1800" spc="-1" strike="noStrike">
                 <a:solidFill>
                   <a:schemeClr val="dk1"/>
@@ -2386,7 +2386,7 @@
                 <a:tab algn="l" pos="0"/>
               </a:tabLst>
             </a:pPr>
-            <a:fld id="{4BDE3991-37A6-4895-835C-BE4BA63C1B89}" type="slidenum">
+            <a:fld id="{9D6028F0-BDB5-4EC3-8958-525BC0AFEE56}" type="slidenum">
               <a:rPr b="0" lang="en-US" sz="1800" spc="-1" strike="noStrike">
                 <a:solidFill>
                   <a:schemeClr val="dk1"/>
@@ -2545,7 +2545,7 @@
                 <a:tab algn="l" pos="0"/>
               </a:tabLst>
             </a:pPr>
-            <a:fld id="{C9E1CD3F-554E-4BB9-A949-04F6CC7F6E8D}" type="slidenum">
+            <a:fld id="{0FA2553E-9BFC-4795-89D8-C67EEE20A754}" type="slidenum">
               <a:rPr b="0" lang="en-US" sz="1800" spc="-1" strike="noStrike">
                 <a:solidFill>
                   <a:schemeClr val="dk1"/>
@@ -2719,7 +2719,7 @@
                 <a:tab algn="l" pos="0"/>
               </a:tabLst>
             </a:pPr>
-            <a:fld id="{5709743E-6C46-40BC-A069-597EA721863B}" type="slidenum">
+            <a:fld id="{2B2A6EBF-4604-465E-A468-A6403C78D4ED}" type="slidenum">
               <a:rPr b="0" lang="en-US" sz="1800" spc="-1" strike="noStrike">
                 <a:solidFill>
                   <a:srgbClr val="000000"/>
@@ -2878,7 +2878,7 @@
                 <a:tab algn="l" pos="0"/>
               </a:tabLst>
             </a:pPr>
-            <a:fld id="{2A9C7263-3188-40BC-AB80-320F26F200DA}" type="slidenum">
+            <a:fld id="{27D3BA92-1FFF-4FA2-BA21-29968ECE55ED}" type="slidenum">
               <a:rPr b="0" lang="en-US" sz="1800" spc="-1" strike="noStrike">
                 <a:solidFill>
                   <a:schemeClr val="dk1"/>
@@ -3037,7 +3037,7 @@
                 <a:tab algn="l" pos="0"/>
               </a:tabLst>
             </a:pPr>
-            <a:fld id="{1C1DE094-C3AC-4C9D-A398-760239913874}" type="slidenum">
+            <a:fld id="{B37478A2-BECC-4B4B-82AE-0A4B1C661EF1}" type="slidenum">
               <a:rPr b="0" lang="en-US" sz="1800" spc="-1" strike="noStrike">
                 <a:solidFill>
                   <a:schemeClr val="dk1"/>
@@ -3196,7 +3196,7 @@
                 <a:tab algn="l" pos="0"/>
               </a:tabLst>
             </a:pPr>
-            <a:fld id="{D9ADCF65-5808-4694-8615-64956029F0CC}" type="slidenum">
+            <a:fld id="{3BDD8F74-84E7-42EC-B547-124C59F4759B}" type="slidenum">
               <a:rPr b="0" lang="en-US" sz="1800" spc="-1" strike="noStrike">
                 <a:solidFill>
                   <a:schemeClr val="dk1"/>
@@ -3355,7 +3355,7 @@
                 <a:tab algn="l" pos="0"/>
               </a:tabLst>
             </a:pPr>
-            <a:fld id="{E9871D45-E60D-4AFD-BE89-231F93126022}" type="slidenum">
+            <a:fld id="{FB407DD1-F7A8-481E-A426-58B286304B59}" type="slidenum">
               <a:rPr b="0" lang="en-US" sz="1800" spc="-1" strike="noStrike">
                 <a:solidFill>
                   <a:schemeClr val="dk1"/>
@@ -3514,7 +3514,7 @@
                 <a:tab algn="l" pos="0"/>
               </a:tabLst>
             </a:pPr>
-            <a:fld id="{04778849-E4B3-4B52-AC8C-303366419DF1}" type="slidenum">
+            <a:fld id="{82208337-0668-4CD5-A784-01E9D6F016A3}" type="slidenum">
               <a:rPr b="0" lang="en-US" sz="1800" spc="-1" strike="noStrike">
                 <a:solidFill>
                   <a:schemeClr val="dk1"/>
@@ -3673,7 +3673,7 @@
                 <a:tab algn="l" pos="0"/>
               </a:tabLst>
             </a:pPr>
-            <a:fld id="{4D7C1717-19FE-4D7A-9253-D5BA01E917A0}" type="slidenum">
+            <a:fld id="{B752EAD1-6AEE-427E-AD4A-106053B65ABB}" type="slidenum">
               <a:rPr b="0" lang="en-US" sz="1800" spc="-1" strike="noStrike">
                 <a:solidFill>
                   <a:schemeClr val="dk1"/>
@@ -3832,7 +3832,7 @@
                 <a:tab algn="l" pos="0"/>
               </a:tabLst>
             </a:pPr>
-            <a:fld id="{F513AD34-CE56-46E3-A1DF-F91BC21FCDFA}" type="slidenum">
+            <a:fld id="{93F6DC69-F760-4140-8BA5-98C9477D0EA4}" type="slidenum">
               <a:rPr b="0" lang="en-US" sz="1800" spc="-1" strike="noStrike">
                 <a:solidFill>
                   <a:schemeClr val="dk1"/>
@@ -4024,7 +4024,7 @@
                 <a:tab algn="l" pos="0"/>
               </a:tabLst>
             </a:pPr>
-            <a:fld id="{E92052EF-FA7C-4FBE-B449-C6C465E65507}" type="slidenum">
+            <a:fld id="{FDB7C56F-5EE5-4CC8-811F-12FE0CC9EE5D}" type="slidenum">
               <a:rPr b="0" lang="en-US" sz="1800" spc="-1" strike="noStrike">
                 <a:solidFill>
                   <a:schemeClr val="dk1"/>
@@ -4198,7 +4198,7 @@
                 <a:tab algn="l" pos="0"/>
               </a:tabLst>
             </a:pPr>
-            <a:fld id="{E8EF2A17-31EB-42E4-A9C5-B9F39AB618D2}" type="slidenum">
+            <a:fld id="{DC445EC5-0D6D-47C2-81CB-C21315204176}" type="slidenum">
               <a:rPr b="0" lang="en-US" sz="1800" spc="-1" strike="noStrike">
                 <a:solidFill>
                   <a:schemeClr val="dk1"/>
@@ -4372,7 +4372,7 @@
                 <a:tab algn="l" pos="0"/>
               </a:tabLst>
             </a:pPr>
-            <a:fld id="{005990C6-651E-497E-95B8-AAA56FF49E30}" type="slidenum">
+            <a:fld id="{39BC769F-144B-4660-A660-ADAC9D4D744A}" type="slidenum">
               <a:rPr b="0" lang="en-US" sz="1800" spc="-1" strike="noStrike">
                 <a:solidFill>
                   <a:schemeClr val="dk1"/>
@@ -4758,7 +4758,7 @@
         <p:spPr>
           <a:xfrm>
             <a:off x="762120" y="762120"/>
-            <a:ext cx="10666440" cy="5332680"/>
+            <a:ext cx="10666080" cy="5332320"/>
           </a:xfrm>
           <a:prstGeom prst="rect">
             <a:avLst/>
@@ -4846,7 +4846,7 @@
         <p:spPr>
           <a:xfrm>
             <a:off x="5207040" y="2540160"/>
-            <a:ext cx="1776600" cy="1776600"/>
+            <a:ext cx="1776240" cy="1776240"/>
           </a:xfrm>
           <a:prstGeom prst="ellipse">
             <a:avLst/>
@@ -4893,7 +4893,7 @@
         <p:spPr>
           <a:xfrm>
             <a:off x="6045120" y="3378240"/>
-            <a:ext cx="100080" cy="100080"/>
+            <a:ext cx="99720" cy="99720"/>
           </a:xfrm>
           <a:prstGeom prst="ellipse">
             <a:avLst/>
@@ -4942,7 +4942,7 @@
         <p:spPr>
           <a:xfrm>
             <a:off x="762120" y="1905120"/>
-            <a:ext cx="1522440" cy="3046680"/>
+            <a:ext cx="1522080" cy="3046320"/>
           </a:xfrm>
           <a:prstGeom prst="rect">
             <a:avLst/>
@@ -4989,7 +4989,7 @@
         <p:spPr>
           <a:xfrm>
             <a:off x="762120" y="2666880"/>
-            <a:ext cx="658800" cy="1522440"/>
+            <a:ext cx="658440" cy="1522080"/>
           </a:xfrm>
           <a:prstGeom prst="rect">
             <a:avLst/>
@@ -5036,7 +5036,7 @@
         <p:spPr>
           <a:xfrm>
             <a:off x="9906120" y="1905120"/>
-            <a:ext cx="1522440" cy="3046680"/>
+            <a:ext cx="1522080" cy="3046320"/>
           </a:xfrm>
           <a:prstGeom prst="rect">
             <a:avLst/>
@@ -5083,7 +5083,7 @@
         <p:spPr>
           <a:xfrm>
             <a:off x="10769760" y="2666880"/>
-            <a:ext cx="658800" cy="1522440"/>
+            <a:ext cx="658440" cy="1522080"/>
           </a:xfrm>
           <a:prstGeom prst="rect">
             <a:avLst/>
@@ -5130,7 +5130,7 @@
         <p:spPr>
           <a:xfrm>
             <a:off x="-365760" y="-365760"/>
-            <a:ext cx="730080" cy="730080"/>
+            <a:ext cx="729720" cy="729720"/>
           </a:xfrm>
           <a:prstGeom prst="ellipse">
             <a:avLst/>
@@ -5179,7 +5179,7 @@
         <p:spPr>
           <a:xfrm>
             <a:off x="11826000" y="-365760"/>
-            <a:ext cx="730080" cy="730080"/>
+            <a:ext cx="729720" cy="729720"/>
           </a:xfrm>
           <a:prstGeom prst="ellipse">
             <a:avLst/>
@@ -5228,7 +5228,7 @@
         <p:spPr>
           <a:xfrm>
             <a:off x="-365760" y="6492240"/>
-            <a:ext cx="730080" cy="730080"/>
+            <a:ext cx="729720" cy="729720"/>
           </a:xfrm>
           <a:prstGeom prst="ellipse">
             <a:avLst/>
@@ -5277,7 +5277,7 @@
         <p:spPr>
           <a:xfrm>
             <a:off x="11826000" y="6492240"/>
-            <a:ext cx="730080" cy="730080"/>
+            <a:ext cx="729720" cy="729720"/>
           </a:xfrm>
           <a:prstGeom prst="ellipse">
             <a:avLst/>
@@ -5326,7 +5326,7 @@
         <p:spPr>
           <a:xfrm>
             <a:off x="7589520" y="-4297680"/>
-            <a:ext cx="5850720" cy="5850720"/>
+            <a:ext cx="5850360" cy="5850360"/>
           </a:xfrm>
           <a:prstGeom prst="ellipse">
             <a:avLst/>
@@ -5379,7 +5379,7 @@
         <p:spPr>
           <a:xfrm>
             <a:off x="10469880" y="-1417320"/>
-            <a:ext cx="90000" cy="90000"/>
+            <a:ext cx="89640" cy="89640"/>
           </a:xfrm>
           <a:prstGeom prst="ellipse">
             <a:avLst/>
@@ -5427,7 +5427,7 @@
         <p:spPr>
           <a:xfrm>
             <a:off x="822960" y="1691640"/>
-            <a:ext cx="7313760" cy="318600"/>
+            <a:ext cx="7313400" cy="318240"/>
           </a:xfrm>
           <a:prstGeom prst="rect">
             <a:avLst/>
@@ -5457,7 +5457,7 @@
               </a:tabLst>
             </a:pPr>
             <a:r>
-              <a:rPr b="1" lang="en-US" sz="1400" spc="194" strike="noStrike">
+              <a:rPr b="1" lang="en-US" sz="1400" spc="191" strike="noStrike">
                 <a:solidFill>
                   <a:srgbClr val="e8a33d"/>
                 </a:solidFill>
@@ -5484,7 +5484,7 @@
         <p:spPr>
           <a:xfrm>
             <a:off x="777240" y="2057400"/>
-            <a:ext cx="10056960" cy="1370160"/>
+            <a:ext cx="10056600" cy="1369800"/>
           </a:xfrm>
           <a:prstGeom prst="rect">
             <a:avLst/>
@@ -5541,7 +5541,7 @@
         <p:spPr>
           <a:xfrm>
             <a:off x="822960" y="3310200"/>
-            <a:ext cx="8776800" cy="821520"/>
+            <a:ext cx="8776440" cy="821160"/>
           </a:xfrm>
           <a:prstGeom prst="rect">
             <a:avLst/>
@@ -5598,7 +5598,7 @@
         <p:spPr>
           <a:xfrm>
             <a:off x="822960" y="4343400"/>
-            <a:ext cx="81000" cy="547200"/>
+            <a:ext cx="80640" cy="546840"/>
           </a:xfrm>
           <a:prstGeom prst="roundRect">
             <a:avLst>
@@ -5646,7 +5646,7 @@
         <p:spPr>
           <a:xfrm>
             <a:off x="1051560" y="4343400"/>
-            <a:ext cx="7313760" cy="547200"/>
+            <a:ext cx="7313400" cy="546840"/>
           </a:xfrm>
           <a:prstGeom prst="rect">
             <a:avLst/>
@@ -5703,7 +5703,7 @@
         <p:spPr>
           <a:xfrm>
             <a:off x="822960" y="6210360"/>
-            <a:ext cx="9599760" cy="364320"/>
+            <a:ext cx="9599400" cy="363960"/>
           </a:xfrm>
           <a:prstGeom prst="rect">
             <a:avLst/>
@@ -5770,7 +5770,7 @@
         <p:spPr>
           <a:xfrm>
             <a:off x="10223640" y="3238560"/>
-            <a:ext cx="379440" cy="379440"/>
+            <a:ext cx="379080" cy="379080"/>
           </a:xfrm>
           <a:prstGeom prst="rect">
             <a:avLst/>
@@ -6149,7 +6149,7 @@
         <p:spPr>
           <a:xfrm>
             <a:off x="-368280" y="-368280"/>
-            <a:ext cx="735480" cy="735480"/>
+            <a:ext cx="735120" cy="735120"/>
           </a:xfrm>
           <a:prstGeom prst="ellipse">
             <a:avLst/>
@@ -6196,7 +6196,7 @@
         <p:spPr>
           <a:xfrm>
             <a:off x="11823840" y="-368280"/>
-            <a:ext cx="735480" cy="735480"/>
+            <a:ext cx="735120" cy="735120"/>
           </a:xfrm>
           <a:prstGeom prst="ellipse">
             <a:avLst/>
@@ -6243,7 +6243,7 @@
         <p:spPr>
           <a:xfrm>
             <a:off x="-368280" y="6489720"/>
-            <a:ext cx="735480" cy="735480"/>
+            <a:ext cx="735120" cy="735120"/>
           </a:xfrm>
           <a:prstGeom prst="ellipse">
             <a:avLst/>
@@ -6290,7 +6290,7 @@
         <p:spPr>
           <a:xfrm>
             <a:off x="11823840" y="6489720"/>
-            <a:ext cx="735480" cy="735480"/>
+            <a:ext cx="735120" cy="735120"/>
           </a:xfrm>
           <a:prstGeom prst="ellipse">
             <a:avLst/>
@@ -6337,7 +6337,7 @@
         <p:spPr>
           <a:xfrm>
             <a:off x="825480" y="787320"/>
-            <a:ext cx="6348960" cy="316440"/>
+            <a:ext cx="6348600" cy="316080"/>
           </a:xfrm>
           <a:prstGeom prst="rect">
             <a:avLst/>
@@ -6364,7 +6364,7 @@
               </a:lnSpc>
             </a:pPr>
             <a:r>
-              <a:rPr b="1" lang="en-US" sz="1400" spc="194" strike="noStrike">
+              <a:rPr b="1" lang="en-US" sz="1400" spc="191" strike="noStrike">
                 <a:solidFill>
                   <a:srgbClr val="e8a33d"/>
                 </a:solidFill>
@@ -6391,7 +6391,7 @@
         <p:spPr>
           <a:xfrm>
             <a:off x="825480" y="1168560"/>
-            <a:ext cx="10540080" cy="735480"/>
+            <a:ext cx="10539720" cy="735120"/>
           </a:xfrm>
           <a:prstGeom prst="rect">
             <a:avLst/>
@@ -6445,7 +6445,7 @@
         <p:spPr>
           <a:xfrm>
             <a:off x="825480" y="1930320"/>
-            <a:ext cx="10540080" cy="354600"/>
+            <a:ext cx="10539720" cy="354240"/>
           </a:xfrm>
           <a:prstGeom prst="rect">
             <a:avLst/>
@@ -6499,7 +6499,7 @@
         <p:spPr>
           <a:xfrm>
             <a:off x="825480" y="2692440"/>
-            <a:ext cx="3250080" cy="1497600"/>
+            <a:ext cx="3249720" cy="1497240"/>
           </a:xfrm>
           <a:prstGeom prst="roundRect">
             <a:avLst>
@@ -6583,7 +6583,7 @@
         <p:spPr>
           <a:xfrm>
             <a:off x="825480" y="4622760"/>
-            <a:ext cx="3250080" cy="1269000"/>
+            <a:ext cx="3249720" cy="1268640"/>
           </a:xfrm>
           <a:prstGeom prst="roundRect">
             <a:avLst>
@@ -6652,7 +6652,7 @@
         <p:spPr>
           <a:xfrm>
             <a:off x="4470480" y="2692440"/>
-            <a:ext cx="3250080" cy="1497600"/>
+            <a:ext cx="3249720" cy="1497240"/>
           </a:xfrm>
           <a:prstGeom prst="roundRect">
             <a:avLst>
@@ -6736,7 +6736,7 @@
         <p:spPr>
           <a:xfrm>
             <a:off x="4470480" y="4622760"/>
-            <a:ext cx="3250080" cy="1269000"/>
+            <a:ext cx="3249720" cy="1268640"/>
           </a:xfrm>
           <a:prstGeom prst="roundRect">
             <a:avLst>
@@ -6805,7 +6805,7 @@
         <p:spPr>
           <a:xfrm>
             <a:off x="8115480" y="2692440"/>
-            <a:ext cx="3250080" cy="1497600"/>
+            <a:ext cx="3249720" cy="1497240"/>
           </a:xfrm>
           <a:prstGeom prst="roundRect">
             <a:avLst>
@@ -6889,7 +6889,7 @@
         <p:spPr>
           <a:xfrm>
             <a:off x="8115480" y="4622760"/>
-            <a:ext cx="3250080" cy="1269000"/>
+            <a:ext cx="3249720" cy="1268640"/>
           </a:xfrm>
           <a:prstGeom prst="roundRect">
             <a:avLst>
@@ -6958,7 +6958,7 @@
         <p:spPr>
           <a:xfrm>
             <a:off x="11368800" y="6400800"/>
-            <a:ext cx="547200" cy="272880"/>
+            <a:ext cx="546840" cy="272520"/>
           </a:xfrm>
           <a:prstGeom prst="rect">
             <a:avLst/>
@@ -7320,7 +7320,7 @@
         <p:spPr>
           <a:xfrm>
             <a:off x="697320" y="468720"/>
-            <a:ext cx="753120" cy="753120"/>
+            <a:ext cx="752760" cy="752760"/>
           </a:xfrm>
           <a:prstGeom prst="ellipse">
             <a:avLst/>
@@ -7368,7 +7368,7 @@
         <p:spPr>
           <a:xfrm>
             <a:off x="822960" y="594360"/>
-            <a:ext cx="501480" cy="501480"/>
+            <a:ext cx="501120" cy="501120"/>
           </a:xfrm>
           <a:prstGeom prst="ellipse">
             <a:avLst/>
@@ -7418,7 +7418,7 @@
         <p:spPr>
           <a:xfrm>
             <a:off x="969120" y="740520"/>
-            <a:ext cx="208800" cy="208800"/>
+            <a:ext cx="208440" cy="208440"/>
           </a:xfrm>
           <a:prstGeom prst="rect">
             <a:avLst/>
@@ -7437,7 +7437,7 @@
         <p:spPr>
           <a:xfrm>
             <a:off x="1481400" y="713160"/>
-            <a:ext cx="4277880" cy="272880"/>
+            <a:ext cx="4277520" cy="272520"/>
           </a:xfrm>
           <a:prstGeom prst="rect">
             <a:avLst/>
@@ -7467,7 +7467,7 @@
               </a:tabLst>
             </a:pPr>
             <a:r>
-              <a:rPr b="1" lang="en-US" sz="1400" spc="194" strike="noStrike">
+              <a:rPr b="1" lang="en-US" sz="1400" spc="191" strike="noStrike">
                 <a:solidFill>
                   <a:srgbClr val="0f1b3d"/>
                 </a:solidFill>
@@ -7494,7 +7494,7 @@
         <p:spPr>
           <a:xfrm>
             <a:off x="822960" y="1188720"/>
-            <a:ext cx="4936320" cy="775800"/>
+            <a:ext cx="4935960" cy="775440"/>
           </a:xfrm>
           <a:prstGeom prst="rect">
             <a:avLst/>
@@ -7551,7 +7551,7 @@
         <p:spPr>
           <a:xfrm>
             <a:off x="822960" y="2057400"/>
-            <a:ext cx="4936320" cy="894600"/>
+            <a:ext cx="4935960" cy="894240"/>
           </a:xfrm>
           <a:prstGeom prst="roundRect">
             <a:avLst>
@@ -7599,7 +7599,7 @@
         <p:spPr>
           <a:xfrm>
             <a:off x="1024200" y="2148840"/>
-            <a:ext cx="4533840" cy="227160"/>
+            <a:ext cx="4533480" cy="226800"/>
           </a:xfrm>
           <a:prstGeom prst="rect">
             <a:avLst/>
@@ -7629,7 +7629,7 @@
               </a:tabLst>
             </a:pPr>
             <a:r>
-              <a:rPr b="1" lang="en-US" sz="1200" spc="92" strike="noStrike">
+              <a:rPr b="1" lang="en-US" sz="1200" spc="89" strike="noStrike">
                 <a:solidFill>
                   <a:srgbClr val="e8a33d"/>
                 </a:solidFill>
@@ -7656,7 +7656,7 @@
         <p:spPr>
           <a:xfrm>
             <a:off x="1024200" y="2377440"/>
-            <a:ext cx="4533840" cy="528840"/>
+            <a:ext cx="4533480" cy="528480"/>
           </a:xfrm>
           <a:prstGeom prst="rect">
             <a:avLst/>
@@ -7713,7 +7713,7 @@
         <p:spPr>
           <a:xfrm>
             <a:off x="822960" y="3154680"/>
-            <a:ext cx="4936320" cy="419040"/>
+            <a:ext cx="4935960" cy="418680"/>
           </a:xfrm>
           <a:prstGeom prst="roundRect">
             <a:avLst>
@@ -7765,7 +7765,7 @@
         <p:spPr>
           <a:xfrm>
             <a:off x="969120" y="3255120"/>
-            <a:ext cx="218160" cy="218160"/>
+            <a:ext cx="217800" cy="217800"/>
           </a:xfrm>
           <a:prstGeom prst="rect">
             <a:avLst/>
@@ -7784,7 +7784,7 @@
         <p:spPr>
           <a:xfrm>
             <a:off x="1280160" y="3154680"/>
-            <a:ext cx="4387680" cy="419040"/>
+            <a:ext cx="4387320" cy="418680"/>
           </a:xfrm>
           <a:prstGeom prst="rect">
             <a:avLst/>
@@ -7841,7 +7841,7 @@
         <p:spPr>
           <a:xfrm>
             <a:off x="1152000" y="3822120"/>
-            <a:ext cx="4607280" cy="528840"/>
+            <a:ext cx="4606920" cy="528480"/>
           </a:xfrm>
           <a:prstGeom prst="rect">
             <a:avLst/>
@@ -7898,7 +7898,7 @@
         <p:spPr>
           <a:xfrm>
             <a:off x="1152000" y="4535280"/>
-            <a:ext cx="4607280" cy="528840"/>
+            <a:ext cx="4606920" cy="528480"/>
           </a:xfrm>
           <a:prstGeom prst="rect">
             <a:avLst/>
@@ -7955,7 +7955,7 @@
         <p:spPr>
           <a:xfrm>
             <a:off x="1152000" y="5248800"/>
-            <a:ext cx="4607280" cy="528840"/>
+            <a:ext cx="4606920" cy="528480"/>
           </a:xfrm>
           <a:prstGeom prst="rect">
             <a:avLst/>
@@ -8012,7 +8012,7 @@
         <p:spPr>
           <a:xfrm>
             <a:off x="6217920" y="594360"/>
-            <a:ext cx="5146560" cy="5622120"/>
+            <a:ext cx="5146200" cy="5621760"/>
           </a:xfrm>
           <a:prstGeom prst="roundRect">
             <a:avLst>
@@ -8067,7 +8067,7 @@
         <p:spPr>
           <a:xfrm>
             <a:off x="6537960" y="822960"/>
-            <a:ext cx="4506480" cy="364320"/>
+            <a:ext cx="4506120" cy="363960"/>
           </a:xfrm>
           <a:prstGeom prst="rect">
             <a:avLst/>
@@ -8124,7 +8124,7 @@
         <p:spPr>
           <a:xfrm>
             <a:off x="6537960" y="5029200"/>
-            <a:ext cx="4506480" cy="958680"/>
+            <a:ext cx="4506120" cy="958320"/>
           </a:xfrm>
           <a:prstGeom prst="rect">
             <a:avLst/>
@@ -8181,7 +8181,7 @@
         <p:spPr>
           <a:xfrm>
             <a:off x="11368800" y="6400800"/>
-            <a:ext cx="547200" cy="272880"/>
+            <a:ext cx="546840" cy="272520"/>
           </a:xfrm>
           <a:prstGeom prst="rect">
             <a:avLst/>
@@ -8238,7 +8238,7 @@
         <p:spPr>
           <a:xfrm>
             <a:off x="1152000" y="5820120"/>
-            <a:ext cx="5398920" cy="502920"/>
+            <a:ext cx="5398560" cy="502920"/>
           </a:xfrm>
           <a:prstGeom prst="rect">
             <a:avLst/>
@@ -8299,7 +8299,7 @@
         </p:nvGraphicFramePr>
         <p:xfrm>
           <a:off x="6537960" y="1280160"/>
-          <a:ext cx="4506480" cy="3564720"/>
+          <a:ext cx="4506120" cy="3564360"/>
         </p:xfrm>
         <a:graphic>
           <a:graphicData uri="http://schemas.openxmlformats.org/drawingml/2006/chart">
@@ -8320,7 +8320,7 @@
         <p:spPr>
           <a:xfrm>
             <a:off x="825480" y="3873600"/>
-            <a:ext cx="252720" cy="252720"/>
+            <a:ext cx="252360" cy="252360"/>
           </a:xfrm>
           <a:prstGeom prst="rect">
             <a:avLst/>
@@ -8343,7 +8343,7 @@
         <p:spPr>
           <a:xfrm>
             <a:off x="825480" y="4584600"/>
-            <a:ext cx="252720" cy="252720"/>
+            <a:ext cx="252360" cy="252360"/>
           </a:xfrm>
           <a:prstGeom prst="rect">
             <a:avLst/>
@@ -8366,7 +8366,7 @@
         <p:spPr>
           <a:xfrm>
             <a:off x="825480" y="5295960"/>
-            <a:ext cx="252720" cy="252720"/>
+            <a:ext cx="252360" cy="252360"/>
           </a:xfrm>
           <a:prstGeom prst="rect">
             <a:avLst/>
@@ -9279,7 +9279,7 @@
         <p:spPr>
           <a:xfrm>
             <a:off x="-365760" y="-365760"/>
-            <a:ext cx="730080" cy="730080"/>
+            <a:ext cx="729720" cy="729720"/>
           </a:xfrm>
           <a:prstGeom prst="ellipse">
             <a:avLst/>
@@ -9328,7 +9328,7 @@
         <p:spPr>
           <a:xfrm>
             <a:off x="11826000" y="-365760"/>
-            <a:ext cx="730080" cy="730080"/>
+            <a:ext cx="729720" cy="729720"/>
           </a:xfrm>
           <a:prstGeom prst="ellipse">
             <a:avLst/>
@@ -9377,7 +9377,7 @@
         <p:spPr>
           <a:xfrm>
             <a:off x="-365760" y="6492240"/>
-            <a:ext cx="730080" cy="730080"/>
+            <a:ext cx="729720" cy="729720"/>
           </a:xfrm>
           <a:prstGeom prst="ellipse">
             <a:avLst/>
@@ -9426,7 +9426,7 @@
         <p:spPr>
           <a:xfrm>
             <a:off x="11826000" y="6492240"/>
-            <a:ext cx="730080" cy="730080"/>
+            <a:ext cx="729720" cy="729720"/>
           </a:xfrm>
           <a:prstGeom prst="ellipse">
             <a:avLst/>
@@ -9475,7 +9475,7 @@
         <p:spPr>
           <a:xfrm>
             <a:off x="-1371600" y="6217920"/>
-            <a:ext cx="3656160" cy="3656160"/>
+            <a:ext cx="3655800" cy="3655800"/>
           </a:xfrm>
           <a:prstGeom prst="ellipse">
             <a:avLst/>
@@ -9528,7 +9528,7 @@
         <p:spPr>
           <a:xfrm>
             <a:off x="411480" y="8001000"/>
-            <a:ext cx="90000" cy="90000"/>
+            <a:ext cx="89640" cy="89640"/>
           </a:xfrm>
           <a:prstGeom prst="ellipse">
             <a:avLst/>
@@ -9576,7 +9576,7 @@
         <p:spPr>
           <a:xfrm>
             <a:off x="685800" y="502920"/>
-            <a:ext cx="821520" cy="821520"/>
+            <a:ext cx="821160" cy="821160"/>
           </a:xfrm>
           <a:prstGeom prst="ellipse">
             <a:avLst/>
@@ -9624,7 +9624,7 @@
         <p:spPr>
           <a:xfrm>
             <a:off x="822960" y="640080"/>
-            <a:ext cx="547200" cy="547200"/>
+            <a:ext cx="546840" cy="546840"/>
           </a:xfrm>
           <a:prstGeom prst="ellipse">
             <a:avLst/>
@@ -9670,7 +9670,7 @@
         <p:spPr>
           <a:xfrm>
             <a:off x="1536120" y="777240"/>
-            <a:ext cx="5484960" cy="272880"/>
+            <a:ext cx="5484600" cy="272520"/>
           </a:xfrm>
           <a:prstGeom prst="rect">
             <a:avLst/>
@@ -9700,7 +9700,7 @@
               </a:tabLst>
             </a:pPr>
             <a:r>
-              <a:rPr b="1" lang="en-US" sz="1400" spc="194" strike="noStrike">
+              <a:rPr b="1" lang="en-US" sz="1400" spc="191" strike="noStrike">
                 <a:solidFill>
                   <a:srgbClr val="e8a33d"/>
                 </a:solidFill>
@@ -9727,7 +9727,7 @@
         <p:spPr>
           <a:xfrm>
             <a:off x="1051560" y="2217600"/>
-            <a:ext cx="3061800" cy="1461240"/>
+            <a:ext cx="3061440" cy="1460880"/>
           </a:xfrm>
           <a:prstGeom prst="rect">
             <a:avLst/>
@@ -9784,7 +9784,7 @@
         <p:spPr>
           <a:xfrm>
             <a:off x="1051560" y="3719880"/>
-            <a:ext cx="3061800" cy="398880"/>
+            <a:ext cx="3061440" cy="398520"/>
           </a:xfrm>
           <a:prstGeom prst="rect">
             <a:avLst/>
@@ -9814,7 +9814,7 @@
               </a:tabLst>
             </a:pPr>
             <a:r>
-              <a:rPr b="1" lang="en-US" sz="2000" spc="194" strike="noStrike">
+              <a:rPr b="1" lang="en-US" sz="2000" spc="191" strike="noStrike">
                 <a:solidFill>
                   <a:srgbClr val="e8a33d"/>
                 </a:solidFill>
@@ -9841,7 +9841,7 @@
         <p:spPr>
           <a:xfrm>
             <a:off x="1051560" y="5156280"/>
-            <a:ext cx="144720" cy="144720"/>
+            <a:ext cx="144360" cy="144360"/>
           </a:xfrm>
           <a:prstGeom prst="ellipse">
             <a:avLst/>
@@ -9887,7 +9887,7 @@
         <p:spPr>
           <a:xfrm>
             <a:off x="1298520" y="5110560"/>
-            <a:ext cx="4062600" cy="455760"/>
+            <a:ext cx="4062240" cy="455400"/>
           </a:xfrm>
           <a:prstGeom prst="rect">
             <a:avLst/>
@@ -9944,7 +9944,7 @@
         <p:spPr>
           <a:xfrm>
             <a:off x="1051560" y="5664240"/>
-            <a:ext cx="144720" cy="144720"/>
+            <a:ext cx="144360" cy="144360"/>
           </a:xfrm>
           <a:prstGeom prst="ellipse">
             <a:avLst/>
@@ -9993,7 +9993,7 @@
         <p:spPr>
           <a:xfrm>
             <a:off x="1298520" y="5618520"/>
-            <a:ext cx="4062600" cy="455760"/>
+            <a:ext cx="4062240" cy="455400"/>
           </a:xfrm>
           <a:prstGeom prst="rect">
             <a:avLst/>
@@ -10050,7 +10050,7 @@
         <p:spPr>
           <a:xfrm>
             <a:off x="5440680" y="777240"/>
-            <a:ext cx="5942160" cy="5393520"/>
+            <a:ext cx="5941800" cy="5393160"/>
           </a:xfrm>
           <a:prstGeom prst="roundRect">
             <a:avLst>
@@ -10098,7 +10098,7 @@
         <p:spPr>
           <a:xfrm>
             <a:off x="5760720" y="1005840"/>
-            <a:ext cx="5302080" cy="455760"/>
+            <a:ext cx="5301720" cy="455400"/>
           </a:xfrm>
           <a:prstGeom prst="rect">
             <a:avLst/>
@@ -10159,7 +10159,7 @@
         <p:spPr>
           <a:xfrm>
             <a:off x="5740560" y="1816200"/>
-            <a:ext cx="252720" cy="252720"/>
+            <a:ext cx="252360" cy="252360"/>
           </a:xfrm>
           <a:prstGeom prst="rect">
             <a:avLst/>
@@ -10178,7 +10178,7 @@
         <p:spPr>
           <a:xfrm>
             <a:off x="6089760" y="1752480"/>
-            <a:ext cx="4973040" cy="775800"/>
+            <a:ext cx="4972680" cy="775440"/>
           </a:xfrm>
           <a:prstGeom prst="rect">
             <a:avLst/>
@@ -10239,7 +10239,7 @@
         <p:spPr>
           <a:xfrm>
             <a:off x="5740560" y="2882880"/>
-            <a:ext cx="252720" cy="252720"/>
+            <a:ext cx="252360" cy="252360"/>
           </a:xfrm>
           <a:prstGeom prst="rect">
             <a:avLst/>
@@ -10258,7 +10258,7 @@
         <p:spPr>
           <a:xfrm>
             <a:off x="6089760" y="2819520"/>
-            <a:ext cx="4973040" cy="775800"/>
+            <a:ext cx="4972680" cy="775440"/>
           </a:xfrm>
           <a:prstGeom prst="rect">
             <a:avLst/>
@@ -10319,7 +10319,7 @@
         <p:spPr>
           <a:xfrm>
             <a:off x="5740560" y="3949560"/>
-            <a:ext cx="252720" cy="252720"/>
+            <a:ext cx="252360" cy="252360"/>
           </a:xfrm>
           <a:prstGeom prst="rect">
             <a:avLst/>
@@ -10338,7 +10338,7 @@
         <p:spPr>
           <a:xfrm>
             <a:off x="6089760" y="3886200"/>
-            <a:ext cx="4973040" cy="775800"/>
+            <a:ext cx="4972680" cy="775440"/>
           </a:xfrm>
           <a:prstGeom prst="rect">
             <a:avLst/>
@@ -10399,7 +10399,7 @@
         <p:spPr>
           <a:xfrm>
             <a:off x="5740560" y="5016600"/>
-            <a:ext cx="252720" cy="252720"/>
+            <a:ext cx="252360" cy="252360"/>
           </a:xfrm>
           <a:prstGeom prst="rect">
             <a:avLst/>
@@ -10418,7 +10418,7 @@
         <p:spPr>
           <a:xfrm>
             <a:off x="6089760" y="4952880"/>
-            <a:ext cx="4973040" cy="775800"/>
+            <a:ext cx="4972680" cy="775440"/>
           </a:xfrm>
           <a:prstGeom prst="rect">
             <a:avLst/>
@@ -10475,7 +10475,7 @@
         <p:spPr>
           <a:xfrm>
             <a:off x="11368800" y="6400800"/>
-            <a:ext cx="547200" cy="272880"/>
+            <a:ext cx="546840" cy="272520"/>
           </a:xfrm>
           <a:prstGeom prst="rect">
             <a:avLst/>
@@ -10542,7 +10542,7 @@
         <p:spPr>
           <a:xfrm>
             <a:off x="900360" y="717480"/>
-            <a:ext cx="392400" cy="392400"/>
+            <a:ext cx="392040" cy="392040"/>
           </a:xfrm>
           <a:prstGeom prst="rect">
             <a:avLst/>
@@ -11302,7 +11302,7 @@
         <p:spPr>
           <a:xfrm>
             <a:off x="822960" y="594360"/>
-            <a:ext cx="5484960" cy="318600"/>
+            <a:ext cx="5484600" cy="318240"/>
           </a:xfrm>
           <a:prstGeom prst="rect">
             <a:avLst/>
@@ -11332,7 +11332,7 @@
               </a:tabLst>
             </a:pPr>
             <a:r>
-              <a:rPr b="1" lang="en-US" sz="1400" spc="194" strike="noStrike">
+              <a:rPr b="1" lang="en-US" sz="1400" spc="191" strike="noStrike">
                 <a:solidFill>
                   <a:srgbClr val="1f7a4d"/>
                 </a:solidFill>
@@ -11359,7 +11359,7 @@
         <p:spPr>
           <a:xfrm>
             <a:off x="777240" y="896040"/>
-            <a:ext cx="9142560" cy="730080"/>
+            <a:ext cx="9142200" cy="729720"/>
           </a:xfrm>
           <a:prstGeom prst="rect">
             <a:avLst/>
@@ -11416,7 +11416,7 @@
         <p:spPr>
           <a:xfrm>
             <a:off x="822960" y="1645920"/>
-            <a:ext cx="10331280" cy="775800"/>
+            <a:ext cx="10330920" cy="775440"/>
           </a:xfrm>
           <a:prstGeom prst="rect">
             <a:avLst/>
@@ -11473,7 +11473,7 @@
         <p:spPr>
           <a:xfrm>
             <a:off x="822960" y="2697480"/>
-            <a:ext cx="3381840" cy="2330280"/>
+            <a:ext cx="3381480" cy="2329920"/>
           </a:xfrm>
           <a:prstGeom prst="roundRect">
             <a:avLst>
@@ -11531,7 +11531,7 @@
         <p:spPr>
           <a:xfrm>
             <a:off x="960120" y="2834640"/>
-            <a:ext cx="711720" cy="711720"/>
+            <a:ext cx="711360" cy="711360"/>
           </a:xfrm>
           <a:prstGeom prst="ellipse">
             <a:avLst/>
@@ -11579,7 +11579,7 @@
         <p:spPr>
           <a:xfrm>
             <a:off x="1078920" y="2953440"/>
-            <a:ext cx="474120" cy="474120"/>
+            <a:ext cx="473760" cy="473760"/>
           </a:xfrm>
           <a:prstGeom prst="ellipse">
             <a:avLst/>
@@ -11629,7 +11629,7 @@
         <p:spPr>
           <a:xfrm>
             <a:off x="1225440" y="3099960"/>
-            <a:ext cx="181440" cy="181440"/>
+            <a:ext cx="181080" cy="181080"/>
           </a:xfrm>
           <a:prstGeom prst="rect">
             <a:avLst/>
@@ -11648,7 +11648,7 @@
         <p:spPr>
           <a:xfrm>
             <a:off x="1078920" y="3008520"/>
-            <a:ext cx="2558880" cy="218160"/>
+            <a:ext cx="2558520" cy="217800"/>
           </a:xfrm>
           <a:prstGeom prst="rect">
             <a:avLst/>
@@ -11678,7 +11678,7 @@
               </a:tabLst>
             </a:pPr>
             <a:r>
-              <a:rPr b="1" lang="en-US" sz="1100" spc="92" strike="noStrike">
+              <a:rPr b="1" lang="en-US" sz="1100" spc="89" strike="noStrike">
                 <a:solidFill>
                   <a:srgbClr val="b8790c"/>
                 </a:solidFill>
@@ -11705,7 +11705,7 @@
         <p:spPr>
           <a:xfrm>
             <a:off x="1078920" y="3557160"/>
-            <a:ext cx="2869920" cy="364320"/>
+            <a:ext cx="2869560" cy="363960"/>
           </a:xfrm>
           <a:prstGeom prst="rect">
             <a:avLst/>
@@ -11762,7 +11762,7 @@
         <p:spPr>
           <a:xfrm>
             <a:off x="1078920" y="3922920"/>
-            <a:ext cx="2869920" cy="1004400"/>
+            <a:ext cx="2869560" cy="1004040"/>
           </a:xfrm>
           <a:prstGeom prst="rect">
             <a:avLst/>
@@ -11819,7 +11819,7 @@
         <p:spPr>
           <a:xfrm>
             <a:off x="4434840" y="2697480"/>
-            <a:ext cx="3381840" cy="2330280"/>
+            <a:ext cx="3381480" cy="2329920"/>
           </a:xfrm>
           <a:prstGeom prst="roundRect">
             <a:avLst>
@@ -11874,7 +11874,7 @@
         <p:spPr>
           <a:xfrm>
             <a:off x="4572000" y="2834640"/>
-            <a:ext cx="711720" cy="711720"/>
+            <a:ext cx="711360" cy="711360"/>
           </a:xfrm>
           <a:prstGeom prst="ellipse">
             <a:avLst/>
@@ -11922,7 +11922,7 @@
         <p:spPr>
           <a:xfrm>
             <a:off x="4690800" y="2953440"/>
-            <a:ext cx="474120" cy="474120"/>
+            <a:ext cx="473760" cy="473760"/>
           </a:xfrm>
           <a:prstGeom prst="ellipse">
             <a:avLst/>
@@ -11972,7 +11972,7 @@
         <p:spPr>
           <a:xfrm>
             <a:off x="4837320" y="3099960"/>
-            <a:ext cx="181440" cy="181440"/>
+            <a:ext cx="181080" cy="181080"/>
           </a:xfrm>
           <a:prstGeom prst="rect">
             <a:avLst/>
@@ -11991,7 +11991,7 @@
         <p:spPr>
           <a:xfrm>
             <a:off x="4690800" y="3557160"/>
-            <a:ext cx="2869920" cy="364320"/>
+            <a:ext cx="2869560" cy="363960"/>
           </a:xfrm>
           <a:prstGeom prst="rect">
             <a:avLst/>
@@ -12048,7 +12048,7 @@
         <p:spPr>
           <a:xfrm>
             <a:off x="4690800" y="3922920"/>
-            <a:ext cx="2869920" cy="1004400"/>
+            <a:ext cx="2869560" cy="1004040"/>
           </a:xfrm>
           <a:prstGeom prst="rect">
             <a:avLst/>
@@ -12105,7 +12105,7 @@
         <p:spPr>
           <a:xfrm>
             <a:off x="8046720" y="2697480"/>
-            <a:ext cx="3381840" cy="2330280"/>
+            <a:ext cx="3381480" cy="2329920"/>
           </a:xfrm>
           <a:prstGeom prst="roundRect">
             <a:avLst>
@@ -12160,7 +12160,7 @@
         <p:spPr>
           <a:xfrm>
             <a:off x="8183880" y="2834640"/>
-            <a:ext cx="711720" cy="711720"/>
+            <a:ext cx="711360" cy="711360"/>
           </a:xfrm>
           <a:prstGeom prst="ellipse">
             <a:avLst/>
@@ -12208,7 +12208,7 @@
         <p:spPr>
           <a:xfrm>
             <a:off x="8302680" y="2953440"/>
-            <a:ext cx="474120" cy="474120"/>
+            <a:ext cx="473760" cy="473760"/>
           </a:xfrm>
           <a:prstGeom prst="ellipse">
             <a:avLst/>
@@ -12258,7 +12258,7 @@
         <p:spPr>
           <a:xfrm>
             <a:off x="8449200" y="3099960"/>
-            <a:ext cx="181440" cy="181440"/>
+            <a:ext cx="181080" cy="181080"/>
           </a:xfrm>
           <a:prstGeom prst="rect">
             <a:avLst/>
@@ -12277,7 +12277,7 @@
         <p:spPr>
           <a:xfrm>
             <a:off x="8302680" y="3557160"/>
-            <a:ext cx="2869920" cy="364320"/>
+            <a:ext cx="2869560" cy="363960"/>
           </a:xfrm>
           <a:prstGeom prst="rect">
             <a:avLst/>
@@ -12334,7 +12334,7 @@
         <p:spPr>
           <a:xfrm>
             <a:off x="8302680" y="3922920"/>
-            <a:ext cx="2869920" cy="1004400"/>
+            <a:ext cx="2869560" cy="1004040"/>
           </a:xfrm>
           <a:prstGeom prst="rect">
             <a:avLst/>
@@ -12391,7 +12391,7 @@
         <p:spPr>
           <a:xfrm>
             <a:off x="822960" y="5349240"/>
-            <a:ext cx="10514160" cy="1050120"/>
+            <a:ext cx="10513800" cy="1049760"/>
           </a:xfrm>
           <a:prstGeom prst="roundRect">
             <a:avLst>
@@ -12439,7 +12439,7 @@
         <p:spPr>
           <a:xfrm>
             <a:off x="1051560" y="5349240"/>
-            <a:ext cx="10056960" cy="1050120"/>
+            <a:ext cx="10056600" cy="1049760"/>
           </a:xfrm>
           <a:prstGeom prst="rect">
             <a:avLst/>
@@ -12506,7 +12506,7 @@
         <p:spPr>
           <a:xfrm>
             <a:off x="11368800" y="6400800"/>
-            <a:ext cx="547200" cy="272880"/>
+            <a:ext cx="546840" cy="272520"/>
           </a:xfrm>
           <a:prstGeom prst="rect">
             <a:avLst/>
@@ -14341,7 +14341,7 @@
         <p:spPr>
           <a:xfrm>
             <a:off x="822960" y="594360"/>
-            <a:ext cx="5484960" cy="318600"/>
+            <a:ext cx="5484600" cy="318240"/>
           </a:xfrm>
           <a:prstGeom prst="rect">
             <a:avLst/>
@@ -14371,7 +14371,7 @@
               </a:tabLst>
             </a:pPr>
             <a:r>
-              <a:rPr b="1" lang="en-US" sz="1400" spc="194" strike="noStrike">
+              <a:rPr b="1" lang="en-US" sz="1400" spc="191" strike="noStrike">
                 <a:solidFill>
                   <a:srgbClr val="1f7a4d"/>
                 </a:solidFill>
@@ -14398,7 +14398,7 @@
         <p:spPr>
           <a:xfrm>
             <a:off x="777240" y="896040"/>
-            <a:ext cx="9599760" cy="730080"/>
+            <a:ext cx="9599400" cy="729720"/>
           </a:xfrm>
           <a:prstGeom prst="rect">
             <a:avLst/>
@@ -14455,7 +14455,7 @@
         <p:spPr>
           <a:xfrm>
             <a:off x="822960" y="2011680"/>
-            <a:ext cx="10514160" cy="1187280"/>
+            <a:ext cx="10513800" cy="1186920"/>
           </a:xfrm>
           <a:prstGeom prst="roundRect">
             <a:avLst>
@@ -14510,7 +14510,7 @@
         <p:spPr>
           <a:xfrm>
             <a:off x="937440" y="2180880"/>
-            <a:ext cx="848880" cy="848880"/>
+            <a:ext cx="848520" cy="848520"/>
           </a:xfrm>
           <a:prstGeom prst="ellipse">
             <a:avLst/>
@@ -14558,7 +14558,7 @@
         <p:spPr>
           <a:xfrm>
             <a:off x="1078920" y="2322720"/>
-            <a:ext cx="565560" cy="565560"/>
+            <a:ext cx="565200" cy="565200"/>
           </a:xfrm>
           <a:prstGeom prst="ellipse">
             <a:avLst/>
@@ -14604,7 +14604,7 @@
         <p:spPr>
           <a:xfrm>
             <a:off x="1920240" y="2194560"/>
-            <a:ext cx="2741760" cy="821520"/>
+            <a:ext cx="2741400" cy="821160"/>
           </a:xfrm>
           <a:prstGeom prst="rect">
             <a:avLst/>
@@ -14661,7 +14661,7 @@
         <p:spPr>
           <a:xfrm>
             <a:off x="4317840" y="2148840"/>
-            <a:ext cx="6793200" cy="912960"/>
+            <a:ext cx="6792840" cy="912600"/>
           </a:xfrm>
           <a:prstGeom prst="rect">
             <a:avLst/>
@@ -14718,7 +14718,7 @@
         <p:spPr>
           <a:xfrm>
             <a:off x="822960" y="3429000"/>
-            <a:ext cx="10514160" cy="1187280"/>
+            <a:ext cx="10513800" cy="1186920"/>
           </a:xfrm>
           <a:prstGeom prst="roundRect">
             <a:avLst>
@@ -14773,7 +14773,7 @@
         <p:spPr>
           <a:xfrm>
             <a:off x="937440" y="3598200"/>
-            <a:ext cx="848880" cy="848880"/>
+            <a:ext cx="848520" cy="848520"/>
           </a:xfrm>
           <a:prstGeom prst="ellipse">
             <a:avLst/>
@@ -14821,7 +14821,7 @@
         <p:spPr>
           <a:xfrm>
             <a:off x="1078920" y="3740040"/>
-            <a:ext cx="565560" cy="565560"/>
+            <a:ext cx="565200" cy="565200"/>
           </a:xfrm>
           <a:prstGeom prst="ellipse">
             <a:avLst/>
@@ -14871,7 +14871,7 @@
         <p:spPr>
           <a:xfrm>
             <a:off x="1225440" y="3886200"/>
-            <a:ext cx="272880" cy="272880"/>
+            <a:ext cx="272520" cy="272520"/>
           </a:xfrm>
           <a:prstGeom prst="rect">
             <a:avLst/>
@@ -14890,7 +14890,7 @@
         <p:spPr>
           <a:xfrm>
             <a:off x="1920240" y="3611880"/>
-            <a:ext cx="2741760" cy="821520"/>
+            <a:ext cx="2741400" cy="821160"/>
           </a:xfrm>
           <a:prstGeom prst="rect">
             <a:avLst/>
@@ -14947,7 +14947,7 @@
         <p:spPr>
           <a:xfrm>
             <a:off x="4317840" y="3566160"/>
-            <a:ext cx="6793200" cy="912960"/>
+            <a:ext cx="6792840" cy="912600"/>
           </a:xfrm>
           <a:prstGeom prst="rect">
             <a:avLst/>
@@ -15004,7 +15004,7 @@
         <p:spPr>
           <a:xfrm>
             <a:off x="822960" y="4846320"/>
-            <a:ext cx="10514160" cy="1187280"/>
+            <a:ext cx="10513800" cy="1186920"/>
           </a:xfrm>
           <a:prstGeom prst="roundRect">
             <a:avLst>
@@ -15059,7 +15059,7 @@
         <p:spPr>
           <a:xfrm>
             <a:off x="937440" y="5015520"/>
-            <a:ext cx="848880" cy="848880"/>
+            <a:ext cx="848520" cy="848520"/>
           </a:xfrm>
           <a:prstGeom prst="ellipse">
             <a:avLst/>
@@ -15107,7 +15107,7 @@
         <p:spPr>
           <a:xfrm>
             <a:off x="1078920" y="5157360"/>
-            <a:ext cx="565560" cy="565560"/>
+            <a:ext cx="565200" cy="565200"/>
           </a:xfrm>
           <a:prstGeom prst="ellipse">
             <a:avLst/>
@@ -15157,7 +15157,7 @@
         <p:spPr>
           <a:xfrm>
             <a:off x="1225440" y="5303520"/>
-            <a:ext cx="272880" cy="272880"/>
+            <a:ext cx="272520" cy="272520"/>
           </a:xfrm>
           <a:prstGeom prst="rect">
             <a:avLst/>
@@ -15176,7 +15176,7 @@
         <p:spPr>
           <a:xfrm>
             <a:off x="1920240" y="5029200"/>
-            <a:ext cx="2741760" cy="821520"/>
+            <a:ext cx="2741400" cy="821160"/>
           </a:xfrm>
           <a:prstGeom prst="rect">
             <a:avLst/>
@@ -15233,7 +15233,7 @@
         <p:spPr>
           <a:xfrm>
             <a:off x="4317840" y="4983480"/>
-            <a:ext cx="6793200" cy="912960"/>
+            <a:ext cx="6792840" cy="912600"/>
           </a:xfrm>
           <a:prstGeom prst="rect">
             <a:avLst/>
@@ -15290,7 +15290,7 @@
         <p:spPr>
           <a:xfrm>
             <a:off x="11368800" y="6400800"/>
-            <a:ext cx="547200" cy="272880"/>
+            <a:ext cx="546840" cy="272520"/>
           </a:xfrm>
           <a:prstGeom prst="rect">
             <a:avLst/>
@@ -15351,7 +15351,7 @@
         <p:spPr>
           <a:xfrm>
             <a:off x="1219320" y="2463840"/>
-            <a:ext cx="278280" cy="278280"/>
+            <a:ext cx="277920" cy="277920"/>
           </a:xfrm>
           <a:prstGeom prst="rect">
             <a:avLst/>
@@ -16116,7 +16116,7 @@
         <p:spPr>
           <a:xfrm>
             <a:off x="-365760" y="-365760"/>
-            <a:ext cx="730080" cy="730080"/>
+            <a:ext cx="729720" cy="729720"/>
           </a:xfrm>
           <a:prstGeom prst="ellipse">
             <a:avLst/>
@@ -16165,7 +16165,7 @@
         <p:spPr>
           <a:xfrm>
             <a:off x="11826000" y="-365760"/>
-            <a:ext cx="730080" cy="730080"/>
+            <a:ext cx="729720" cy="729720"/>
           </a:xfrm>
           <a:prstGeom prst="ellipse">
             <a:avLst/>
@@ -16214,7 +16214,7 @@
         <p:spPr>
           <a:xfrm>
             <a:off x="-365760" y="6492240"/>
-            <a:ext cx="730080" cy="730080"/>
+            <a:ext cx="729720" cy="729720"/>
           </a:xfrm>
           <a:prstGeom prst="ellipse">
             <a:avLst/>
@@ -16263,7 +16263,7 @@
         <p:spPr>
           <a:xfrm>
             <a:off x="11826000" y="6492240"/>
-            <a:ext cx="730080" cy="730080"/>
+            <a:ext cx="729720" cy="729720"/>
           </a:xfrm>
           <a:prstGeom prst="ellipse">
             <a:avLst/>
@@ -16312,7 +16312,7 @@
         <p:spPr>
           <a:xfrm>
             <a:off x="7863840" y="137160"/>
-            <a:ext cx="6582240" cy="6582240"/>
+            <a:ext cx="6581880" cy="6581880"/>
           </a:xfrm>
           <a:prstGeom prst="ellipse">
             <a:avLst/>
@@ -16365,7 +16365,7 @@
         <p:spPr>
           <a:xfrm>
             <a:off x="11109960" y="3383280"/>
-            <a:ext cx="90000" cy="90000"/>
+            <a:ext cx="89640" cy="89640"/>
           </a:xfrm>
           <a:prstGeom prst="ellipse">
             <a:avLst/>
@@ -16456,7 +16456,7 @@
         <p:spPr>
           <a:xfrm>
             <a:off x="822960" y="1737360"/>
-            <a:ext cx="5484960" cy="318600"/>
+            <a:ext cx="5484600" cy="318240"/>
           </a:xfrm>
           <a:prstGeom prst="rect">
             <a:avLst/>
@@ -16486,7 +16486,7 @@
               </a:tabLst>
             </a:pPr>
             <a:r>
-              <a:rPr b="1" lang="en-US" sz="1400" spc="194" strike="noStrike">
+              <a:rPr b="1" lang="en-US" sz="1400" spc="191" strike="noStrike">
                 <a:solidFill>
                   <a:srgbClr val="e8a33d"/>
                 </a:solidFill>
@@ -16513,7 +16513,7 @@
         <p:spPr>
           <a:xfrm>
             <a:off x="777240" y="2057400"/>
-            <a:ext cx="8228160" cy="1004400"/>
+            <a:ext cx="8227800" cy="1004040"/>
           </a:xfrm>
           <a:prstGeom prst="rect">
             <a:avLst/>
@@ -16570,7 +16570,7 @@
         <p:spPr>
           <a:xfrm>
             <a:off x="822960" y="3063240"/>
-            <a:ext cx="7496640" cy="730080"/>
+            <a:ext cx="7496280" cy="729720"/>
           </a:xfrm>
           <a:prstGeom prst="rect">
             <a:avLst/>
@@ -16629,7 +16629,7 @@
         <p:spPr>
           <a:xfrm>
             <a:off x="822960" y="4160520"/>
-            <a:ext cx="3930480" cy="684360"/>
+            <a:ext cx="3930120" cy="684000"/>
           </a:xfrm>
           <a:prstGeom prst="roundRect">
             <a:avLst>
@@ -16676,8 +16676,8 @@
         </p:nvSpPr>
         <p:spPr>
           <a:xfrm rot="5400000">
-            <a:off x="1299960" y="4402800"/>
-            <a:ext cx="199800" cy="199800"/>
+            <a:off x="1300320" y="4402800"/>
+            <a:ext cx="199440" cy="199440"/>
           </a:xfrm>
           <a:prstGeom prst="triangle">
             <a:avLst>
@@ -16727,7 +16727,7 @@
         <p:spPr>
           <a:xfrm>
             <a:off x="1691640" y="4160520"/>
-            <a:ext cx="2970360" cy="684360"/>
+            <a:ext cx="2970000" cy="684000"/>
           </a:xfrm>
           <a:prstGeom prst="rect">
             <a:avLst/>
@@ -16786,7 +16786,7 @@
         <p:spPr>
           <a:xfrm>
             <a:off x="822960" y="5129640"/>
-            <a:ext cx="90000" cy="90000"/>
+            <a:ext cx="89640" cy="89640"/>
           </a:xfrm>
           <a:prstGeom prst="ellipse">
             <a:avLst/>
@@ -16832,7 +16832,7 @@
         <p:spPr>
           <a:xfrm>
             <a:off x="1051560" y="5001840"/>
-            <a:ext cx="3656160" cy="318600"/>
+            <a:ext cx="3655800" cy="318240"/>
           </a:xfrm>
           <a:prstGeom prst="rect">
             <a:avLst/>
@@ -16889,7 +16889,7 @@
         <p:spPr>
           <a:xfrm>
             <a:off x="822960" y="5422320"/>
-            <a:ext cx="90000" cy="90000"/>
+            <a:ext cx="89640" cy="89640"/>
           </a:xfrm>
           <a:prstGeom prst="ellipse">
             <a:avLst/>
@@ -16935,7 +16935,7 @@
         <p:spPr>
           <a:xfrm>
             <a:off x="1051560" y="5294520"/>
-            <a:ext cx="3656160" cy="318600"/>
+            <a:ext cx="3655800" cy="318240"/>
           </a:xfrm>
           <a:prstGeom prst="rect">
             <a:avLst/>
@@ -16992,7 +16992,7 @@
         <p:spPr>
           <a:xfrm>
             <a:off x="822960" y="5715000"/>
-            <a:ext cx="90000" cy="90000"/>
+            <a:ext cx="89640" cy="89640"/>
           </a:xfrm>
           <a:prstGeom prst="ellipse">
             <a:avLst/>
@@ -17038,7 +17038,7 @@
         <p:spPr>
           <a:xfrm>
             <a:off x="1051560" y="5586840"/>
-            <a:ext cx="3656160" cy="318600"/>
+            <a:ext cx="3655800" cy="318240"/>
           </a:xfrm>
           <a:prstGeom prst="rect">
             <a:avLst/>
@@ -17095,7 +17095,7 @@
         <p:spPr>
           <a:xfrm>
             <a:off x="822960" y="6007680"/>
-            <a:ext cx="90000" cy="90000"/>
+            <a:ext cx="89640" cy="89640"/>
           </a:xfrm>
           <a:prstGeom prst="ellipse">
             <a:avLst/>
@@ -17141,7 +17141,7 @@
         <p:spPr>
           <a:xfrm>
             <a:off x="1051560" y="5879520"/>
-            <a:ext cx="3656160" cy="318600"/>
+            <a:ext cx="3655800" cy="318240"/>
           </a:xfrm>
           <a:prstGeom prst="rect">
             <a:avLst/>
@@ -17198,7 +17198,7 @@
         <p:spPr>
           <a:xfrm>
             <a:off x="822960" y="6300360"/>
-            <a:ext cx="90000" cy="90000"/>
+            <a:ext cx="89640" cy="89640"/>
           </a:xfrm>
           <a:prstGeom prst="ellipse">
             <a:avLst/>
@@ -17244,7 +17244,7 @@
         <p:spPr>
           <a:xfrm>
             <a:off x="1051560" y="6172200"/>
-            <a:ext cx="3656160" cy="318600"/>
+            <a:ext cx="3655800" cy="318240"/>
           </a:xfrm>
           <a:prstGeom prst="rect">
             <a:avLst/>
@@ -17301,7 +17301,7 @@
         <p:spPr>
           <a:xfrm>
             <a:off x="11368800" y="6400800"/>
-            <a:ext cx="547200" cy="272880"/>
+            <a:ext cx="546840" cy="272520"/>
           </a:xfrm>
           <a:prstGeom prst="rect">
             <a:avLst/>
@@ -18139,7 +18139,7 @@
         <p:spPr>
           <a:xfrm>
             <a:off x="762120" y="762120"/>
-            <a:ext cx="10666440" cy="5332680"/>
+            <a:ext cx="10666080" cy="5332320"/>
           </a:xfrm>
           <a:prstGeom prst="rect">
             <a:avLst/>
@@ -18227,7 +18227,7 @@
         <p:spPr>
           <a:xfrm>
             <a:off x="5207040" y="2540160"/>
-            <a:ext cx="1776600" cy="1776600"/>
+            <a:ext cx="1776240" cy="1776240"/>
           </a:xfrm>
           <a:prstGeom prst="ellipse">
             <a:avLst/>
@@ -18274,7 +18274,7 @@
         <p:spPr>
           <a:xfrm>
             <a:off x="6045120" y="3378240"/>
-            <a:ext cx="100080" cy="100080"/>
+            <a:ext cx="99720" cy="99720"/>
           </a:xfrm>
           <a:prstGeom prst="ellipse">
             <a:avLst/>
@@ -18323,7 +18323,7 @@
         <p:spPr>
           <a:xfrm>
             <a:off x="762120" y="1905120"/>
-            <a:ext cx="1522440" cy="3046680"/>
+            <a:ext cx="1522080" cy="3046320"/>
           </a:xfrm>
           <a:prstGeom prst="rect">
             <a:avLst/>
@@ -18370,7 +18370,7 @@
         <p:spPr>
           <a:xfrm>
             <a:off x="762120" y="2666880"/>
-            <a:ext cx="658800" cy="1522440"/>
+            <a:ext cx="658440" cy="1522080"/>
           </a:xfrm>
           <a:prstGeom prst="rect">
             <a:avLst/>
@@ -18417,7 +18417,7 @@
         <p:spPr>
           <a:xfrm>
             <a:off x="9906120" y="1905120"/>
-            <a:ext cx="1522440" cy="3046680"/>
+            <a:ext cx="1522080" cy="3046320"/>
           </a:xfrm>
           <a:prstGeom prst="rect">
             <a:avLst/>
@@ -18464,7 +18464,7 @@
         <p:spPr>
           <a:xfrm>
             <a:off x="10769760" y="2666880"/>
-            <a:ext cx="658800" cy="1522440"/>
+            <a:ext cx="658440" cy="1522080"/>
           </a:xfrm>
           <a:prstGeom prst="rect">
             <a:avLst/>
@@ -18511,7 +18511,7 @@
         <p:spPr>
           <a:xfrm>
             <a:off x="-365760" y="-365760"/>
-            <a:ext cx="730080" cy="730080"/>
+            <a:ext cx="729720" cy="729720"/>
           </a:xfrm>
           <a:prstGeom prst="ellipse">
             <a:avLst/>
@@ -18560,7 +18560,7 @@
         <p:spPr>
           <a:xfrm>
             <a:off x="11826000" y="-365760"/>
-            <a:ext cx="730080" cy="730080"/>
+            <a:ext cx="729720" cy="729720"/>
           </a:xfrm>
           <a:prstGeom prst="ellipse">
             <a:avLst/>
@@ -18609,7 +18609,7 @@
         <p:spPr>
           <a:xfrm>
             <a:off x="-365760" y="6492240"/>
-            <a:ext cx="730080" cy="730080"/>
+            <a:ext cx="729720" cy="729720"/>
           </a:xfrm>
           <a:prstGeom prst="ellipse">
             <a:avLst/>
@@ -18658,7 +18658,7 @@
         <p:spPr>
           <a:xfrm>
             <a:off x="11826000" y="6492240"/>
-            <a:ext cx="730080" cy="730080"/>
+            <a:ext cx="729720" cy="729720"/>
           </a:xfrm>
           <a:prstGeom prst="ellipse">
             <a:avLst/>
@@ -18707,7 +18707,7 @@
         <p:spPr>
           <a:xfrm>
             <a:off x="-3291840" y="-3291840"/>
-            <a:ext cx="4753440" cy="4753440"/>
+            <a:ext cx="4753080" cy="4753080"/>
           </a:xfrm>
           <a:prstGeom prst="ellipse">
             <a:avLst/>
@@ -18760,7 +18760,7 @@
         <p:spPr>
           <a:xfrm>
             <a:off x="-960120" y="-960120"/>
-            <a:ext cx="90000" cy="90000"/>
+            <a:ext cx="89640" cy="89640"/>
           </a:xfrm>
           <a:prstGeom prst="ellipse">
             <a:avLst/>
@@ -18808,7 +18808,7 @@
         <p:spPr>
           <a:xfrm>
             <a:off x="9784080" y="4480560"/>
-            <a:ext cx="6582240" cy="6582240"/>
+            <a:ext cx="6581880" cy="6581880"/>
           </a:xfrm>
           <a:prstGeom prst="ellipse">
             <a:avLst/>
@@ -18861,7 +18861,7 @@
         <p:spPr>
           <a:xfrm>
             <a:off x="13030200" y="7726680"/>
-            <a:ext cx="90000" cy="90000"/>
+            <a:ext cx="89640" cy="89640"/>
           </a:xfrm>
           <a:prstGeom prst="ellipse">
             <a:avLst/>
@@ -18909,7 +18909,7 @@
         <p:spPr>
           <a:xfrm>
             <a:off x="822960" y="2286000"/>
-            <a:ext cx="8228160" cy="1095840"/>
+            <a:ext cx="8227800" cy="1095480"/>
           </a:xfrm>
           <a:prstGeom prst="rect">
             <a:avLst/>
@@ -18966,7 +18966,7 @@
         <p:spPr>
           <a:xfrm>
             <a:off x="822960" y="3246120"/>
-            <a:ext cx="8228160" cy="547200"/>
+            <a:ext cx="8227800" cy="546840"/>
           </a:xfrm>
           <a:prstGeom prst="rect">
             <a:avLst/>
@@ -19027,7 +19027,7 @@
         <p:spPr>
           <a:xfrm>
             <a:off x="822960" y="4206240"/>
-            <a:ext cx="291240" cy="291240"/>
+            <a:ext cx="290880" cy="290880"/>
           </a:xfrm>
           <a:prstGeom prst="rect">
             <a:avLst/>
@@ -19048,7 +19048,7 @@
         <p:spPr>
           <a:xfrm>
             <a:off x="1234440" y="4206240"/>
-            <a:ext cx="7770960" cy="291240"/>
+            <a:ext cx="7770600" cy="290880"/>
           </a:xfrm>
           <a:prstGeom prst="rect">
             <a:avLst/>
@@ -19107,7 +19107,7 @@
         <p:spPr>
           <a:xfrm>
             <a:off x="11368800" y="6400800"/>
-            <a:ext cx="547200" cy="272880"/>
+            <a:ext cx="546840" cy="272520"/>
           </a:xfrm>
           <a:prstGeom prst="rect">
             <a:avLst/>
@@ -19174,7 +19174,7 @@
         <p:spPr>
           <a:xfrm>
             <a:off x="10452240" y="3238560"/>
-            <a:ext cx="379440" cy="379440"/>
+            <a:ext cx="379080" cy="379080"/>
           </a:xfrm>
           <a:prstGeom prst="rect">
             <a:avLst/>
@@ -19193,7 +19193,7 @@
         <p:spPr>
           <a:xfrm>
             <a:off x="822960" y="4648320"/>
-            <a:ext cx="9599760" cy="426960"/>
+            <a:ext cx="9599400" cy="426600"/>
           </a:xfrm>
           <a:prstGeom prst="rect">
             <a:avLst/>
@@ -19562,7 +19562,7 @@
         <p:spPr>
           <a:xfrm>
             <a:off x="822960" y="594360"/>
-            <a:ext cx="5484960" cy="318600"/>
+            <a:ext cx="5484600" cy="318240"/>
           </a:xfrm>
           <a:prstGeom prst="rect">
             <a:avLst/>
@@ -19592,7 +19592,7 @@
               </a:tabLst>
             </a:pPr>
             <a:r>
-              <a:rPr b="1" lang="en-US" sz="1400" spc="194" strike="noStrike">
+              <a:rPr b="1" lang="en-US" sz="1400" spc="191" strike="noStrike">
                 <a:solidFill>
                   <a:srgbClr val="1f7a4d"/>
                 </a:solidFill>
@@ -19619,7 +19619,7 @@
         <p:spPr>
           <a:xfrm>
             <a:off x="777240" y="896040"/>
-            <a:ext cx="7313760" cy="730080"/>
+            <a:ext cx="7313400" cy="729720"/>
           </a:xfrm>
           <a:prstGeom prst="rect">
             <a:avLst/>
@@ -19680,7 +19680,7 @@
         <p:spPr>
           <a:xfrm>
             <a:off x="822960" y="1917720"/>
-            <a:ext cx="309600" cy="309600"/>
+            <a:ext cx="309240" cy="309240"/>
           </a:xfrm>
           <a:prstGeom prst="rect">
             <a:avLst/>
@@ -19699,7 +19699,7 @@
         <p:spPr>
           <a:xfrm>
             <a:off x="1298520" y="1905120"/>
-            <a:ext cx="6033600" cy="364320"/>
+            <a:ext cx="6033240" cy="363960"/>
           </a:xfrm>
           <a:prstGeom prst="rect">
             <a:avLst/>
@@ -19760,7 +19760,7 @@
         <p:spPr>
           <a:xfrm>
             <a:off x="822960" y="2679840"/>
-            <a:ext cx="309600" cy="309600"/>
+            <a:ext cx="309240" cy="309240"/>
           </a:xfrm>
           <a:prstGeom prst="rect">
             <a:avLst/>
@@ -19779,7 +19779,7 @@
         <p:spPr>
           <a:xfrm>
             <a:off x="1298520" y="2666880"/>
-            <a:ext cx="6033600" cy="364320"/>
+            <a:ext cx="6033240" cy="363960"/>
           </a:xfrm>
           <a:prstGeom prst="rect">
             <a:avLst/>
@@ -19840,7 +19840,7 @@
         <p:spPr>
           <a:xfrm>
             <a:off x="822960" y="3441600"/>
-            <a:ext cx="309600" cy="309600"/>
+            <a:ext cx="309240" cy="309240"/>
           </a:xfrm>
           <a:prstGeom prst="rect">
             <a:avLst/>
@@ -19859,7 +19859,7 @@
         <p:spPr>
           <a:xfrm>
             <a:off x="1298520" y="3429000"/>
-            <a:ext cx="6033600" cy="364320"/>
+            <a:ext cx="6033240" cy="363960"/>
           </a:xfrm>
           <a:prstGeom prst="rect">
             <a:avLst/>
@@ -19920,7 +19920,7 @@
         <p:spPr>
           <a:xfrm>
             <a:off x="822960" y="4203720"/>
-            <a:ext cx="309600" cy="309600"/>
+            <a:ext cx="309240" cy="309240"/>
           </a:xfrm>
           <a:prstGeom prst="rect">
             <a:avLst/>
@@ -19939,7 +19939,7 @@
         <p:spPr>
           <a:xfrm>
             <a:off x="1298520" y="4191120"/>
-            <a:ext cx="6033600" cy="364320"/>
+            <a:ext cx="6033240" cy="363960"/>
           </a:xfrm>
           <a:prstGeom prst="rect">
             <a:avLst/>
@@ -20000,7 +20000,7 @@
         <p:spPr>
           <a:xfrm>
             <a:off x="822960" y="4965840"/>
-            <a:ext cx="309600" cy="309600"/>
+            <a:ext cx="309240" cy="309240"/>
           </a:xfrm>
           <a:prstGeom prst="rect">
             <a:avLst/>
@@ -20019,7 +20019,7 @@
         <p:spPr>
           <a:xfrm>
             <a:off x="1298520" y="4952880"/>
-            <a:ext cx="6033600" cy="364320"/>
+            <a:ext cx="6033240" cy="363960"/>
           </a:xfrm>
           <a:prstGeom prst="rect">
             <a:avLst/>
@@ -20076,7 +20076,7 @@
         <p:spPr>
           <a:xfrm>
             <a:off x="1298520" y="5715000"/>
-            <a:ext cx="6033600" cy="364320"/>
+            <a:ext cx="6033240" cy="363960"/>
           </a:xfrm>
           <a:prstGeom prst="rect">
             <a:avLst/>
@@ -20133,7 +20133,7 @@
         <p:spPr>
           <a:xfrm>
             <a:off x="7818120" y="1920240"/>
-            <a:ext cx="3519000" cy="4204800"/>
+            <a:ext cx="3518640" cy="4204440"/>
           </a:xfrm>
           <a:prstGeom prst="roundRect">
             <a:avLst>
@@ -20181,7 +20181,7 @@
         <p:spPr>
           <a:xfrm>
             <a:off x="8092440" y="2121480"/>
-            <a:ext cx="3016080" cy="364320"/>
+            <a:ext cx="3015720" cy="363960"/>
           </a:xfrm>
           <a:prstGeom prst="rect">
             <a:avLst/>
@@ -20238,7 +20238,7 @@
         <p:spPr>
           <a:xfrm>
             <a:off x="8092440" y="2633400"/>
-            <a:ext cx="144720" cy="144720"/>
+            <a:ext cx="144360" cy="144360"/>
           </a:xfrm>
           <a:prstGeom prst="ellipse">
             <a:avLst/>
@@ -20284,7 +20284,7 @@
         <p:spPr>
           <a:xfrm>
             <a:off x="8366760" y="2532960"/>
-            <a:ext cx="1004400" cy="291240"/>
+            <a:ext cx="1004040" cy="290880"/>
           </a:xfrm>
           <a:prstGeom prst="rect">
             <a:avLst/>
@@ -20341,7 +20341,7 @@
         <p:spPr>
           <a:xfrm>
             <a:off x="8366760" y="2807280"/>
-            <a:ext cx="2833200" cy="410040"/>
+            <a:ext cx="2832840" cy="409680"/>
           </a:xfrm>
           <a:prstGeom prst="rect">
             <a:avLst/>
@@ -20398,7 +20398,7 @@
         <p:spPr>
           <a:xfrm>
             <a:off x="8092440" y="3291840"/>
-            <a:ext cx="144720" cy="144720"/>
+            <a:ext cx="144360" cy="144360"/>
           </a:xfrm>
           <a:prstGeom prst="ellipse">
             <a:avLst/>
@@ -20444,7 +20444,7 @@
         <p:spPr>
           <a:xfrm>
             <a:off x="8366760" y="3191400"/>
-            <a:ext cx="1004400" cy="291240"/>
+            <a:ext cx="1004040" cy="290880"/>
           </a:xfrm>
           <a:prstGeom prst="rect">
             <a:avLst/>
@@ -20501,7 +20501,7 @@
         <p:spPr>
           <a:xfrm>
             <a:off x="8366760" y="3465720"/>
-            <a:ext cx="2833200" cy="410040"/>
+            <a:ext cx="2832840" cy="409680"/>
           </a:xfrm>
           <a:prstGeom prst="rect">
             <a:avLst/>
@@ -20558,7 +20558,7 @@
         <p:spPr>
           <a:xfrm>
             <a:off x="8092440" y="3950280"/>
-            <a:ext cx="144720" cy="144720"/>
+            <a:ext cx="144360" cy="144360"/>
           </a:xfrm>
           <a:prstGeom prst="ellipse">
             <a:avLst/>
@@ -20604,7 +20604,7 @@
         <p:spPr>
           <a:xfrm>
             <a:off x="8366760" y="3849480"/>
-            <a:ext cx="1004400" cy="291240"/>
+            <a:ext cx="1004040" cy="290880"/>
           </a:xfrm>
           <a:prstGeom prst="rect">
             <a:avLst/>
@@ -20661,7 +20661,7 @@
         <p:spPr>
           <a:xfrm>
             <a:off x="8366760" y="4123800"/>
-            <a:ext cx="2833200" cy="410040"/>
+            <a:ext cx="2832840" cy="409680"/>
           </a:xfrm>
           <a:prstGeom prst="rect">
             <a:avLst/>
@@ -20718,7 +20718,7 @@
         <p:spPr>
           <a:xfrm>
             <a:off x="8092440" y="4608720"/>
-            <a:ext cx="144720" cy="144720"/>
+            <a:ext cx="144360" cy="144360"/>
           </a:xfrm>
           <a:prstGeom prst="ellipse">
             <a:avLst/>
@@ -20764,7 +20764,7 @@
         <p:spPr>
           <a:xfrm>
             <a:off x="8366760" y="4507920"/>
-            <a:ext cx="1004400" cy="291240"/>
+            <a:ext cx="1004040" cy="290880"/>
           </a:xfrm>
           <a:prstGeom prst="rect">
             <a:avLst/>
@@ -20821,7 +20821,7 @@
         <p:spPr>
           <a:xfrm>
             <a:off x="8366760" y="4782240"/>
-            <a:ext cx="2833200" cy="410040"/>
+            <a:ext cx="2832840" cy="409680"/>
           </a:xfrm>
           <a:prstGeom prst="rect">
             <a:avLst/>
@@ -20878,7 +20878,7 @@
         <p:spPr>
           <a:xfrm>
             <a:off x="8092440" y="5266800"/>
-            <a:ext cx="144720" cy="144720"/>
+            <a:ext cx="144360" cy="144360"/>
           </a:xfrm>
           <a:prstGeom prst="ellipse">
             <a:avLst/>
@@ -20924,7 +20924,7 @@
         <p:spPr>
           <a:xfrm>
             <a:off x="8366760" y="5166360"/>
-            <a:ext cx="1004400" cy="291240"/>
+            <a:ext cx="1004040" cy="290880"/>
           </a:xfrm>
           <a:prstGeom prst="rect">
             <a:avLst/>
@@ -20981,7 +20981,7 @@
         <p:spPr>
           <a:xfrm>
             <a:off x="8366760" y="5440680"/>
-            <a:ext cx="2833200" cy="410040"/>
+            <a:ext cx="2832840" cy="409680"/>
           </a:xfrm>
           <a:prstGeom prst="rect">
             <a:avLst/>
@@ -21038,7 +21038,7 @@
         <p:spPr>
           <a:xfrm>
             <a:off x="825480" y="6400800"/>
-            <a:ext cx="8888400" cy="272880"/>
+            <a:ext cx="8888040" cy="272520"/>
           </a:xfrm>
           <a:prstGeom prst="rect">
             <a:avLst/>
@@ -21095,7 +21095,7 @@
         <p:spPr>
           <a:xfrm>
             <a:off x="11368800" y="6400800"/>
-            <a:ext cx="547200" cy="272880"/>
+            <a:ext cx="546840" cy="272520"/>
           </a:xfrm>
           <a:prstGeom prst="rect">
             <a:avLst/>
@@ -21152,7 +21152,7 @@
         <p:spPr>
           <a:xfrm>
             <a:off x="902880" y="5775480"/>
-            <a:ext cx="149760" cy="213480"/>
+            <a:ext cx="149400" cy="213120"/>
           </a:xfrm>
           <a:prstGeom prst="rect">
             <a:avLst/>
@@ -21209,7 +21209,7 @@
         <p:spPr>
           <a:xfrm>
             <a:off x="825480" y="5727600"/>
-            <a:ext cx="303840" cy="303840"/>
+            <a:ext cx="303480" cy="303480"/>
           </a:xfrm>
           <a:prstGeom prst="rect">
             <a:avLst/>
@@ -22238,7 +22238,7 @@
         <p:spPr>
           <a:xfrm>
             <a:off x="822960" y="594360"/>
-            <a:ext cx="5484960" cy="318600"/>
+            <a:ext cx="5484600" cy="318240"/>
           </a:xfrm>
           <a:prstGeom prst="rect">
             <a:avLst/>
@@ -22268,7 +22268,7 @@
               </a:tabLst>
             </a:pPr>
             <a:r>
-              <a:rPr b="1" lang="en-US" sz="1400" spc="194" strike="noStrike">
+              <a:rPr b="1" lang="en-US" sz="1400" spc="191" strike="noStrike">
                 <a:solidFill>
                   <a:srgbClr val="1f7a4d"/>
                 </a:solidFill>
@@ -22295,7 +22295,7 @@
         <p:spPr>
           <a:xfrm>
             <a:off x="777240" y="896040"/>
-            <a:ext cx="8228160" cy="730080"/>
+            <a:ext cx="8227800" cy="729720"/>
           </a:xfrm>
           <a:prstGeom prst="rect">
             <a:avLst/>
@@ -22352,7 +22352,7 @@
         <p:spPr>
           <a:xfrm>
             <a:off x="681120" y="1824120"/>
-            <a:ext cx="848880" cy="848880"/>
+            <a:ext cx="848520" cy="848520"/>
           </a:xfrm>
           <a:prstGeom prst="ellipse">
             <a:avLst/>
@@ -22400,7 +22400,7 @@
         <p:spPr>
           <a:xfrm>
             <a:off x="822960" y="1965960"/>
-            <a:ext cx="565560" cy="565560"/>
+            <a:ext cx="565200" cy="565200"/>
           </a:xfrm>
           <a:prstGeom prst="ellipse">
             <a:avLst/>
@@ -22446,7 +22446,7 @@
         <p:spPr>
           <a:xfrm>
             <a:off x="1645920" y="1947600"/>
-            <a:ext cx="7770960" cy="364320"/>
+            <a:ext cx="7770600" cy="363960"/>
           </a:xfrm>
           <a:prstGeom prst="rect">
             <a:avLst/>
@@ -22503,7 +22503,7 @@
         <p:spPr>
           <a:xfrm>
             <a:off x="1645920" y="2286000"/>
-            <a:ext cx="8685360" cy="364320"/>
+            <a:ext cx="8685000" cy="363960"/>
           </a:xfrm>
           <a:prstGeom prst="rect">
             <a:avLst/>
@@ -22560,7 +22560,7 @@
         <p:spPr>
           <a:xfrm>
             <a:off x="681120" y="2720520"/>
-            <a:ext cx="848880" cy="848880"/>
+            <a:ext cx="848520" cy="848520"/>
           </a:xfrm>
           <a:prstGeom prst="ellipse">
             <a:avLst/>
@@ -22608,7 +22608,7 @@
         <p:spPr>
           <a:xfrm>
             <a:off x="822960" y="2862000"/>
-            <a:ext cx="565560" cy="565560"/>
+            <a:ext cx="565200" cy="565200"/>
           </a:xfrm>
           <a:prstGeom prst="ellipse">
             <a:avLst/>
@@ -22654,7 +22654,7 @@
         <p:spPr>
           <a:xfrm>
             <a:off x="1645920" y="2843640"/>
-            <a:ext cx="7770960" cy="364320"/>
+            <a:ext cx="7770600" cy="363960"/>
           </a:xfrm>
           <a:prstGeom prst="rect">
             <a:avLst/>
@@ -22711,7 +22711,7 @@
         <p:spPr>
           <a:xfrm>
             <a:off x="1645920" y="3182040"/>
-            <a:ext cx="8685360" cy="364320"/>
+            <a:ext cx="8685000" cy="363960"/>
           </a:xfrm>
           <a:prstGeom prst="rect">
             <a:avLst/>
@@ -22768,7 +22768,7 @@
         <p:spPr>
           <a:xfrm>
             <a:off x="681120" y="3616560"/>
-            <a:ext cx="848880" cy="848880"/>
+            <a:ext cx="848520" cy="848520"/>
           </a:xfrm>
           <a:prstGeom prst="ellipse">
             <a:avLst/>
@@ -22816,7 +22816,7 @@
         <p:spPr>
           <a:xfrm>
             <a:off x="822960" y="3758040"/>
-            <a:ext cx="565560" cy="565560"/>
+            <a:ext cx="565200" cy="565200"/>
           </a:xfrm>
           <a:prstGeom prst="ellipse">
             <a:avLst/>
@@ -22862,7 +22862,7 @@
         <p:spPr>
           <a:xfrm>
             <a:off x="1645920" y="3740040"/>
-            <a:ext cx="7770960" cy="364320"/>
+            <a:ext cx="7770600" cy="363960"/>
           </a:xfrm>
           <a:prstGeom prst="rect">
             <a:avLst/>
@@ -22919,7 +22919,7 @@
         <p:spPr>
           <a:xfrm>
             <a:off x="1645920" y="4078080"/>
-            <a:ext cx="8685360" cy="364320"/>
+            <a:ext cx="8685000" cy="363960"/>
           </a:xfrm>
           <a:prstGeom prst="rect">
             <a:avLst/>
@@ -22976,7 +22976,7 @@
         <p:spPr>
           <a:xfrm>
             <a:off x="681120" y="4512600"/>
-            <a:ext cx="848880" cy="848880"/>
+            <a:ext cx="848520" cy="848520"/>
           </a:xfrm>
           <a:prstGeom prst="ellipse">
             <a:avLst/>
@@ -23024,7 +23024,7 @@
         <p:spPr>
           <a:xfrm>
             <a:off x="822960" y="4654440"/>
-            <a:ext cx="565560" cy="565560"/>
+            <a:ext cx="565200" cy="565200"/>
           </a:xfrm>
           <a:prstGeom prst="ellipse">
             <a:avLst/>
@@ -23070,7 +23070,7 @@
         <p:spPr>
           <a:xfrm>
             <a:off x="1645920" y="4636080"/>
-            <a:ext cx="7770960" cy="364320"/>
+            <a:ext cx="7770600" cy="363960"/>
           </a:xfrm>
           <a:prstGeom prst="rect">
             <a:avLst/>
@@ -23127,7 +23127,7 @@
         <p:spPr>
           <a:xfrm>
             <a:off x="1645920" y="4974480"/>
-            <a:ext cx="8685360" cy="364320"/>
+            <a:ext cx="8685000" cy="363960"/>
           </a:xfrm>
           <a:prstGeom prst="rect">
             <a:avLst/>
@@ -23184,7 +23184,7 @@
         <p:spPr>
           <a:xfrm>
             <a:off x="681120" y="5408640"/>
-            <a:ext cx="848880" cy="848880"/>
+            <a:ext cx="848520" cy="848520"/>
           </a:xfrm>
           <a:prstGeom prst="ellipse">
             <a:avLst/>
@@ -23232,7 +23232,7 @@
         <p:spPr>
           <a:xfrm>
             <a:off x="822960" y="5550480"/>
-            <a:ext cx="565560" cy="565560"/>
+            <a:ext cx="565200" cy="565200"/>
           </a:xfrm>
           <a:prstGeom prst="ellipse">
             <a:avLst/>
@@ -23278,7 +23278,7 @@
         <p:spPr>
           <a:xfrm>
             <a:off x="1645920" y="5532120"/>
-            <a:ext cx="7770960" cy="364320"/>
+            <a:ext cx="7770600" cy="363960"/>
           </a:xfrm>
           <a:prstGeom prst="rect">
             <a:avLst/>
@@ -23335,7 +23335,7 @@
         <p:spPr>
           <a:xfrm>
             <a:off x="1645920" y="5870520"/>
-            <a:ext cx="8685360" cy="364320"/>
+            <a:ext cx="8685000" cy="363960"/>
           </a:xfrm>
           <a:prstGeom prst="rect">
             <a:avLst/>
@@ -23392,7 +23392,7 @@
         <p:spPr>
           <a:xfrm>
             <a:off x="11368800" y="6400800"/>
-            <a:ext cx="547200" cy="272880"/>
+            <a:ext cx="546840" cy="272520"/>
           </a:xfrm>
           <a:prstGeom prst="rect">
             <a:avLst/>
@@ -23459,7 +23459,7 @@
         <p:spPr>
           <a:xfrm>
             <a:off x="939960" y="2082960"/>
-            <a:ext cx="328680" cy="328680"/>
+            <a:ext cx="328320" cy="328320"/>
           </a:xfrm>
           <a:prstGeom prst="rect">
             <a:avLst/>
@@ -23488,7 +23488,7 @@
         <p:spPr>
           <a:xfrm>
             <a:off x="939960" y="2971800"/>
-            <a:ext cx="328680" cy="328680"/>
+            <a:ext cx="328320" cy="328320"/>
           </a:xfrm>
           <a:prstGeom prst="rect">
             <a:avLst/>
@@ -23517,7 +23517,7 @@
         <p:spPr>
           <a:xfrm>
             <a:off x="939960" y="3873600"/>
-            <a:ext cx="328680" cy="328680"/>
+            <a:ext cx="328320" cy="328320"/>
           </a:xfrm>
           <a:prstGeom prst="rect">
             <a:avLst/>
@@ -23546,7 +23546,7 @@
         <p:spPr>
           <a:xfrm>
             <a:off x="939960" y="4762440"/>
-            <a:ext cx="328680" cy="328680"/>
+            <a:ext cx="328320" cy="328320"/>
           </a:xfrm>
           <a:prstGeom prst="rect">
             <a:avLst/>
@@ -23575,7 +23575,7 @@
         <p:spPr>
           <a:xfrm>
             <a:off x="939960" y="5664240"/>
-            <a:ext cx="328680" cy="328680"/>
+            <a:ext cx="328320" cy="328320"/>
           </a:xfrm>
           <a:prstGeom prst="rect">
             <a:avLst/>
@@ -24621,7 +24621,7 @@
         <p:spPr>
           <a:xfrm>
             <a:off x="-365760" y="-365760"/>
-            <a:ext cx="730080" cy="730080"/>
+            <a:ext cx="729720" cy="729720"/>
           </a:xfrm>
           <a:prstGeom prst="ellipse">
             <a:avLst/>
@@ -24670,7 +24670,7 @@
         <p:spPr>
           <a:xfrm>
             <a:off x="11826000" y="-365760"/>
-            <a:ext cx="730080" cy="730080"/>
+            <a:ext cx="729720" cy="729720"/>
           </a:xfrm>
           <a:prstGeom prst="ellipse">
             <a:avLst/>
@@ -24719,7 +24719,7 @@
         <p:spPr>
           <a:xfrm>
             <a:off x="-365760" y="6492240"/>
-            <a:ext cx="730080" cy="730080"/>
+            <a:ext cx="729720" cy="729720"/>
           </a:xfrm>
           <a:prstGeom prst="ellipse">
             <a:avLst/>
@@ -24768,7 +24768,7 @@
         <p:spPr>
           <a:xfrm>
             <a:off x="11826000" y="6492240"/>
-            <a:ext cx="730080" cy="730080"/>
+            <a:ext cx="729720" cy="729720"/>
           </a:xfrm>
           <a:prstGeom prst="ellipse">
             <a:avLst/>
@@ -24817,7 +24817,7 @@
         <p:spPr>
           <a:xfrm>
             <a:off x="-1371600" y="5486400"/>
-            <a:ext cx="5484960" cy="5484960"/>
+            <a:ext cx="5484600" cy="5484600"/>
           </a:xfrm>
           <a:prstGeom prst="ellipse">
             <a:avLst/>
@@ -24870,7 +24870,7 @@
         <p:spPr>
           <a:xfrm>
             <a:off x="1325880" y="8183880"/>
-            <a:ext cx="90000" cy="90000"/>
+            <a:ext cx="89640" cy="89640"/>
           </a:xfrm>
           <a:prstGeom prst="ellipse">
             <a:avLst/>
@@ -24918,7 +24918,7 @@
         <p:spPr>
           <a:xfrm>
             <a:off x="822960" y="685800"/>
-            <a:ext cx="7313760" cy="318600"/>
+            <a:ext cx="7313400" cy="318240"/>
           </a:xfrm>
           <a:prstGeom prst="rect">
             <a:avLst/>
@@ -24948,7 +24948,7 @@
               </a:tabLst>
             </a:pPr>
             <a:r>
-              <a:rPr b="1" lang="en-US" sz="1400" spc="194" strike="noStrike">
+              <a:rPr b="1" lang="en-US" sz="1400" spc="191" strike="noStrike">
                 <a:solidFill>
                   <a:srgbClr val="e8a33d"/>
                 </a:solidFill>
@@ -24975,7 +24975,7 @@
         <p:spPr>
           <a:xfrm>
             <a:off x="822960" y="1188720"/>
-            <a:ext cx="10331280" cy="1827360"/>
+            <a:ext cx="10330920" cy="1827000"/>
           </a:xfrm>
           <a:prstGeom prst="rect">
             <a:avLst/>
@@ -25082,7 +25082,7 @@
         <p:spPr>
           <a:xfrm>
             <a:off x="822960" y="3657600"/>
-            <a:ext cx="3381840" cy="2330280"/>
+            <a:ext cx="3381480" cy="2329920"/>
           </a:xfrm>
           <a:prstGeom prst="roundRect">
             <a:avLst>
@@ -25130,7 +25130,7 @@
         <p:spPr>
           <a:xfrm>
             <a:off x="964800" y="3762720"/>
-            <a:ext cx="684360" cy="684360"/>
+            <a:ext cx="684000" cy="684000"/>
           </a:xfrm>
           <a:prstGeom prst="ellipse">
             <a:avLst/>
@@ -25178,7 +25178,7 @@
         <p:spPr>
           <a:xfrm>
             <a:off x="1078920" y="3877200"/>
-            <a:ext cx="455760" cy="455760"/>
+            <a:ext cx="455400" cy="455400"/>
           </a:xfrm>
           <a:prstGeom prst="ellipse">
             <a:avLst/>
@@ -25228,7 +25228,7 @@
         <p:spPr>
           <a:xfrm>
             <a:off x="1225440" y="4023360"/>
-            <a:ext cx="163080" cy="163080"/>
+            <a:ext cx="162720" cy="162720"/>
           </a:xfrm>
           <a:prstGeom prst="rect">
             <a:avLst/>
@@ -25247,7 +25247,7 @@
         <p:spPr>
           <a:xfrm>
             <a:off x="1645920" y="3913560"/>
-            <a:ext cx="912960" cy="382680"/>
+            <a:ext cx="912600" cy="382320"/>
           </a:xfrm>
           <a:prstGeom prst="rect">
             <a:avLst/>
@@ -25304,7 +25304,7 @@
         <p:spPr>
           <a:xfrm>
             <a:off x="1078920" y="4521240"/>
-            <a:ext cx="2869920" cy="1268640"/>
+            <a:ext cx="2869560" cy="1268280"/>
           </a:xfrm>
           <a:prstGeom prst="rect">
             <a:avLst/>
@@ -25361,7 +25361,7 @@
         <p:spPr>
           <a:xfrm>
             <a:off x="4434840" y="3657600"/>
-            <a:ext cx="3381840" cy="2330280"/>
+            <a:ext cx="3381480" cy="2329920"/>
           </a:xfrm>
           <a:prstGeom prst="roundRect">
             <a:avLst>
@@ -25409,7 +25409,7 @@
         <p:spPr>
           <a:xfrm>
             <a:off x="4576680" y="3762720"/>
-            <a:ext cx="684360" cy="684360"/>
+            <a:ext cx="684000" cy="684000"/>
           </a:xfrm>
           <a:prstGeom prst="ellipse">
             <a:avLst/>
@@ -25457,7 +25457,7 @@
         <p:spPr>
           <a:xfrm>
             <a:off x="4690800" y="3877200"/>
-            <a:ext cx="455760" cy="455760"/>
+            <a:ext cx="455400" cy="455400"/>
           </a:xfrm>
           <a:prstGeom prst="ellipse">
             <a:avLst/>
@@ -25507,7 +25507,7 @@
         <p:spPr>
           <a:xfrm>
             <a:off x="4837320" y="4023360"/>
-            <a:ext cx="163080" cy="163080"/>
+            <a:ext cx="162720" cy="162720"/>
           </a:xfrm>
           <a:prstGeom prst="rect">
             <a:avLst/>
@@ -25526,7 +25526,7 @@
         <p:spPr>
           <a:xfrm>
             <a:off x="5257800" y="3913560"/>
-            <a:ext cx="912960" cy="382680"/>
+            <a:ext cx="912600" cy="382320"/>
           </a:xfrm>
           <a:prstGeom prst="rect">
             <a:avLst/>
@@ -25583,7 +25583,7 @@
         <p:spPr>
           <a:xfrm>
             <a:off x="4690800" y="4521240"/>
-            <a:ext cx="2869920" cy="1268640"/>
+            <a:ext cx="2869560" cy="1268280"/>
           </a:xfrm>
           <a:prstGeom prst="rect">
             <a:avLst/>
@@ -25640,7 +25640,7 @@
         <p:spPr>
           <a:xfrm>
             <a:off x="8046720" y="3657600"/>
-            <a:ext cx="3381840" cy="2330280"/>
+            <a:ext cx="3381480" cy="2329920"/>
           </a:xfrm>
           <a:prstGeom prst="roundRect">
             <a:avLst>
@@ -25688,7 +25688,7 @@
         <p:spPr>
           <a:xfrm>
             <a:off x="8188560" y="3762720"/>
-            <a:ext cx="684360" cy="684360"/>
+            <a:ext cx="684000" cy="684000"/>
           </a:xfrm>
           <a:prstGeom prst="ellipse">
             <a:avLst/>
@@ -25736,7 +25736,7 @@
         <p:spPr>
           <a:xfrm>
             <a:off x="8302680" y="3877200"/>
-            <a:ext cx="455760" cy="455760"/>
+            <a:ext cx="455400" cy="455400"/>
           </a:xfrm>
           <a:prstGeom prst="ellipse">
             <a:avLst/>
@@ -25786,7 +25786,7 @@
         <p:spPr>
           <a:xfrm>
             <a:off x="8449200" y="4023360"/>
-            <a:ext cx="163080" cy="163080"/>
+            <a:ext cx="162720" cy="162720"/>
           </a:xfrm>
           <a:prstGeom prst="rect">
             <a:avLst/>
@@ -25805,7 +25805,7 @@
         <p:spPr>
           <a:xfrm>
             <a:off x="8869680" y="3913560"/>
-            <a:ext cx="912960" cy="382680"/>
+            <a:ext cx="912600" cy="382320"/>
           </a:xfrm>
           <a:prstGeom prst="rect">
             <a:avLst/>
@@ -25862,7 +25862,7 @@
         <p:spPr>
           <a:xfrm>
             <a:off x="8302680" y="4521240"/>
-            <a:ext cx="2869920" cy="1268640"/>
+            <a:ext cx="2869560" cy="1268280"/>
           </a:xfrm>
           <a:prstGeom prst="rect">
             <a:avLst/>
@@ -25919,7 +25919,7 @@
         <p:spPr>
           <a:xfrm>
             <a:off x="11368800" y="6400800"/>
-            <a:ext cx="547200" cy="272880"/>
+            <a:ext cx="546840" cy="272520"/>
           </a:xfrm>
           <a:prstGeom prst="rect">
             <a:avLst/>
@@ -25976,7 +25976,7 @@
         <p:spPr>
           <a:xfrm>
             <a:off x="822960" y="3160080"/>
-            <a:ext cx="10544400" cy="182520"/>
+            <a:ext cx="10544040" cy="182520"/>
           </a:xfrm>
           <a:prstGeom prst="rect">
             <a:avLst/>
@@ -26766,7 +26766,7 @@
         <p:spPr>
           <a:xfrm>
             <a:off x="822960" y="594360"/>
-            <a:ext cx="5484960" cy="318600"/>
+            <a:ext cx="5484600" cy="318240"/>
           </a:xfrm>
           <a:prstGeom prst="rect">
             <a:avLst/>
@@ -26796,7 +26796,7 @@
               </a:tabLst>
             </a:pPr>
             <a:r>
-              <a:rPr b="1" lang="en-US" sz="1400" spc="194" strike="noStrike">
+              <a:rPr b="1" lang="en-US" sz="1400" spc="191" strike="noStrike">
                 <a:solidFill>
                   <a:srgbClr val="1f7a4d"/>
                 </a:solidFill>
@@ -26823,7 +26823,7 @@
         <p:spPr>
           <a:xfrm>
             <a:off x="777240" y="896040"/>
-            <a:ext cx="9142560" cy="730080"/>
+            <a:ext cx="9142200" cy="729720"/>
           </a:xfrm>
           <a:prstGeom prst="rect">
             <a:avLst/>
@@ -26880,7 +26880,7 @@
         <p:spPr>
           <a:xfrm>
             <a:off x="822960" y="1965960"/>
-            <a:ext cx="3427560" cy="2233800"/>
+            <a:ext cx="3427200" cy="2233440"/>
           </a:xfrm>
           <a:prstGeom prst="roundRect">
             <a:avLst>
@@ -26935,7 +26935,7 @@
         <p:spPr>
           <a:xfrm>
             <a:off x="951120" y="2084760"/>
-            <a:ext cx="766800" cy="766800"/>
+            <a:ext cx="766440" cy="766440"/>
           </a:xfrm>
           <a:prstGeom prst="ellipse">
             <a:avLst/>
@@ -26983,7 +26983,7 @@
         <p:spPr>
           <a:xfrm>
             <a:off x="1078920" y="2212920"/>
-            <a:ext cx="510480" cy="510480"/>
+            <a:ext cx="510120" cy="510120"/>
           </a:xfrm>
           <a:prstGeom prst="ellipse">
             <a:avLst/>
@@ -27033,7 +27033,7 @@
         <p:spPr>
           <a:xfrm>
             <a:off x="1225440" y="2359080"/>
-            <a:ext cx="218160" cy="218160"/>
+            <a:ext cx="217800" cy="217800"/>
           </a:xfrm>
           <a:prstGeom prst="rect">
             <a:avLst/>
@@ -27052,7 +27052,7 @@
         <p:spPr>
           <a:xfrm>
             <a:off x="1078920" y="2871360"/>
-            <a:ext cx="2915640" cy="547200"/>
+            <a:ext cx="2915280" cy="546840"/>
           </a:xfrm>
           <a:prstGeom prst="rect">
             <a:avLst/>
@@ -27109,7 +27109,7 @@
         <p:spPr>
           <a:xfrm>
             <a:off x="1078920" y="3429000"/>
-            <a:ext cx="2915640" cy="532080"/>
+            <a:ext cx="2915280" cy="531720"/>
           </a:xfrm>
           <a:prstGeom prst="rect">
             <a:avLst/>
@@ -27166,7 +27166,7 @@
         <p:spPr>
           <a:xfrm>
             <a:off x="4507920" y="1965960"/>
-            <a:ext cx="3427560" cy="2233800"/>
+            <a:ext cx="3427200" cy="2233440"/>
           </a:xfrm>
           <a:prstGeom prst="roundRect">
             <a:avLst>
@@ -27221,7 +27221,7 @@
         <p:spPr>
           <a:xfrm>
             <a:off x="4636080" y="2084760"/>
-            <a:ext cx="766800" cy="766800"/>
+            <a:ext cx="766440" cy="766440"/>
           </a:xfrm>
           <a:prstGeom prst="ellipse">
             <a:avLst/>
@@ -27269,7 +27269,7 @@
         <p:spPr>
           <a:xfrm>
             <a:off x="4763880" y="2212920"/>
-            <a:ext cx="510480" cy="510480"/>
+            <a:ext cx="510120" cy="510120"/>
           </a:xfrm>
           <a:prstGeom prst="ellipse">
             <a:avLst/>
@@ -27319,7 +27319,7 @@
         <p:spPr>
           <a:xfrm>
             <a:off x="4910400" y="2359080"/>
-            <a:ext cx="218160" cy="218160"/>
+            <a:ext cx="217800" cy="217800"/>
           </a:xfrm>
           <a:prstGeom prst="rect">
             <a:avLst/>
@@ -27338,7 +27338,7 @@
         <p:spPr>
           <a:xfrm>
             <a:off x="4763880" y="2871360"/>
-            <a:ext cx="2915640" cy="547200"/>
+            <a:ext cx="2915280" cy="546840"/>
           </a:xfrm>
           <a:prstGeom prst="rect">
             <a:avLst/>
@@ -27395,7 +27395,7 @@
         <p:spPr>
           <a:xfrm>
             <a:off x="4763880" y="3429000"/>
-            <a:ext cx="2915640" cy="532080"/>
+            <a:ext cx="2915280" cy="531720"/>
           </a:xfrm>
           <a:prstGeom prst="rect">
             <a:avLst/>
@@ -27452,7 +27452,7 @@
         <p:spPr>
           <a:xfrm>
             <a:off x="8192880" y="1965960"/>
-            <a:ext cx="3427560" cy="2233800"/>
+            <a:ext cx="3427200" cy="2233440"/>
           </a:xfrm>
           <a:prstGeom prst="roundRect">
             <a:avLst>
@@ -27507,7 +27507,7 @@
         <p:spPr>
           <a:xfrm>
             <a:off x="8321040" y="2084760"/>
-            <a:ext cx="766800" cy="766800"/>
+            <a:ext cx="766440" cy="766440"/>
           </a:xfrm>
           <a:prstGeom prst="ellipse">
             <a:avLst/>
@@ -27555,7 +27555,7 @@
         <p:spPr>
           <a:xfrm>
             <a:off x="8449200" y="2212920"/>
-            <a:ext cx="510480" cy="510480"/>
+            <a:ext cx="510120" cy="510120"/>
           </a:xfrm>
           <a:prstGeom prst="ellipse">
             <a:avLst/>
@@ -27605,7 +27605,7 @@
         <p:spPr>
           <a:xfrm>
             <a:off x="8595360" y="2359080"/>
-            <a:ext cx="218160" cy="218160"/>
+            <a:ext cx="217800" cy="217800"/>
           </a:xfrm>
           <a:prstGeom prst="rect">
             <a:avLst/>
@@ -27624,7 +27624,7 @@
         <p:spPr>
           <a:xfrm>
             <a:off x="8449200" y="2871360"/>
-            <a:ext cx="2915640" cy="547200"/>
+            <a:ext cx="2915280" cy="546840"/>
           </a:xfrm>
           <a:prstGeom prst="rect">
             <a:avLst/>
@@ -27681,7 +27681,7 @@
         <p:spPr>
           <a:xfrm>
             <a:off x="8449200" y="3429000"/>
-            <a:ext cx="2915640" cy="532080"/>
+            <a:ext cx="2915280" cy="531720"/>
           </a:xfrm>
           <a:prstGeom prst="rect">
             <a:avLst/>
@@ -27738,7 +27738,7 @@
         <p:spPr>
           <a:xfrm>
             <a:off x="822960" y="4617720"/>
-            <a:ext cx="2010240" cy="547200"/>
+            <a:ext cx="2009880" cy="546840"/>
           </a:xfrm>
           <a:prstGeom prst="roundRect">
             <a:avLst>
@@ -27786,7 +27786,7 @@
         <p:spPr>
           <a:xfrm>
             <a:off x="822960" y="4617720"/>
-            <a:ext cx="2010240" cy="547200"/>
+            <a:ext cx="2009880" cy="546840"/>
           </a:xfrm>
           <a:prstGeom prst="rect">
             <a:avLst/>
@@ -27847,7 +27847,7 @@
         <p:spPr>
           <a:xfrm>
             <a:off x="2853000" y="4800600"/>
-            <a:ext cx="181440" cy="181440"/>
+            <a:ext cx="181080" cy="181080"/>
           </a:xfrm>
           <a:prstGeom prst="rect">
             <a:avLst/>
@@ -27866,7 +27866,7 @@
         <p:spPr>
           <a:xfrm>
             <a:off x="3072240" y="4617720"/>
-            <a:ext cx="2010240" cy="547200"/>
+            <a:ext cx="2009880" cy="546840"/>
           </a:xfrm>
           <a:prstGeom prst="roundRect">
             <a:avLst>
@@ -27914,7 +27914,7 @@
         <p:spPr>
           <a:xfrm>
             <a:off x="3072240" y="4617720"/>
-            <a:ext cx="2010240" cy="547200"/>
+            <a:ext cx="2009880" cy="546840"/>
           </a:xfrm>
           <a:prstGeom prst="rect">
             <a:avLst/>
@@ -27975,7 +27975,7 @@
         <p:spPr>
           <a:xfrm>
             <a:off x="5102280" y="4800600"/>
-            <a:ext cx="181440" cy="181440"/>
+            <a:ext cx="181080" cy="181080"/>
           </a:xfrm>
           <a:prstGeom prst="rect">
             <a:avLst/>
@@ -27994,7 +27994,7 @@
         <p:spPr>
           <a:xfrm>
             <a:off x="5321880" y="4617720"/>
-            <a:ext cx="2010240" cy="547200"/>
+            <a:ext cx="2009880" cy="546840"/>
           </a:xfrm>
           <a:prstGeom prst="roundRect">
             <a:avLst>
@@ -28042,7 +28042,7 @@
         <p:spPr>
           <a:xfrm>
             <a:off x="5321880" y="4617720"/>
-            <a:ext cx="2010240" cy="547200"/>
+            <a:ext cx="2009880" cy="546840"/>
           </a:xfrm>
           <a:prstGeom prst="rect">
             <a:avLst/>
@@ -28103,7 +28103,7 @@
         <p:spPr>
           <a:xfrm>
             <a:off x="7351920" y="4800600"/>
-            <a:ext cx="181440" cy="181440"/>
+            <a:ext cx="181080" cy="181080"/>
           </a:xfrm>
           <a:prstGeom prst="rect">
             <a:avLst/>
@@ -28122,7 +28122,7 @@
         <p:spPr>
           <a:xfrm>
             <a:off x="7571160" y="4617720"/>
-            <a:ext cx="2010240" cy="547200"/>
+            <a:ext cx="2009880" cy="546840"/>
           </a:xfrm>
           <a:prstGeom prst="roundRect">
             <a:avLst>
@@ -28170,7 +28170,7 @@
         <p:spPr>
           <a:xfrm>
             <a:off x="7571160" y="4617720"/>
-            <a:ext cx="2010240" cy="547200"/>
+            <a:ext cx="2009880" cy="546840"/>
           </a:xfrm>
           <a:prstGeom prst="rect">
             <a:avLst/>
@@ -28231,7 +28231,7 @@
         <p:spPr>
           <a:xfrm>
             <a:off x="9601200" y="4800600"/>
-            <a:ext cx="181440" cy="181440"/>
+            <a:ext cx="181080" cy="181080"/>
           </a:xfrm>
           <a:prstGeom prst="rect">
             <a:avLst/>
@@ -28250,7 +28250,7 @@
         <p:spPr>
           <a:xfrm>
             <a:off x="9820800" y="4617720"/>
-            <a:ext cx="2010240" cy="547200"/>
+            <a:ext cx="2009880" cy="546840"/>
           </a:xfrm>
           <a:prstGeom prst="roundRect">
             <a:avLst>
@@ -28298,7 +28298,7 @@
         <p:spPr>
           <a:xfrm>
             <a:off x="9820800" y="4617720"/>
-            <a:ext cx="2010240" cy="547200"/>
+            <a:ext cx="2009880" cy="546840"/>
           </a:xfrm>
           <a:prstGeom prst="rect">
             <a:avLst/>
@@ -28355,7 +28355,7 @@
         <p:spPr>
           <a:xfrm>
             <a:off x="822960" y="5623560"/>
-            <a:ext cx="10331280" cy="547200"/>
+            <a:ext cx="10330920" cy="546840"/>
           </a:xfrm>
           <a:prstGeom prst="rect">
             <a:avLst/>
@@ -28452,7 +28452,7 @@
         <p:spPr>
           <a:xfrm>
             <a:off x="11368800" y="6400800"/>
-            <a:ext cx="547200" cy="272880"/>
+            <a:ext cx="546840" cy="272520"/>
           </a:xfrm>
           <a:prstGeom prst="rect">
             <a:avLst/>
@@ -29658,7 +29658,7 @@
         <p:spPr>
           <a:xfrm>
             <a:off x="-365760" y="-365760"/>
-            <a:ext cx="730080" cy="730080"/>
+            <a:ext cx="729720" cy="729720"/>
           </a:xfrm>
           <a:prstGeom prst="ellipse">
             <a:avLst/>
@@ -29707,7 +29707,7 @@
         <p:spPr>
           <a:xfrm>
             <a:off x="11826000" y="-365760"/>
-            <a:ext cx="730080" cy="730080"/>
+            <a:ext cx="729720" cy="729720"/>
           </a:xfrm>
           <a:prstGeom prst="ellipse">
             <a:avLst/>
@@ -29756,7 +29756,7 @@
         <p:spPr>
           <a:xfrm>
             <a:off x="-365760" y="6492240"/>
-            <a:ext cx="730080" cy="730080"/>
+            <a:ext cx="729720" cy="729720"/>
           </a:xfrm>
           <a:prstGeom prst="ellipse">
             <a:avLst/>
@@ -29805,7 +29805,7 @@
         <p:spPr>
           <a:xfrm>
             <a:off x="11826000" y="6492240"/>
-            <a:ext cx="730080" cy="730080"/>
+            <a:ext cx="729720" cy="729720"/>
           </a:xfrm>
           <a:prstGeom prst="ellipse">
             <a:avLst/>
@@ -29854,7 +29854,7 @@
         <p:spPr>
           <a:xfrm>
             <a:off x="2926080" y="-4846320"/>
-            <a:ext cx="6033600" cy="6033600"/>
+            <a:ext cx="6033240" cy="6033240"/>
           </a:xfrm>
           <a:prstGeom prst="ellipse">
             <a:avLst/>
@@ -29907,7 +29907,7 @@
         <p:spPr>
           <a:xfrm>
             <a:off x="5897880" y="-1874520"/>
-            <a:ext cx="90000" cy="90000"/>
+            <a:ext cx="89640" cy="89640"/>
           </a:xfrm>
           <a:prstGeom prst="ellipse">
             <a:avLst/>
@@ -29955,7 +29955,7 @@
         <p:spPr>
           <a:xfrm>
             <a:off x="822960" y="1234440"/>
-            <a:ext cx="5484960" cy="318600"/>
+            <a:ext cx="5484600" cy="318240"/>
           </a:xfrm>
           <a:prstGeom prst="rect">
             <a:avLst/>
@@ -29985,7 +29985,7 @@
               </a:tabLst>
             </a:pPr>
             <a:r>
-              <a:rPr b="1" lang="en-US" sz="1400" spc="194" strike="noStrike">
+              <a:rPr b="1" lang="en-US" sz="1400" spc="191" strike="noStrike">
                 <a:solidFill>
                   <a:srgbClr val="e8a33d"/>
                 </a:solidFill>
@@ -30012,7 +30012,7 @@
         <p:spPr>
           <a:xfrm>
             <a:off x="777240" y="1554480"/>
-            <a:ext cx="9599760" cy="1735920"/>
+            <a:ext cx="9599400" cy="1735560"/>
           </a:xfrm>
           <a:prstGeom prst="rect">
             <a:avLst/>
@@ -30095,7 +30095,7 @@
         <p:spPr>
           <a:xfrm>
             <a:off x="822960" y="3611880"/>
-            <a:ext cx="3381840" cy="2330280"/>
+            <a:ext cx="3381480" cy="2329920"/>
           </a:xfrm>
           <a:prstGeom prst="roundRect">
             <a:avLst>
@@ -30143,7 +30143,7 @@
         <p:spPr>
           <a:xfrm>
             <a:off x="1965960" y="3703320"/>
-            <a:ext cx="1095840" cy="1095840"/>
+            <a:ext cx="1095480" cy="1095480"/>
           </a:xfrm>
           <a:prstGeom prst="ellipse">
             <a:avLst/>
@@ -30191,7 +30191,7 @@
         <p:spPr>
           <a:xfrm>
             <a:off x="2148840" y="3886200"/>
-            <a:ext cx="730080" cy="730080"/>
+            <a:ext cx="729720" cy="729720"/>
           </a:xfrm>
           <a:prstGeom prst="ellipse">
             <a:avLst/>
@@ -30241,7 +30241,7 @@
         <p:spPr>
           <a:xfrm>
             <a:off x="2331720" y="4069080"/>
-            <a:ext cx="364320" cy="364320"/>
+            <a:ext cx="363960" cy="363960"/>
           </a:xfrm>
           <a:prstGeom prst="rect">
             <a:avLst/>
@@ -30260,7 +30260,7 @@
         <p:spPr>
           <a:xfrm>
             <a:off x="822960" y="4648320"/>
-            <a:ext cx="3381840" cy="658800"/>
+            <a:ext cx="3381480" cy="658440"/>
           </a:xfrm>
           <a:prstGeom prst="rect">
             <a:avLst/>
@@ -30343,7 +30343,7 @@
         <p:spPr>
           <a:xfrm>
             <a:off x="1005840" y="5308560"/>
-            <a:ext cx="3016080" cy="506520"/>
+            <a:ext cx="3015720" cy="506160"/>
           </a:xfrm>
           <a:prstGeom prst="rect">
             <a:avLst/>
@@ -30400,7 +30400,7 @@
         <p:spPr>
           <a:xfrm>
             <a:off x="4434840" y="3611880"/>
-            <a:ext cx="3381840" cy="2330280"/>
+            <a:ext cx="3381480" cy="2329920"/>
           </a:xfrm>
           <a:prstGeom prst="roundRect">
             <a:avLst>
@@ -30448,7 +30448,7 @@
         <p:spPr>
           <a:xfrm>
             <a:off x="5577840" y="3703320"/>
-            <a:ext cx="1095840" cy="1095840"/>
+            <a:ext cx="1095480" cy="1095480"/>
           </a:xfrm>
           <a:prstGeom prst="ellipse">
             <a:avLst/>
@@ -30496,7 +30496,7 @@
         <p:spPr>
           <a:xfrm>
             <a:off x="5760720" y="3886200"/>
-            <a:ext cx="730080" cy="730080"/>
+            <a:ext cx="729720" cy="729720"/>
           </a:xfrm>
           <a:prstGeom prst="ellipse">
             <a:avLst/>
@@ -30546,7 +30546,7 @@
         <p:spPr>
           <a:xfrm>
             <a:off x="5943600" y="4069080"/>
-            <a:ext cx="364320" cy="364320"/>
+            <a:ext cx="363960" cy="363960"/>
           </a:xfrm>
           <a:prstGeom prst="rect">
             <a:avLst/>
@@ -30565,7 +30565,7 @@
         <p:spPr>
           <a:xfrm>
             <a:off x="4434840" y="4648320"/>
-            <a:ext cx="3381840" cy="658800"/>
+            <a:ext cx="3381480" cy="658440"/>
           </a:xfrm>
           <a:prstGeom prst="rect">
             <a:avLst/>
@@ -30648,7 +30648,7 @@
         <p:spPr>
           <a:xfrm>
             <a:off x="4617720" y="5308560"/>
-            <a:ext cx="3016080" cy="506520"/>
+            <a:ext cx="3015720" cy="506160"/>
           </a:xfrm>
           <a:prstGeom prst="rect">
             <a:avLst/>
@@ -30705,7 +30705,7 @@
         <p:spPr>
           <a:xfrm>
             <a:off x="8046720" y="3611880"/>
-            <a:ext cx="3381840" cy="2330280"/>
+            <a:ext cx="3381480" cy="2329920"/>
           </a:xfrm>
           <a:prstGeom prst="roundRect">
             <a:avLst>
@@ -30753,7 +30753,7 @@
         <p:spPr>
           <a:xfrm>
             <a:off x="9189720" y="3703320"/>
-            <a:ext cx="1095840" cy="1095840"/>
+            <a:ext cx="1095480" cy="1095480"/>
           </a:xfrm>
           <a:prstGeom prst="ellipse">
             <a:avLst/>
@@ -30801,7 +30801,7 @@
         <p:spPr>
           <a:xfrm>
             <a:off x="9372600" y="3886200"/>
-            <a:ext cx="730080" cy="730080"/>
+            <a:ext cx="729720" cy="729720"/>
           </a:xfrm>
           <a:prstGeom prst="ellipse">
             <a:avLst/>
@@ -30851,7 +30851,7 @@
         <p:spPr>
           <a:xfrm>
             <a:off x="9555480" y="4069080"/>
-            <a:ext cx="364320" cy="364320"/>
+            <a:ext cx="363960" cy="363960"/>
           </a:xfrm>
           <a:prstGeom prst="rect">
             <a:avLst/>
@@ -30870,7 +30870,7 @@
         <p:spPr>
           <a:xfrm>
             <a:off x="8046720" y="4648320"/>
-            <a:ext cx="3381840" cy="658800"/>
+            <a:ext cx="3381480" cy="658440"/>
           </a:xfrm>
           <a:prstGeom prst="rect">
             <a:avLst/>
@@ -30953,7 +30953,7 @@
         <p:spPr>
           <a:xfrm>
             <a:off x="8229600" y="5308560"/>
-            <a:ext cx="3016080" cy="506520"/>
+            <a:ext cx="3015720" cy="506160"/>
           </a:xfrm>
           <a:prstGeom prst="rect">
             <a:avLst/>
@@ -31010,7 +31010,7 @@
         <p:spPr>
           <a:xfrm>
             <a:off x="11368800" y="6400800"/>
-            <a:ext cx="547200" cy="272880"/>
+            <a:ext cx="546840" cy="272520"/>
           </a:xfrm>
           <a:prstGeom prst="rect">
             <a:avLst/>
@@ -31795,7 +31795,7 @@
         <p:spPr>
           <a:xfrm>
             <a:off x="-365760" y="-365760"/>
-            <a:ext cx="730080" cy="730080"/>
+            <a:ext cx="729720" cy="729720"/>
           </a:xfrm>
           <a:prstGeom prst="ellipse">
             <a:avLst/>
@@ -31844,7 +31844,7 @@
         <p:spPr>
           <a:xfrm>
             <a:off x="11826000" y="-365760"/>
-            <a:ext cx="730080" cy="730080"/>
+            <a:ext cx="729720" cy="729720"/>
           </a:xfrm>
           <a:prstGeom prst="ellipse">
             <a:avLst/>
@@ -31893,7 +31893,7 @@
         <p:spPr>
           <a:xfrm>
             <a:off x="-365760" y="6492240"/>
-            <a:ext cx="730080" cy="730080"/>
+            <a:ext cx="729720" cy="729720"/>
           </a:xfrm>
           <a:prstGeom prst="ellipse">
             <a:avLst/>
@@ -31942,7 +31942,7 @@
         <p:spPr>
           <a:xfrm>
             <a:off x="11826000" y="6492240"/>
-            <a:ext cx="730080" cy="730080"/>
+            <a:ext cx="729720" cy="729720"/>
           </a:xfrm>
           <a:prstGeom prst="ellipse">
             <a:avLst/>
@@ -31991,7 +31991,7 @@
         <p:spPr>
           <a:xfrm>
             <a:off x="2926080" y="-4846320"/>
-            <a:ext cx="6033600" cy="6033600"/>
+            <a:ext cx="6033240" cy="6033240"/>
           </a:xfrm>
           <a:prstGeom prst="ellipse">
             <a:avLst/>
@@ -32044,7 +32044,7 @@
         <p:spPr>
           <a:xfrm>
             <a:off x="5897880" y="-1874520"/>
-            <a:ext cx="90000" cy="90000"/>
+            <a:ext cx="89640" cy="89640"/>
           </a:xfrm>
           <a:prstGeom prst="ellipse">
             <a:avLst/>
@@ -32092,7 +32092,7 @@
         <p:spPr>
           <a:xfrm>
             <a:off x="825480" y="787320"/>
-            <a:ext cx="6348960" cy="316440"/>
+            <a:ext cx="6348600" cy="316080"/>
           </a:xfrm>
           <a:prstGeom prst="rect">
             <a:avLst/>
@@ -32119,7 +32119,7 @@
               </a:lnSpc>
             </a:pPr>
             <a:r>
-              <a:rPr b="1" lang="en-US" sz="1400" spc="194" strike="noStrike">
+              <a:rPr b="1" lang="en-US" sz="1400" spc="191" strike="noStrike">
                 <a:solidFill>
                   <a:srgbClr val="e8a33d"/>
                 </a:solidFill>
@@ -32146,7 +32146,7 @@
         <p:spPr>
           <a:xfrm>
             <a:off x="825480" y="1168560"/>
-            <a:ext cx="10540080" cy="735480"/>
+            <a:ext cx="10539720" cy="735120"/>
           </a:xfrm>
           <a:prstGeom prst="rect">
             <a:avLst/>
@@ -32200,7 +32200,7 @@
         <p:spPr>
           <a:xfrm>
             <a:off x="825480" y="1930320"/>
-            <a:ext cx="10540080" cy="354600"/>
+            <a:ext cx="10539720" cy="354240"/>
           </a:xfrm>
           <a:prstGeom prst="rect">
             <a:avLst/>
@@ -32254,7 +32254,7 @@
         <p:spPr>
           <a:xfrm>
             <a:off x="825480" y="2692440"/>
-            <a:ext cx="5078880" cy="1497600"/>
+            <a:ext cx="5078520" cy="1497240"/>
           </a:xfrm>
           <a:prstGeom prst="roundRect">
             <a:avLst>
@@ -32338,7 +32338,7 @@
         <p:spPr>
           <a:xfrm>
             <a:off x="6286680" y="2692440"/>
-            <a:ext cx="5078880" cy="1497600"/>
+            <a:ext cx="5078520" cy="1497240"/>
           </a:xfrm>
           <a:prstGeom prst="roundRect">
             <a:avLst>
@@ -32422,7 +32422,7 @@
         <p:spPr>
           <a:xfrm>
             <a:off x="825480" y="4622760"/>
-            <a:ext cx="5078880" cy="1269000"/>
+            <a:ext cx="5078520" cy="1268640"/>
           </a:xfrm>
           <a:prstGeom prst="roundRect">
             <a:avLst>
@@ -32491,7 +32491,7 @@
         <p:spPr>
           <a:xfrm>
             <a:off x="6286680" y="4622760"/>
-            <a:ext cx="5078880" cy="1269000"/>
+            <a:ext cx="5078520" cy="1268640"/>
           </a:xfrm>
           <a:prstGeom prst="roundRect">
             <a:avLst>
@@ -32560,7 +32560,7 @@
         <p:spPr>
           <a:xfrm>
             <a:off x="11368800" y="6400800"/>
-            <a:ext cx="547200" cy="272880"/>
+            <a:ext cx="546840" cy="272520"/>
           </a:xfrm>
           <a:prstGeom prst="rect">
             <a:avLst/>
@@ -32845,7 +32845,7 @@
         <p:spPr>
           <a:xfrm>
             <a:off x="697320" y="468720"/>
-            <a:ext cx="753120" cy="753120"/>
+            <a:ext cx="752760" cy="752760"/>
           </a:xfrm>
           <a:prstGeom prst="ellipse">
             <a:avLst/>
@@ -32893,7 +32893,7 @@
         <p:spPr>
           <a:xfrm>
             <a:off x="822960" y="594360"/>
-            <a:ext cx="501480" cy="501480"/>
+            <a:ext cx="501120" cy="501120"/>
           </a:xfrm>
           <a:prstGeom prst="ellipse">
             <a:avLst/>
@@ -32939,7 +32939,7 @@
         <p:spPr>
           <a:xfrm>
             <a:off x="1481400" y="713160"/>
-            <a:ext cx="4277880" cy="272880"/>
+            <a:ext cx="4277520" cy="272520"/>
           </a:xfrm>
           <a:prstGeom prst="rect">
             <a:avLst/>
@@ -32969,7 +32969,7 @@
               </a:tabLst>
             </a:pPr>
             <a:r>
-              <a:rPr b="1" lang="en-US" sz="1400" spc="194" strike="noStrike">
+              <a:rPr b="1" lang="en-US" sz="1400" spc="191" strike="noStrike">
                 <a:solidFill>
                   <a:srgbClr val="b8790c"/>
                 </a:solidFill>
@@ -32996,7 +32996,7 @@
         <p:spPr>
           <a:xfrm>
             <a:off x="822960" y="1188720"/>
-            <a:ext cx="4936320" cy="775800"/>
+            <a:ext cx="4935960" cy="775440"/>
           </a:xfrm>
           <a:prstGeom prst="rect">
             <a:avLst/>
@@ -33053,7 +33053,7 @@
         <p:spPr>
           <a:xfrm>
             <a:off x="822960" y="2057400"/>
-            <a:ext cx="4936320" cy="894600"/>
+            <a:ext cx="4935960" cy="894240"/>
           </a:xfrm>
           <a:prstGeom prst="roundRect">
             <a:avLst>
@@ -33101,7 +33101,7 @@
         <p:spPr>
           <a:xfrm>
             <a:off x="1024200" y="2148840"/>
-            <a:ext cx="4533840" cy="227160"/>
+            <a:ext cx="4533480" cy="226800"/>
           </a:xfrm>
           <a:prstGeom prst="rect">
             <a:avLst/>
@@ -33131,7 +33131,7 @@
               </a:tabLst>
             </a:pPr>
             <a:r>
-              <a:rPr b="1" lang="en-US" sz="1200" spc="92" strike="noStrike">
+              <a:rPr b="1" lang="en-US" sz="1200" spc="89" strike="noStrike">
                 <a:solidFill>
                   <a:srgbClr val="e8a33d"/>
                 </a:solidFill>
@@ -33158,7 +33158,7 @@
         <p:spPr>
           <a:xfrm>
             <a:off x="1024200" y="2377440"/>
-            <a:ext cx="4533840" cy="528840"/>
+            <a:ext cx="4533480" cy="528480"/>
           </a:xfrm>
           <a:prstGeom prst="rect">
             <a:avLst/>
@@ -33215,7 +33215,7 @@
         <p:spPr>
           <a:xfrm>
             <a:off x="822960" y="3154680"/>
-            <a:ext cx="4936320" cy="419040"/>
+            <a:ext cx="4935960" cy="418680"/>
           </a:xfrm>
           <a:prstGeom prst="roundRect">
             <a:avLst>
@@ -33263,7 +33263,7 @@
         <p:spPr>
           <a:xfrm>
             <a:off x="1371600" y="3154680"/>
-            <a:ext cx="4266000" cy="419040"/>
+            <a:ext cx="4265640" cy="418680"/>
           </a:xfrm>
           <a:prstGeom prst="rect">
             <a:avLst/>
@@ -33324,7 +33324,7 @@
         <p:spPr>
           <a:xfrm>
             <a:off x="800280" y="4013280"/>
-            <a:ext cx="252720" cy="252720"/>
+            <a:ext cx="252360" cy="252360"/>
           </a:xfrm>
           <a:prstGeom prst="rect">
             <a:avLst/>
@@ -33343,7 +33343,7 @@
         <p:spPr>
           <a:xfrm>
             <a:off x="1152000" y="3962520"/>
-            <a:ext cx="4607280" cy="528840"/>
+            <a:ext cx="4606920" cy="528480"/>
           </a:xfrm>
           <a:prstGeom prst="rect">
             <a:avLst/>
@@ -33404,7 +33404,7 @@
         <p:spPr>
           <a:xfrm>
             <a:off x="800280" y="4851360"/>
-            <a:ext cx="252720" cy="252720"/>
+            <a:ext cx="252360" cy="252360"/>
           </a:xfrm>
           <a:prstGeom prst="rect">
             <a:avLst/>
@@ -33423,7 +33423,7 @@
         <p:spPr>
           <a:xfrm>
             <a:off x="1152000" y="4800600"/>
-            <a:ext cx="4607280" cy="528840"/>
+            <a:ext cx="4606920" cy="528480"/>
           </a:xfrm>
           <a:prstGeom prst="rect">
             <a:avLst/>
@@ -33484,7 +33484,7 @@
         <p:spPr>
           <a:xfrm>
             <a:off x="800280" y="5689440"/>
-            <a:ext cx="252720" cy="252720"/>
+            <a:ext cx="252360" cy="252360"/>
           </a:xfrm>
           <a:prstGeom prst="rect">
             <a:avLst/>
@@ -33503,7 +33503,7 @@
         <p:spPr>
           <a:xfrm>
             <a:off x="1152000" y="5638680"/>
-            <a:ext cx="4607280" cy="528840"/>
+            <a:ext cx="4606920" cy="528480"/>
           </a:xfrm>
           <a:prstGeom prst="rect">
             <a:avLst/>
@@ -33560,7 +33560,7 @@
         <p:spPr>
           <a:xfrm>
             <a:off x="6217920" y="594360"/>
-            <a:ext cx="5146560" cy="4544280"/>
+            <a:ext cx="5146200" cy="4543920"/>
           </a:xfrm>
           <a:prstGeom prst="roundRect">
             <a:avLst>
@@ -33615,7 +33615,7 @@
         <p:spPr>
           <a:xfrm>
             <a:off x="6537960" y="822960"/>
-            <a:ext cx="4506480" cy="364320"/>
+            <a:ext cx="4506120" cy="363960"/>
           </a:xfrm>
           <a:prstGeom prst="rect">
             <a:avLst/>
@@ -33672,7 +33672,7 @@
         <p:spPr>
           <a:xfrm>
             <a:off x="6537960" y="3879720"/>
-            <a:ext cx="4506480" cy="958680"/>
+            <a:ext cx="4506120" cy="958320"/>
           </a:xfrm>
           <a:prstGeom prst="rect">
             <a:avLst/>
@@ -33729,7 +33729,7 @@
         <p:spPr>
           <a:xfrm>
             <a:off x="11368800" y="6400800"/>
-            <a:ext cx="547200" cy="272880"/>
+            <a:ext cx="546840" cy="272520"/>
           </a:xfrm>
           <a:prstGeom prst="rect">
             <a:avLst/>
@@ -33786,7 +33786,7 @@
         <p:spPr>
           <a:xfrm>
             <a:off x="8791920" y="1508760"/>
-            <a:ext cx="1440" cy="3110400"/>
+            <a:ext cx="1800" cy="3110760"/>
           </a:xfrm>
           <a:prstGeom prst="straightConnector1">
             <a:avLst/>
@@ -33807,7 +33807,7 @@
         <p:spPr>
           <a:xfrm>
             <a:off x="7550640" y="1430280"/>
-            <a:ext cx="227160" cy="227160"/>
+            <a:ext cx="226800" cy="226800"/>
           </a:xfrm>
           <a:prstGeom prst="triangle">
             <a:avLst>
@@ -33861,7 +33861,7 @@
         <p:spPr>
           <a:xfrm>
             <a:off x="6537960" y="1840320"/>
-            <a:ext cx="2252520" cy="761760"/>
+            <a:ext cx="2252160" cy="761760"/>
           </a:xfrm>
           <a:prstGeom prst="rect">
             <a:avLst/>
@@ -33914,7 +33914,7 @@
         <p:spPr>
           <a:xfrm>
             <a:off x="6537960" y="2780280"/>
-            <a:ext cx="2252520" cy="213120"/>
+            <a:ext cx="2252160" cy="213120"/>
           </a:xfrm>
           <a:prstGeom prst="rect">
             <a:avLst/>
@@ -33967,7 +33967,7 @@
         <p:spPr>
           <a:xfrm>
             <a:off x="6537960" y="3230280"/>
-            <a:ext cx="2252520" cy="167400"/>
+            <a:ext cx="2252160" cy="167400"/>
           </a:xfrm>
           <a:prstGeom prst="rect">
             <a:avLst/>
@@ -34020,7 +34020,7 @@
         <p:spPr>
           <a:xfrm>
             <a:off x="9768960" y="1508760"/>
-            <a:ext cx="298440" cy="73440"/>
+            <a:ext cx="298080" cy="73080"/>
           </a:xfrm>
           <a:prstGeom prst="roundRect">
             <a:avLst>
@@ -34074,7 +34074,7 @@
         <p:spPr>
           <a:xfrm>
             <a:off x="8791920" y="1840320"/>
-            <a:ext cx="2252520" cy="761760"/>
+            <a:ext cx="2252160" cy="761760"/>
           </a:xfrm>
           <a:prstGeom prst="rect">
             <a:avLst/>
@@ -34127,7 +34127,7 @@
         <p:spPr>
           <a:xfrm>
             <a:off x="8791920" y="2780280"/>
-            <a:ext cx="2252520" cy="213120"/>
+            <a:ext cx="2252160" cy="213120"/>
           </a:xfrm>
           <a:prstGeom prst="rect">
             <a:avLst/>
@@ -34180,7 +34180,7 @@
         <p:spPr>
           <a:xfrm>
             <a:off x="8791920" y="3230280"/>
-            <a:ext cx="2252520" cy="167400"/>
+            <a:ext cx="2252160" cy="167400"/>
           </a:xfrm>
           <a:prstGeom prst="rect">
             <a:avLst/>
@@ -34233,7 +34233,7 @@
         <p:spPr>
           <a:xfrm>
             <a:off x="822960" y="6180120"/>
-            <a:ext cx="4936320" cy="152280"/>
+            <a:ext cx="4935960" cy="152280"/>
           </a:xfrm>
           <a:prstGeom prst="rect">
             <a:avLst/>
@@ -34299,7 +34299,7 @@
         <p:spPr>
           <a:xfrm>
             <a:off x="901800" y="673200"/>
-            <a:ext cx="354600" cy="354600"/>
+            <a:ext cx="354240" cy="354240"/>
           </a:xfrm>
           <a:prstGeom prst="rect">
             <a:avLst/>
@@ -34328,7 +34328,7 @@
         <p:spPr>
           <a:xfrm>
             <a:off x="1028880" y="3219480"/>
-            <a:ext cx="278280" cy="278280"/>
+            <a:ext cx="277920" cy="277920"/>
           </a:xfrm>
           <a:prstGeom prst="rect">
             <a:avLst/>
@@ -35007,7 +35007,7 @@
         <p:spPr>
           <a:xfrm>
             <a:off x="6302520" y="468720"/>
-            <a:ext cx="753120" cy="753120"/>
+            <a:ext cx="752760" cy="752760"/>
           </a:xfrm>
           <a:prstGeom prst="ellipse">
             <a:avLst/>
@@ -35055,7 +35055,7 @@
         <p:spPr>
           <a:xfrm>
             <a:off x="6428160" y="594360"/>
-            <a:ext cx="501480" cy="501480"/>
+            <a:ext cx="501120" cy="501120"/>
           </a:xfrm>
           <a:prstGeom prst="ellipse">
             <a:avLst/>
@@ -35101,7 +35101,7 @@
         <p:spPr>
           <a:xfrm>
             <a:off x="7086600" y="713160"/>
-            <a:ext cx="4277880" cy="272880"/>
+            <a:ext cx="4277520" cy="272520"/>
           </a:xfrm>
           <a:prstGeom prst="rect">
             <a:avLst/>
@@ -35131,7 +35131,7 @@
               </a:tabLst>
             </a:pPr>
             <a:r>
-              <a:rPr b="1" lang="en-US" sz="1350" spc="194" strike="noStrike">
+              <a:rPr b="1" lang="en-US" sz="1350" spc="191" strike="noStrike">
                 <a:solidFill>
                   <a:srgbClr val="1f7a4d"/>
                 </a:solidFill>
@@ -35158,7 +35158,7 @@
         <p:spPr>
           <a:xfrm>
             <a:off x="6428160" y="1188720"/>
-            <a:ext cx="4936320" cy="775800"/>
+            <a:ext cx="4935960" cy="775440"/>
           </a:xfrm>
           <a:prstGeom prst="rect">
             <a:avLst/>
@@ -35215,7 +35215,7 @@
         <p:spPr>
           <a:xfrm>
             <a:off x="6428160" y="2057400"/>
-            <a:ext cx="4936320" cy="894600"/>
+            <a:ext cx="4935960" cy="894240"/>
           </a:xfrm>
           <a:prstGeom prst="roundRect">
             <a:avLst>
@@ -35263,7 +35263,7 @@
         <p:spPr>
           <a:xfrm>
             <a:off x="6629400" y="2148840"/>
-            <a:ext cx="4533840" cy="227160"/>
+            <a:ext cx="4533480" cy="226800"/>
           </a:xfrm>
           <a:prstGeom prst="rect">
             <a:avLst/>
@@ -35293,7 +35293,7 @@
               </a:tabLst>
             </a:pPr>
             <a:r>
-              <a:rPr b="1" lang="en-US" sz="1200" spc="92" strike="noStrike">
+              <a:rPr b="1" lang="en-US" sz="1200" spc="89" strike="noStrike">
                 <a:solidFill>
                   <a:srgbClr val="e8a33d"/>
                 </a:solidFill>
@@ -35320,7 +35320,7 @@
         <p:spPr>
           <a:xfrm>
             <a:off x="6629400" y="2377440"/>
-            <a:ext cx="4533840" cy="528840"/>
+            <a:ext cx="4533480" cy="528480"/>
           </a:xfrm>
           <a:prstGeom prst="rect">
             <a:avLst/>
@@ -35377,7 +35377,7 @@
         <p:spPr>
           <a:xfrm>
             <a:off x="6428160" y="3154680"/>
-            <a:ext cx="4936320" cy="419040"/>
+            <a:ext cx="4935960" cy="418680"/>
           </a:xfrm>
           <a:prstGeom prst="roundRect">
             <a:avLst>
@@ -35425,7 +35425,7 @@
         <p:spPr>
           <a:xfrm>
             <a:off x="6972480" y="3154680"/>
-            <a:ext cx="4266000" cy="419040"/>
+            <a:ext cx="4265640" cy="418680"/>
           </a:xfrm>
           <a:prstGeom prst="rect">
             <a:avLst/>
@@ -35486,7 +35486,7 @@
         <p:spPr>
           <a:xfrm>
             <a:off x="6400800" y="4013280"/>
-            <a:ext cx="252720" cy="252720"/>
+            <a:ext cx="252360" cy="252360"/>
           </a:xfrm>
           <a:prstGeom prst="rect">
             <a:avLst/>
@@ -35505,7 +35505,7 @@
         <p:spPr>
           <a:xfrm>
             <a:off x="6757560" y="3962520"/>
-            <a:ext cx="4607280" cy="528840"/>
+            <a:ext cx="4606920" cy="528480"/>
           </a:xfrm>
           <a:prstGeom prst="rect">
             <a:avLst/>
@@ -35566,7 +35566,7 @@
         <p:spPr>
           <a:xfrm>
             <a:off x="6400800" y="4851360"/>
-            <a:ext cx="252720" cy="252720"/>
+            <a:ext cx="252360" cy="252360"/>
           </a:xfrm>
           <a:prstGeom prst="rect">
             <a:avLst/>
@@ -35585,7 +35585,7 @@
         <p:spPr>
           <a:xfrm>
             <a:off x="6757560" y="4800600"/>
-            <a:ext cx="4607280" cy="528840"/>
+            <a:ext cx="4606920" cy="528480"/>
           </a:xfrm>
           <a:prstGeom prst="rect">
             <a:avLst/>
@@ -35646,7 +35646,7 @@
         <p:spPr>
           <a:xfrm>
             <a:off x="6400800" y="5689440"/>
-            <a:ext cx="252720" cy="252720"/>
+            <a:ext cx="252360" cy="252360"/>
           </a:xfrm>
           <a:prstGeom prst="rect">
             <a:avLst/>
@@ -35665,7 +35665,7 @@
         <p:spPr>
           <a:xfrm>
             <a:off x="6757560" y="5638680"/>
-            <a:ext cx="4607280" cy="528840"/>
+            <a:ext cx="4606920" cy="528480"/>
           </a:xfrm>
           <a:prstGeom prst="rect">
             <a:avLst/>
@@ -35722,7 +35722,7 @@
         <p:spPr>
           <a:xfrm>
             <a:off x="822960" y="594360"/>
-            <a:ext cx="5146560" cy="5622120"/>
+            <a:ext cx="5146200" cy="5621760"/>
           </a:xfrm>
           <a:prstGeom prst="roundRect">
             <a:avLst>
@@ -35777,7 +35777,7 @@
         <p:spPr>
           <a:xfrm>
             <a:off x="1143000" y="822960"/>
-            <a:ext cx="4506480" cy="364320"/>
+            <a:ext cx="4506120" cy="363960"/>
           </a:xfrm>
           <a:prstGeom prst="rect">
             <a:avLst/>
@@ -35834,7 +35834,7 @@
         <p:spPr>
           <a:xfrm>
             <a:off x="1143000" y="5029200"/>
-            <a:ext cx="4506480" cy="958680"/>
+            <a:ext cx="4506120" cy="958320"/>
           </a:xfrm>
           <a:prstGeom prst="rect">
             <a:avLst/>
@@ -35891,7 +35891,7 @@
         <p:spPr>
           <a:xfrm>
             <a:off x="11368800" y="6400800"/>
-            <a:ext cx="547200" cy="272880"/>
+            <a:ext cx="546840" cy="272520"/>
           </a:xfrm>
           <a:prstGeom prst="rect">
             <a:avLst/>
@@ -35948,7 +35948,7 @@
         <p:spPr>
           <a:xfrm>
             <a:off x="6757560" y="6099840"/>
-            <a:ext cx="4607280" cy="304920"/>
+            <a:ext cx="4606920" cy="304920"/>
           </a:xfrm>
           <a:prstGeom prst="rect">
             <a:avLst/>
@@ -36009,7 +36009,7 @@
         </p:nvGraphicFramePr>
         <p:xfrm>
           <a:off x="1143000" y="1280160"/>
-          <a:ext cx="4506480" cy="3564720"/>
+          <a:ext cx="4506120" cy="3564360"/>
         </p:xfrm>
         <a:graphic>
           <a:graphicData uri="http://schemas.openxmlformats.org/drawingml/2006/chart">
@@ -36030,7 +36030,7 @@
         <p:spPr>
           <a:xfrm>
             <a:off x="6502320" y="660240"/>
-            <a:ext cx="354600" cy="354600"/>
+            <a:ext cx="354240" cy="354240"/>
           </a:xfrm>
           <a:prstGeom prst="rect">
             <a:avLst/>
@@ -36059,7 +36059,7 @@
         <p:spPr>
           <a:xfrm>
             <a:off x="6629400" y="3219480"/>
-            <a:ext cx="278280" cy="278280"/>
+            <a:ext cx="277920" cy="277920"/>
           </a:xfrm>
           <a:prstGeom prst="rect">
             <a:avLst/>
@@ -36738,7 +36738,7 @@
         <p:spPr>
           <a:xfrm>
             <a:off x="697320" y="468720"/>
-            <a:ext cx="753120" cy="753120"/>
+            <a:ext cx="752760" cy="752760"/>
           </a:xfrm>
           <a:prstGeom prst="ellipse">
             <a:avLst/>
@@ -36786,7 +36786,7 @@
         <p:spPr>
           <a:xfrm>
             <a:off x="822960" y="594360"/>
-            <a:ext cx="501480" cy="501480"/>
+            <a:ext cx="501120" cy="501120"/>
           </a:xfrm>
           <a:prstGeom prst="ellipse">
             <a:avLst/>
@@ -36832,7 +36832,7 @@
         <p:spPr>
           <a:xfrm>
             <a:off x="1481400" y="713160"/>
-            <a:ext cx="4277880" cy="272880"/>
+            <a:ext cx="4277520" cy="272520"/>
           </a:xfrm>
           <a:prstGeom prst="rect">
             <a:avLst/>
@@ -36862,7 +36862,7 @@
               </a:tabLst>
             </a:pPr>
             <a:r>
-              <a:rPr b="1" lang="en-US" sz="1400" spc="194" strike="noStrike">
+              <a:rPr b="1" lang="en-US" sz="1400" spc="191" strike="noStrike">
                 <a:solidFill>
                   <a:srgbClr val="c0392b"/>
                 </a:solidFill>
@@ -36889,7 +36889,7 @@
         <p:spPr>
           <a:xfrm>
             <a:off x="822960" y="1188720"/>
-            <a:ext cx="4936320" cy="775800"/>
+            <a:ext cx="4935960" cy="775440"/>
           </a:xfrm>
           <a:prstGeom prst="rect">
             <a:avLst/>
@@ -36946,7 +36946,7 @@
         <p:spPr>
           <a:xfrm>
             <a:off x="822960" y="2057400"/>
-            <a:ext cx="4936320" cy="894600"/>
+            <a:ext cx="4935960" cy="894240"/>
           </a:xfrm>
           <a:prstGeom prst="roundRect">
             <a:avLst>
@@ -36994,7 +36994,7 @@
         <p:spPr>
           <a:xfrm>
             <a:off x="1024200" y="2148840"/>
-            <a:ext cx="4533840" cy="227160"/>
+            <a:ext cx="4533480" cy="226800"/>
           </a:xfrm>
           <a:prstGeom prst="rect">
             <a:avLst/>
@@ -37024,7 +37024,7 @@
               </a:tabLst>
             </a:pPr>
             <a:r>
-              <a:rPr b="1" lang="en-US" sz="1200" spc="92" strike="noStrike">
+              <a:rPr b="1" lang="en-US" sz="1200" spc="89" strike="noStrike">
                 <a:solidFill>
                   <a:srgbClr val="e8a33d"/>
                 </a:solidFill>
@@ -37051,7 +37051,7 @@
         <p:spPr>
           <a:xfrm>
             <a:off x="1024200" y="2377440"/>
-            <a:ext cx="4533840" cy="528840"/>
+            <a:ext cx="4533480" cy="528480"/>
           </a:xfrm>
           <a:prstGeom prst="rect">
             <a:avLst/>
@@ -37108,7 +37108,7 @@
         <p:spPr>
           <a:xfrm>
             <a:off x="822960" y="3154680"/>
-            <a:ext cx="4936320" cy="419040"/>
+            <a:ext cx="4935960" cy="418680"/>
           </a:xfrm>
           <a:prstGeom prst="roundRect">
             <a:avLst>
@@ -37160,7 +37160,7 @@
         <p:spPr>
           <a:xfrm>
             <a:off x="939960" y="3225960"/>
-            <a:ext cx="252720" cy="252720"/>
+            <a:ext cx="252360" cy="252360"/>
           </a:xfrm>
           <a:prstGeom prst="rect">
             <a:avLst/>
@@ -37179,7 +37179,7 @@
         <p:spPr>
           <a:xfrm>
             <a:off x="1280160" y="3154680"/>
-            <a:ext cx="4387680" cy="419040"/>
+            <a:ext cx="4387320" cy="418680"/>
           </a:xfrm>
           <a:prstGeom prst="rect">
             <a:avLst/>
@@ -37240,7 +37240,7 @@
         <p:spPr>
           <a:xfrm>
             <a:off x="800280" y="4025880"/>
-            <a:ext cx="252720" cy="252720"/>
+            <a:ext cx="252360" cy="252360"/>
           </a:xfrm>
           <a:prstGeom prst="rect">
             <a:avLst/>
@@ -37259,7 +37259,7 @@
         <p:spPr>
           <a:xfrm>
             <a:off x="1152000" y="3962520"/>
-            <a:ext cx="4607280" cy="528840"/>
+            <a:ext cx="4606920" cy="528480"/>
           </a:xfrm>
           <a:prstGeom prst="rect">
             <a:avLst/>
@@ -37320,7 +37320,7 @@
         <p:spPr>
           <a:xfrm>
             <a:off x="800280" y="4863960"/>
-            <a:ext cx="252720" cy="252720"/>
+            <a:ext cx="252360" cy="252360"/>
           </a:xfrm>
           <a:prstGeom prst="rect">
             <a:avLst/>
@@ -37339,7 +37339,7 @@
         <p:spPr>
           <a:xfrm>
             <a:off x="1152000" y="4800600"/>
-            <a:ext cx="4607280" cy="528840"/>
+            <a:ext cx="4606920" cy="528480"/>
           </a:xfrm>
           <a:prstGeom prst="rect">
             <a:avLst/>
@@ -37400,7 +37400,7 @@
         <p:spPr>
           <a:xfrm>
             <a:off x="800280" y="5702400"/>
-            <a:ext cx="252720" cy="252720"/>
+            <a:ext cx="252360" cy="252360"/>
           </a:xfrm>
           <a:prstGeom prst="rect">
             <a:avLst/>
@@ -37419,7 +37419,7 @@
         <p:spPr>
           <a:xfrm>
             <a:off x="1152000" y="5638680"/>
-            <a:ext cx="4607280" cy="528840"/>
+            <a:ext cx="4606920" cy="528480"/>
           </a:xfrm>
           <a:prstGeom prst="rect">
             <a:avLst/>
@@ -37476,7 +37476,7 @@
         <p:spPr>
           <a:xfrm>
             <a:off x="6217920" y="594360"/>
-            <a:ext cx="5146560" cy="5622120"/>
+            <a:ext cx="5146200" cy="5621760"/>
           </a:xfrm>
           <a:prstGeom prst="roundRect">
             <a:avLst>
@@ -37531,7 +37531,7 @@
         <p:spPr>
           <a:xfrm>
             <a:off x="6537960" y="822960"/>
-            <a:ext cx="4506480" cy="364320"/>
+            <a:ext cx="4506120" cy="363960"/>
           </a:xfrm>
           <a:prstGeom prst="rect">
             <a:avLst/>
@@ -37588,7 +37588,7 @@
         <p:spPr>
           <a:xfrm>
             <a:off x="6537960" y="5029200"/>
-            <a:ext cx="4506480" cy="958680"/>
+            <a:ext cx="4506120" cy="958320"/>
           </a:xfrm>
           <a:prstGeom prst="rect">
             <a:avLst/>
@@ -37645,7 +37645,7 @@
         <p:spPr>
           <a:xfrm>
             <a:off x="11368800" y="6400800"/>
-            <a:ext cx="547200" cy="272880"/>
+            <a:ext cx="546840" cy="272520"/>
           </a:xfrm>
           <a:prstGeom prst="rect">
             <a:avLst/>
@@ -37702,7 +37702,7 @@
         <p:spPr>
           <a:xfrm>
             <a:off x="822960" y="6099840"/>
-            <a:ext cx="5398920" cy="335160"/>
+            <a:ext cx="5398560" cy="335160"/>
           </a:xfrm>
           <a:prstGeom prst="rect">
             <a:avLst/>
@@ -37763,7 +37763,7 @@
         </p:nvGraphicFramePr>
         <p:xfrm>
           <a:off x="6537960" y="1280160"/>
-          <a:ext cx="4506480" cy="3564720"/>
+          <a:ext cx="4506120" cy="3564360"/>
         </p:xfrm>
         <a:graphic>
           <a:graphicData uri="http://schemas.openxmlformats.org/drawingml/2006/chart">
@@ -37784,7 +37784,7 @@
         <p:spPr>
           <a:xfrm>
             <a:off x="914400" y="685800"/>
-            <a:ext cx="303840" cy="303840"/>
+            <a:ext cx="303480" cy="303480"/>
           </a:xfrm>
           <a:prstGeom prst="rect">
             <a:avLst/>

</xml_diff>